<commit_message>
:bug: fix(presentation): refresh editable deck chart
</commit_message>
<xml_diff>
--- a/results/tcc/presentation/ensino_personalizado_de_matematica_tcc.pptx
+++ b/results/tcc/presentation/ensino_personalizado_de_matematica_tcc.pptx
@@ -6715,8 +6715,8 @@
         </p:blipFill>
         <p:spPr>
           <a:xfrm>
-            <a:off x="548640" y="1293434"/>
-            <a:ext cx="5486400" cy="2168012"/>
+            <a:off x="548640" y="1275734"/>
+            <a:ext cx="5486400" cy="2203412"/>
           </a:xfrm>
           <a:prstGeom prst="rect">
             <a:avLst/>
@@ -6906,7 +6906,7 @@
                 </a:solidFill>
                 <a:latin typeface="Arial"/>
               </a:rPr>
-              <a:t>O snapshot foi delimitado a 2015–2026, com data de corte em 31 de agosto de 2026.</a:t>
+              <a:t>O snapshot foi delimitado a 2015–2026, com data de corte em 31 de agosto de 2026. Como 2026 é parcial, sua barra não deve ser comparada diretamente com anos completos.</a:t>
             </a:r>
           </a:p>
         </p:txBody>

</xml_diff>

<commit_message>
:art: fix(presentation): standardize slide icons and qualify 2026 chart (#85)
* :art: fix(presentation): standardize slide icons and partial-year chart

* :books: docs(tcc): refresh compiled PDF

* :bug: fix(presentation): refresh editable deck chart
</commit_message>
<xml_diff>
--- a/results/tcc/presentation/ensino_personalizado_de_matematica_tcc.pptx
+++ b/results/tcc/presentation/ensino_personalizado_de_matematica_tcc.pptx
@@ -6715,8 +6715,8 @@
         </p:blipFill>
         <p:spPr>
           <a:xfrm>
-            <a:off x="548640" y="1293434"/>
-            <a:ext cx="5486400" cy="2168012"/>
+            <a:off x="548640" y="1275734"/>
+            <a:ext cx="5486400" cy="2203412"/>
           </a:xfrm>
           <a:prstGeom prst="rect">
             <a:avLst/>
@@ -6906,7 +6906,7 @@
                 </a:solidFill>
                 <a:latin typeface="Arial"/>
               </a:rPr>
-              <a:t>O snapshot foi delimitado a 2015–2026, com data de corte em 31 de agosto de 2026.</a:t>
+              <a:t>O snapshot foi delimitado a 2015–2026, com data de corte em 31 de agosto de 2026. Como 2026 é parcial, sua barra não deve ser comparada diretamente com anos completos.</a:t>
             </a:r>
           </a:p>
         </p:txBody>

</xml_diff>

<commit_message>
:bug: fix(tcc): apply editorial corrections
Align four objectives, explanatory prose, search quadros and review charts.
Preserve operational counts and preliminary MMAT criterion judgments.
Isolate LaTeX builds and verify actual PDF destinations before publication.
Refresh deliverable artifacts while keeping annotations and transcripts private.

Refs #24
</commit_message>
<xml_diff>
--- a/results/tcc/presentation/ensino_personalizado_de_matematica_tcc.pptx
+++ b/results/tcc/presentation/ensino_personalizado_de_matematica_tcc.pptx
@@ -6739,8 +6739,8 @@
         </p:blipFill>
         <p:spPr>
           <a:xfrm>
-            <a:off x="6172200" y="1230414"/>
-            <a:ext cx="5486400" cy="2294051"/>
+            <a:off x="6213560" y="1143000"/>
+            <a:ext cx="5403680" cy="2468880"/>
           </a:xfrm>
           <a:prstGeom prst="rect">
             <a:avLst/>
@@ -13740,7 +13740,7 @@
                 </a:solidFill>
                 <a:latin typeface="Arial"/>
               </a:rPr>
-              <a:t>Como identificar e sintetizar, por meio de revisão sistemática, as principais técnicas computacionais aplicadas ao ensino de matemática e converter essas evidências em uma especificação de protótipo que apoie o professor?</a:t>
+              <a:t>Como estruturar uma especificação técnica e pedagógica para apoiar a interpretação docente de evidências de desempenho em matemática, com base na literatura e nos limites das inferências sobre competências e aprendizagem?</a:t>
             </a:r>
           </a:p>
         </p:txBody>
@@ -13904,7 +13904,7 @@
                 </a:solidFill>
                 <a:latin typeface="Arial"/>
               </a:rPr>
-              <a:t>Mapear e analisar sistematicamente as aplicações e elaborar uma especificação técnica e pedagógica para apoiar a interpretação de evidências sobre competências.</a:t>
+              <a:t>Propor uma especificação técnica e pedagógica para apoiar a interpretação docente de evidências de desempenho em matemática, fundamentada na literatura científica.</a:t>
             </a:r>
           </a:p>
         </p:txBody>
@@ -14120,8 +14120,8 @@
         </p:nvSpPr>
         <p:spPr>
           <a:xfrm>
-            <a:off x="685800" y="1143000"/>
-            <a:ext cx="5166360" cy="868680"/>
+            <a:off x="685800" y="1325880"/>
+            <a:ext cx="5166360" cy="1645920"/>
           </a:xfrm>
           <a:prstGeom prst="rect">
             <a:avLst/>
@@ -14163,8 +14163,8 @@
         </p:nvSpPr>
         <p:spPr>
           <a:xfrm>
-            <a:off x="685800" y="1143000"/>
-            <a:ext cx="59436" cy="868680"/>
+            <a:off x="685800" y="1325880"/>
+            <a:ext cx="59436" cy="1645920"/>
           </a:xfrm>
           <a:prstGeom prst="rect">
             <a:avLst/>
@@ -14206,7 +14206,7 @@
         </p:nvSpPr>
         <p:spPr>
           <a:xfrm>
-            <a:off x="868680" y="1197864"/>
+            <a:off x="868680" y="1380744"/>
             <a:ext cx="4892040" cy="384048"/>
           </a:xfrm>
           <a:prstGeom prst="rect">
@@ -14226,7 +14226,7 @@
               </a:spcAft>
             </a:pPr>
             <a:r>
-              <a:rPr sz="1500" b="1">
+              <a:rPr sz="1900" b="1">
                 <a:solidFill>
                   <a:srgbClr val="0F0F0F"/>
                 </a:solidFill>
@@ -14245,8 +14245,8 @@
         </p:nvSpPr>
         <p:spPr>
           <a:xfrm>
-            <a:off x="868680" y="1600200"/>
-            <a:ext cx="4892040" cy="347473"/>
+            <a:off x="868680" y="1783080"/>
+            <a:ext cx="4892040" cy="1124713"/>
           </a:xfrm>
           <a:prstGeom prst="rect">
             <a:avLst/>
@@ -14265,13 +14265,13 @@
               </a:spcAft>
             </a:pPr>
             <a:r>
-              <a:rPr sz="1350" b="0">
+              <a:rPr sz="1800" b="0">
                 <a:solidFill>
                   <a:srgbClr val="232323"/>
                 </a:solidFill>
                 <a:latin typeface="Arial"/>
               </a:rPr>
-              <a:t>Revisão sistemática, relatada com apoio do PRISMA 2020, sobre estudos de 2015–2026.</a:t>
+              <a:t>Categorizar técnicas computacionais e finalidades pedagógicas na literatura mapeada.</a:t>
             </a:r>
           </a:p>
         </p:txBody>
@@ -14284,8 +14284,8 @@
         </p:nvSpPr>
         <p:spPr>
           <a:xfrm>
-            <a:off x="685800" y="2286000"/>
-            <a:ext cx="5166360" cy="868680"/>
+            <a:off x="685800" y="3337560"/>
+            <a:ext cx="5166360" cy="1645920"/>
           </a:xfrm>
           <a:prstGeom prst="rect">
             <a:avLst/>
@@ -14327,8 +14327,8 @@
         </p:nvSpPr>
         <p:spPr>
           <a:xfrm>
-            <a:off x="685800" y="2286000"/>
-            <a:ext cx="59436" cy="868680"/>
+            <a:off x="685800" y="3337560"/>
+            <a:ext cx="59436" cy="1645920"/>
           </a:xfrm>
           <a:prstGeom prst="rect">
             <a:avLst/>
@@ -14370,7 +14370,7 @@
         </p:nvSpPr>
         <p:spPr>
           <a:xfrm>
-            <a:off x="868680" y="2340864"/>
+            <a:off x="868680" y="3392424"/>
             <a:ext cx="4892040" cy="384048"/>
           </a:xfrm>
           <a:prstGeom prst="rect">
@@ -14390,7 +14390,7 @@
               </a:spcAft>
             </a:pPr>
             <a:r>
-              <a:rPr sz="1500" b="1">
+              <a:rPr sz="1900" b="1">
                 <a:solidFill>
                   <a:srgbClr val="0F0F0F"/>
                 </a:solidFill>
@@ -14409,8 +14409,8 @@
         </p:nvSpPr>
         <p:spPr>
           <a:xfrm>
-            <a:off x="868680" y="2743200"/>
-            <a:ext cx="4892040" cy="347473"/>
+            <a:off x="868680" y="3794760"/>
+            <a:ext cx="4892040" cy="1124713"/>
           </a:xfrm>
           <a:prstGeom prst="rect">
             <a:avLst/>
@@ -14429,13 +14429,13 @@
               </a:spcAft>
             </a:pPr>
             <a:r>
-              <a:rPr sz="1350" b="0">
+              <a:rPr sz="1800" b="0">
                 <a:solidFill>
                   <a:srgbClr val="232323"/>
                 </a:solidFill>
                 <a:latin typeface="Arial"/>
               </a:rPr>
-              <a:t>Identificação e categorização das abordagens computacionais.</a:t>
+              <a:t>Identificar limitações e lacunas técnicas, pedagógicas, metodológicas e éticas.</a:t>
             </a:r>
           </a:p>
         </p:txBody>
@@ -14448,8 +14448,8 @@
         </p:nvSpPr>
         <p:spPr>
           <a:xfrm>
-            <a:off x="685800" y="3429000"/>
-            <a:ext cx="5166360" cy="868680"/>
+            <a:off x="6309360" y="1325880"/>
+            <a:ext cx="5166360" cy="1645920"/>
           </a:xfrm>
           <a:prstGeom prst="rect">
             <a:avLst/>
@@ -14491,14 +14491,14 @@
         </p:nvSpPr>
         <p:spPr>
           <a:xfrm>
-            <a:off x="685800" y="3429000"/>
-            <a:ext cx="59436" cy="868680"/>
-          </a:xfrm>
-          <a:prstGeom prst="rect">
-            <a:avLst/>
-          </a:prstGeom>
-          <a:solidFill>
-            <a:srgbClr val="2563EB"/>
+            <a:off x="6309360" y="1325880"/>
+            <a:ext cx="59436" cy="1645920"/>
+          </a:xfrm>
+          <a:prstGeom prst="rect">
+            <a:avLst/>
+          </a:prstGeom>
+          <a:solidFill>
+            <a:srgbClr val="0D9488"/>
           </a:solidFill>
           <a:ln>
             <a:noFill/>
@@ -14534,7 +14534,7 @@
         </p:nvSpPr>
         <p:spPr>
           <a:xfrm>
-            <a:off x="868680" y="3483864"/>
+            <a:off x="6492240" y="1380744"/>
             <a:ext cx="4892040" cy="384048"/>
           </a:xfrm>
           <a:prstGeom prst="rect">
@@ -14554,7 +14554,7 @@
               </a:spcAft>
             </a:pPr>
             <a:r>
-              <a:rPr sz="1500" b="1">
+              <a:rPr sz="1900" b="1">
                 <a:solidFill>
                   <a:srgbClr val="0F0F0F"/>
                 </a:solidFill>
@@ -14573,8 +14573,8 @@
         </p:nvSpPr>
         <p:spPr>
           <a:xfrm>
-            <a:off x="868680" y="3886200"/>
-            <a:ext cx="4892040" cy="347473"/>
+            <a:off x="6492240" y="1783080"/>
+            <a:ext cx="4892040" cy="1124713"/>
           </a:xfrm>
           <a:prstGeom prst="rect">
             <a:avLst/>
@@ -14593,13 +14593,13 @@
               </a:spcAft>
             </a:pPr>
             <a:r>
-              <a:rPr sz="1350" b="0">
+              <a:rPr sz="1800" b="0">
                 <a:solidFill>
                   <a:srgbClr val="232323"/>
                 </a:solidFill>
                 <a:latin typeface="Arial"/>
               </a:rPr>
-              <a:t>Classificação das finalidades pedagógicas das aplicações.</a:t>
+              <a:t>Formular requisitos, critérios de dados e modelos e arquitetura de referência para o protótipo.</a:t>
             </a:r>
           </a:p>
         </p:txBody>
@@ -14612,8 +14612,8 @@
         </p:nvSpPr>
         <p:spPr>
           <a:xfrm>
-            <a:off x="685800" y="4572000"/>
-            <a:ext cx="5166360" cy="868680"/>
+            <a:off x="6309360" y="3337560"/>
+            <a:ext cx="5166360" cy="1645920"/>
           </a:xfrm>
           <a:prstGeom prst="rect">
             <a:avLst/>
@@ -14655,14 +14655,14 @@
         </p:nvSpPr>
         <p:spPr>
           <a:xfrm>
-            <a:off x="685800" y="4572000"/>
-            <a:ext cx="59436" cy="868680"/>
-          </a:xfrm>
-          <a:prstGeom prst="rect">
-            <a:avLst/>
-          </a:prstGeom>
-          <a:solidFill>
-            <a:srgbClr val="2563EB"/>
+            <a:off x="6309360" y="3337560"/>
+            <a:ext cx="59436" cy="1645920"/>
+          </a:xfrm>
+          <a:prstGeom prst="rect">
+            <a:avLst/>
+          </a:prstGeom>
+          <a:solidFill>
+            <a:srgbClr val="0D9488"/>
           </a:solidFill>
           <a:ln>
             <a:noFill/>
@@ -14698,7 +14698,7 @@
         </p:nvSpPr>
         <p:spPr>
           <a:xfrm>
-            <a:off x="868680" y="4626864"/>
+            <a:off x="6492240" y="3392424"/>
             <a:ext cx="4892040" cy="384048"/>
           </a:xfrm>
           <a:prstGeom prst="rect">
@@ -14718,7 +14718,7 @@
               </a:spcAft>
             </a:pPr>
             <a:r>
-              <a:rPr sz="1500" b="1">
+              <a:rPr sz="1900" b="1">
                 <a:solidFill>
                   <a:srgbClr val="0F0F0F"/>
                 </a:solidFill>
@@ -14737,8 +14737,8 @@
         </p:nvSpPr>
         <p:spPr>
           <a:xfrm>
-            <a:off x="868680" y="5029200"/>
-            <a:ext cx="4892040" cy="347473"/>
+            <a:off x="6492240" y="3794760"/>
+            <a:ext cx="4892040" cy="1124713"/>
           </a:xfrm>
           <a:prstGeom prst="rect">
             <a:avLst/>
@@ -14757,113 +14757,27 @@
               </a:spcAft>
             </a:pPr>
             <a:r>
-              <a:rPr sz="1350" b="0">
+              <a:rPr sz="1800" b="0">
                 <a:solidFill>
                   <a:srgbClr val="232323"/>
                 </a:solidFill>
                 <a:latin typeface="Arial"/>
               </a:rPr>
-              <a:t>Análise crítica das metodologias e limitações dos estudos.</a:t>
-            </a:r>
-          </a:p>
-        </p:txBody>
-      </p:sp>
-      <p:sp>
-        <p:nvSpPr>
-          <p:cNvPr id="19" name="Rectangle 18"/>
-          <p:cNvSpPr/>
-          <p:nvPr/>
-        </p:nvSpPr>
-        <p:spPr>
-          <a:xfrm>
-            <a:off x="6309360" y="1143000"/>
-            <a:ext cx="5166360" cy="1143000"/>
-          </a:xfrm>
-          <a:prstGeom prst="rect">
-            <a:avLst/>
-          </a:prstGeom>
-          <a:solidFill>
-            <a:srgbClr val="FFFFFF"/>
-          </a:solidFill>
-          <a:ln>
-            <a:noFill/>
-          </a:ln>
-        </p:spPr>
-        <p:style>
-          <a:lnRef idx="1">
-            <a:schemeClr val="accent1"/>
-          </a:lnRef>
-          <a:fillRef idx="3">
-            <a:schemeClr val="accent1"/>
-          </a:fillRef>
-          <a:effectRef idx="2">
-            <a:schemeClr val="accent1"/>
-          </a:effectRef>
-          <a:fontRef idx="minor">
-            <a:schemeClr val="lt1"/>
-          </a:fontRef>
-        </p:style>
-        <p:txBody>
-          <a:bodyPr rtlCol="0" anchor="ctr"/>
-          <a:lstStyle/>
-          <a:p>
-            <a:pPr algn="ctr"/>
-          </a:p>
-        </p:txBody>
-      </p:sp>
-      <p:sp>
-        <p:nvSpPr>
-          <p:cNvPr id="20" name="Rectangle 19"/>
-          <p:cNvSpPr/>
-          <p:nvPr/>
-        </p:nvSpPr>
-        <p:spPr>
-          <a:xfrm>
-            <a:off x="6309360" y="1143000"/>
-            <a:ext cx="59436" cy="1143000"/>
-          </a:xfrm>
-          <a:prstGeom prst="rect">
-            <a:avLst/>
-          </a:prstGeom>
-          <a:solidFill>
-            <a:srgbClr val="0D9488"/>
-          </a:solidFill>
-          <a:ln>
-            <a:noFill/>
-          </a:ln>
-        </p:spPr>
-        <p:style>
-          <a:lnRef idx="1">
-            <a:schemeClr val="accent1"/>
-          </a:lnRef>
-          <a:fillRef idx="3">
-            <a:schemeClr val="accent1"/>
-          </a:fillRef>
-          <a:effectRef idx="2">
-            <a:schemeClr val="accent1"/>
-          </a:effectRef>
-          <a:fontRef idx="minor">
-            <a:schemeClr val="lt1"/>
-          </a:fontRef>
-        </p:style>
-        <p:txBody>
-          <a:bodyPr rtlCol="0" anchor="ctr"/>
-          <a:lstStyle/>
-          <a:p>
-            <a:pPr algn="ctr"/>
-          </a:p>
-        </p:txBody>
-      </p:sp>
-      <p:sp>
-        <p:nvSpPr>
-          <p:cNvPr id="21" name="TextBox 20"/>
+              <a:t>Propor um protocolo para avaliação futura dos aspectos técnicos e de adequação pedagógica.</a:t>
+            </a:r>
+          </a:p>
+        </p:txBody>
+      </p:sp>
+      <p:sp>
+        <p:nvSpPr>
+          <p:cNvPr id="19" name="TextBox 18"/>
           <p:cNvSpPr txBox="1"/>
           <p:nvPr/>
         </p:nvSpPr>
         <p:spPr>
           <a:xfrm>
-            <a:off x="6492240" y="1197864"/>
-            <a:ext cx="4892040" cy="384048"/>
+            <a:off x="914400" y="5669280"/>
+            <a:ext cx="10287000" cy="594360"/>
           </a:xfrm>
           <a:prstGeom prst="rect">
             <a:avLst/>
@@ -14876,425 +14790,19 @@
           </a:bodyPr>
           <a:lstStyle/>
           <a:p>
-            <a:pPr algn="l">
+            <a:pPr algn="ctr">
               <a:spcAft>
                 <a:spcPts val="0"/>
               </a:spcAft>
             </a:pPr>
             <a:r>
-              <a:rPr sz="1500" b="1">
-                <a:solidFill>
-                  <a:srgbClr val="0F0F0F"/>
+              <a:rPr sz="1400" b="0">
+                <a:solidFill>
+                  <a:srgbClr val="64748B"/>
                 </a:solidFill>
                 <a:latin typeface="Arial"/>
               </a:rPr>
-              <a:t>OE5</a:t>
-            </a:r>
-          </a:p>
-        </p:txBody>
-      </p:sp>
-      <p:sp>
-        <p:nvSpPr>
-          <p:cNvPr id="22" name="TextBox 21"/>
-          <p:cNvSpPr txBox="1"/>
-          <p:nvPr/>
-        </p:nvSpPr>
-        <p:spPr>
-          <a:xfrm>
-            <a:off x="6492240" y="1600200"/>
-            <a:ext cx="4892040" cy="621793"/>
-          </a:xfrm>
-          <a:prstGeom prst="rect">
-            <a:avLst/>
-          </a:prstGeom>
-          <a:noFill/>
-        </p:spPr>
-        <p:txBody>
-          <a:bodyPr wrap="square" lIns="54864" rIns="54864" tIns="54864" bIns="54864" anchor="t">
-            <a:spAutoFit/>
-          </a:bodyPr>
-          <a:lstStyle/>
-          <a:p>
-            <a:pPr algn="l">
-              <a:spcAft>
-                <a:spcPts val="0"/>
-              </a:spcAft>
-            </a:pPr>
-            <a:r>
-              <a:rPr sz="1350" b="0">
-                <a:solidFill>
-                  <a:srgbClr val="232323"/>
-                </a:solidFill>
-                <a:latin typeface="Arial"/>
-              </a:rPr>
-              <a:t>Mapeamento de lacunas técnicas, pedagógicas, metodológicas e éticas.</a:t>
-            </a:r>
-          </a:p>
-        </p:txBody>
-      </p:sp>
-      <p:sp>
-        <p:nvSpPr>
-          <p:cNvPr id="23" name="Rectangle 22"/>
-          <p:cNvSpPr/>
-          <p:nvPr/>
-        </p:nvSpPr>
-        <p:spPr>
-          <a:xfrm>
-            <a:off x="6309360" y="2560320"/>
-            <a:ext cx="5166360" cy="1143000"/>
-          </a:xfrm>
-          <a:prstGeom prst="rect">
-            <a:avLst/>
-          </a:prstGeom>
-          <a:solidFill>
-            <a:srgbClr val="FFFFFF"/>
-          </a:solidFill>
-          <a:ln>
-            <a:noFill/>
-          </a:ln>
-        </p:spPr>
-        <p:style>
-          <a:lnRef idx="1">
-            <a:schemeClr val="accent1"/>
-          </a:lnRef>
-          <a:fillRef idx="3">
-            <a:schemeClr val="accent1"/>
-          </a:fillRef>
-          <a:effectRef idx="2">
-            <a:schemeClr val="accent1"/>
-          </a:effectRef>
-          <a:fontRef idx="minor">
-            <a:schemeClr val="lt1"/>
-          </a:fontRef>
-        </p:style>
-        <p:txBody>
-          <a:bodyPr rtlCol="0" anchor="ctr"/>
-          <a:lstStyle/>
-          <a:p>
-            <a:pPr algn="ctr"/>
-          </a:p>
-        </p:txBody>
-      </p:sp>
-      <p:sp>
-        <p:nvSpPr>
-          <p:cNvPr id="24" name="Rectangle 23"/>
-          <p:cNvSpPr/>
-          <p:nvPr/>
-        </p:nvSpPr>
-        <p:spPr>
-          <a:xfrm>
-            <a:off x="6309360" y="2560320"/>
-            <a:ext cx="59436" cy="1143000"/>
-          </a:xfrm>
-          <a:prstGeom prst="rect">
-            <a:avLst/>
-          </a:prstGeom>
-          <a:solidFill>
-            <a:srgbClr val="0D9488"/>
-          </a:solidFill>
-          <a:ln>
-            <a:noFill/>
-          </a:ln>
-        </p:spPr>
-        <p:style>
-          <a:lnRef idx="1">
-            <a:schemeClr val="accent1"/>
-          </a:lnRef>
-          <a:fillRef idx="3">
-            <a:schemeClr val="accent1"/>
-          </a:fillRef>
-          <a:effectRef idx="2">
-            <a:schemeClr val="accent1"/>
-          </a:effectRef>
-          <a:fontRef idx="minor">
-            <a:schemeClr val="lt1"/>
-          </a:fontRef>
-        </p:style>
-        <p:txBody>
-          <a:bodyPr rtlCol="0" anchor="ctr"/>
-          <a:lstStyle/>
-          <a:p>
-            <a:pPr algn="ctr"/>
-          </a:p>
-        </p:txBody>
-      </p:sp>
-      <p:sp>
-        <p:nvSpPr>
-          <p:cNvPr id="25" name="TextBox 24"/>
-          <p:cNvSpPr txBox="1"/>
-          <p:nvPr/>
-        </p:nvSpPr>
-        <p:spPr>
-          <a:xfrm>
-            <a:off x="6492240" y="2615184"/>
-            <a:ext cx="4892040" cy="384048"/>
-          </a:xfrm>
-          <a:prstGeom prst="rect">
-            <a:avLst/>
-          </a:prstGeom>
-          <a:noFill/>
-        </p:spPr>
-        <p:txBody>
-          <a:bodyPr wrap="square" lIns="54864" rIns="54864" tIns="54864" bIns="54864" anchor="t">
-            <a:spAutoFit/>
-          </a:bodyPr>
-          <a:lstStyle/>
-          <a:p>
-            <a:pPr algn="l">
-              <a:spcAft>
-                <a:spcPts val="0"/>
-              </a:spcAft>
-            </a:pPr>
-            <a:r>
-              <a:rPr sz="1500" b="1">
-                <a:solidFill>
-                  <a:srgbClr val="0F0F0F"/>
-                </a:solidFill>
-                <a:latin typeface="Arial"/>
-              </a:rPr>
-              <a:t>OE6</a:t>
-            </a:r>
-          </a:p>
-        </p:txBody>
-      </p:sp>
-      <p:sp>
-        <p:nvSpPr>
-          <p:cNvPr id="26" name="TextBox 25"/>
-          <p:cNvSpPr txBox="1"/>
-          <p:nvPr/>
-        </p:nvSpPr>
-        <p:spPr>
-          <a:xfrm>
-            <a:off x="6492240" y="3017520"/>
-            <a:ext cx="4892040" cy="621793"/>
-          </a:xfrm>
-          <a:prstGeom prst="rect">
-            <a:avLst/>
-          </a:prstGeom>
-          <a:noFill/>
-        </p:spPr>
-        <p:txBody>
-          <a:bodyPr wrap="square" lIns="54864" rIns="54864" tIns="54864" bIns="54864" anchor="t">
-            <a:spAutoFit/>
-          </a:bodyPr>
-          <a:lstStyle/>
-          <a:p>
-            <a:pPr algn="l">
-              <a:spcAft>
-                <a:spcPts val="0"/>
-              </a:spcAft>
-            </a:pPr>
-            <a:r>
-              <a:rPr sz="1350" b="0">
-                <a:solidFill>
-                  <a:srgbClr val="232323"/>
-                </a:solidFill>
-                <a:latin typeface="Arial"/>
-              </a:rPr>
-              <a:t>Manutenção de um pipeline automatizado e auditável para coleta, processamento e exportação.</a:t>
-            </a:r>
-          </a:p>
-        </p:txBody>
-      </p:sp>
-      <p:sp>
-        <p:nvSpPr>
-          <p:cNvPr id="27" name="Rectangle 26"/>
-          <p:cNvSpPr/>
-          <p:nvPr/>
-        </p:nvSpPr>
-        <p:spPr>
-          <a:xfrm>
-            <a:off x="6309360" y="3977639"/>
-            <a:ext cx="5166360" cy="1143000"/>
-          </a:xfrm>
-          <a:prstGeom prst="rect">
-            <a:avLst/>
-          </a:prstGeom>
-          <a:solidFill>
-            <a:srgbClr val="FFFFFF"/>
-          </a:solidFill>
-          <a:ln>
-            <a:noFill/>
-          </a:ln>
-        </p:spPr>
-        <p:style>
-          <a:lnRef idx="1">
-            <a:schemeClr val="accent1"/>
-          </a:lnRef>
-          <a:fillRef idx="3">
-            <a:schemeClr val="accent1"/>
-          </a:fillRef>
-          <a:effectRef idx="2">
-            <a:schemeClr val="accent1"/>
-          </a:effectRef>
-          <a:fontRef idx="minor">
-            <a:schemeClr val="lt1"/>
-          </a:fontRef>
-        </p:style>
-        <p:txBody>
-          <a:bodyPr rtlCol="0" anchor="ctr"/>
-          <a:lstStyle/>
-          <a:p>
-            <a:pPr algn="ctr"/>
-          </a:p>
-        </p:txBody>
-      </p:sp>
-      <p:sp>
-        <p:nvSpPr>
-          <p:cNvPr id="28" name="Rectangle 27"/>
-          <p:cNvSpPr/>
-          <p:nvPr/>
-        </p:nvSpPr>
-        <p:spPr>
-          <a:xfrm>
-            <a:off x="6309360" y="3977639"/>
-            <a:ext cx="59436" cy="1143000"/>
-          </a:xfrm>
-          <a:prstGeom prst="rect">
-            <a:avLst/>
-          </a:prstGeom>
-          <a:solidFill>
-            <a:srgbClr val="0D9488"/>
-          </a:solidFill>
-          <a:ln>
-            <a:noFill/>
-          </a:ln>
-        </p:spPr>
-        <p:style>
-          <a:lnRef idx="1">
-            <a:schemeClr val="accent1"/>
-          </a:lnRef>
-          <a:fillRef idx="3">
-            <a:schemeClr val="accent1"/>
-          </a:fillRef>
-          <a:effectRef idx="2">
-            <a:schemeClr val="accent1"/>
-          </a:effectRef>
-          <a:fontRef idx="minor">
-            <a:schemeClr val="lt1"/>
-          </a:fontRef>
-        </p:style>
-        <p:txBody>
-          <a:bodyPr rtlCol="0" anchor="ctr"/>
-          <a:lstStyle/>
-          <a:p>
-            <a:pPr algn="ctr"/>
-          </a:p>
-        </p:txBody>
-      </p:sp>
-      <p:sp>
-        <p:nvSpPr>
-          <p:cNvPr id="29" name="TextBox 28"/>
-          <p:cNvSpPr txBox="1"/>
-          <p:nvPr/>
-        </p:nvSpPr>
-        <p:spPr>
-          <a:xfrm>
-            <a:off x="6492240" y="4032503"/>
-            <a:ext cx="4892040" cy="384048"/>
-          </a:xfrm>
-          <a:prstGeom prst="rect">
-            <a:avLst/>
-          </a:prstGeom>
-          <a:noFill/>
-        </p:spPr>
-        <p:txBody>
-          <a:bodyPr wrap="square" lIns="54864" rIns="54864" tIns="54864" bIns="54864" anchor="t">
-            <a:spAutoFit/>
-          </a:bodyPr>
-          <a:lstStyle/>
-          <a:p>
-            <a:pPr algn="l">
-              <a:spcAft>
-                <a:spcPts val="0"/>
-              </a:spcAft>
-            </a:pPr>
-            <a:r>
-              <a:rPr sz="1500" b="1">
-                <a:solidFill>
-                  <a:srgbClr val="0F0F0F"/>
-                </a:solidFill>
-                <a:latin typeface="Arial"/>
-              </a:rPr>
-              <a:t>OE7</a:t>
-            </a:r>
-          </a:p>
-        </p:txBody>
-      </p:sp>
-      <p:sp>
-        <p:nvSpPr>
-          <p:cNvPr id="30" name="TextBox 29"/>
-          <p:cNvSpPr txBox="1"/>
-          <p:nvPr/>
-        </p:nvSpPr>
-        <p:spPr>
-          <a:xfrm>
-            <a:off x="6492240" y="4434839"/>
-            <a:ext cx="4892040" cy="621793"/>
-          </a:xfrm>
-          <a:prstGeom prst="rect">
-            <a:avLst/>
-          </a:prstGeom>
-          <a:noFill/>
-        </p:spPr>
-        <p:txBody>
-          <a:bodyPr wrap="square" lIns="54864" rIns="54864" tIns="54864" bIns="54864" anchor="t">
-            <a:spAutoFit/>
-          </a:bodyPr>
-          <a:lstStyle/>
-          <a:p>
-            <a:pPr algn="l">
-              <a:spcAft>
-                <a:spcPts val="0"/>
-              </a:spcAft>
-            </a:pPr>
-            <a:r>
-              <a:rPr sz="1350" b="0">
-                <a:solidFill>
-                  <a:srgbClr val="232323"/>
-                </a:solidFill>
-                <a:latin typeface="Arial"/>
-              </a:rPr>
-              <a:t>Derivação de requisitos, critérios de dados e modelos, protocolo de avaliação e arquitetura de referência.</a:t>
-            </a:r>
-          </a:p>
-        </p:txBody>
-      </p:sp>
-      <p:sp>
-        <p:nvSpPr>
-          <p:cNvPr id="31" name="TextBox 30"/>
-          <p:cNvSpPr txBox="1"/>
-          <p:nvPr/>
-        </p:nvSpPr>
-        <p:spPr>
-          <a:xfrm>
-            <a:off x="914400" y="5897880"/>
-            <a:ext cx="10287000" cy="384048"/>
-          </a:xfrm>
-          <a:prstGeom prst="rect">
-            <a:avLst/>
-          </a:prstGeom>
-          <a:noFill/>
-        </p:spPr>
-        <p:txBody>
-          <a:bodyPr wrap="square" lIns="54864" rIns="54864" tIns="54864" bIns="54864" anchor="t">
-            <a:spAutoFit/>
-          </a:bodyPr>
-          <a:lstStyle/>
-          <a:p>
-            <a:pPr algn="ctr">
-              <a:spcAft>
-                <a:spcPts val="0"/>
-              </a:spcAft>
-            </a:pPr>
-            <a:r>
-              <a:rPr sz="1400" b="0">
-                <a:solidFill>
-                  <a:srgbClr val="64748B"/>
-                </a:solidFill>
-                <a:latin typeface="Arial"/>
-              </a:rPr>
-              <a:t>A apresentação distingue objetivos executados de atividades que permanecem fora do escopo, como implementação funcional e validação com participantes.</a:t>
+              <a:t>Revisão, MMAT preliminar e pipeline são meios metodológicos. Propor o protocolo não equivale a executá-lo nem comprova eficácia pedagógica.</a:t>
             </a:r>
           </a:p>
         </p:txBody>
@@ -15892,7 +15400,7 @@
                 </a:solidFill>
                 <a:latin typeface="Arial"/>
               </a:rPr>
-              <a:t>Mobilização integrada de conhecimentos, procedimentos, estratégias e atitudes.</a:t>
+              <a:t>Mobilização de conhecimentos, habilidades, atitudes e valores para resolver demandas.</a:t>
             </a:r>
           </a:p>
         </p:txBody>
@@ -16056,7 +15564,7 @@
                 </a:solidFill>
                 <a:latin typeface="Arial"/>
               </a:rPr>
-              <a:t>Transformação construída ao longo do tempo, com compreensão, autonomia e transferência.</a:t>
+              <a:t>Neste TCC: mudanças no que o estudante sabe e consegue fazer ao longo do tempo.</a:t>
             </a:r>
           </a:p>
         </p:txBody>
@@ -18397,8 +17905,8 @@
         </p:blipFill>
         <p:spPr>
           <a:xfrm>
-            <a:off x="2359571" y="960120"/>
-            <a:ext cx="7488097" cy="5212080"/>
+            <a:off x="1470660" y="960120"/>
+            <a:ext cx="9265920" cy="5212080"/>
           </a:xfrm>
           <a:prstGeom prst="rect">
             <a:avLst/>
@@ -18525,8 +18033,8 @@
         </p:blipFill>
         <p:spPr>
           <a:xfrm>
-            <a:off x="640080" y="1649878"/>
-            <a:ext cx="5623560" cy="3741123"/>
+            <a:off x="640080" y="1649086"/>
+            <a:ext cx="5623560" cy="3742707"/>
           </a:xfrm>
           <a:prstGeom prst="rect">
             <a:avLst/>

</xml_diff>

<commit_message>
:bug: fix(tcc): complete editorial corrections
Move detailed scope to methodology and remove misplaced justification prose.
Replace source coverage with a counted pie and improve printed PRISMA labels.
Keep all synthesis fields in portrait layout without a forced page break.
Refresh verified document artifacts without changing study selection or MMAT.

Refs #24
</commit_message>
<xml_diff>
--- a/results/tcc/presentation/ensino_personalizado_de_matematica_tcc.pptx
+++ b/results/tcc/presentation/ensino_personalizado_de_matematica_tcc.pptx
@@ -6739,8 +6739,8 @@
         </p:blipFill>
         <p:spPr>
           <a:xfrm>
-            <a:off x="6213560" y="1143000"/>
-            <a:ext cx="5403680" cy="2468880"/>
+            <a:off x="7187460" y="1143000"/>
+            <a:ext cx="3455879" cy="2468880"/>
           </a:xfrm>
           <a:prstGeom prst="rect">
             <a:avLst/>

</xml_diff>

<commit_message>
:books: docs(tcc): clarify learning interpretation scope
Align the question, objective, abstracts and presentations with the approved documentary purpose.

Retain inference limits and exclude unperformed educational validation.

Refresh the canonical PDF and parallel editable PPTX without changing study data.

Refs #24
</commit_message>
<xml_diff>
--- a/results/tcc/presentation/ensino_personalizado_de_matematica_tcc.pptx
+++ b/results/tcc/presentation/ensino_personalizado_de_matematica_tcc.pptx
@@ -13740,7 +13740,7 @@
                 </a:solidFill>
                 <a:latin typeface="Arial"/>
               </a:rPr>
-              <a:t>Como estruturar uma especificação técnica e pedagógica para apoiar a interpretação docente de evidências de desempenho em matemática, com base na literatura e nos limites das inferências sobre competências e aprendizagem?</a:t>
+              <a:t>Como estruturar uma especificação técnica e pedagógica de protótipo para apoiar a interpretação docente da aprendizagem matemática a partir das evidências e técnicas computacionais identificadas na literatura?</a:t>
             </a:r>
           </a:p>
         </p:txBody>
@@ -13904,7 +13904,7 @@
                 </a:solidFill>
                 <a:latin typeface="Arial"/>
               </a:rPr>
-              <a:t>Propor uma especificação técnica e pedagógica para apoiar a interpretação docente de evidências de desempenho em matemática, fundamentada na literatura científica.</a:t>
+              <a:t>Propor uma especificação técnica e pedagógica de protótipo para apoiar a interpretação docente da aprendizagem matemática, fundamentada no mapeamento e na análise da literatura científica.</a:t>
             </a:r>
           </a:p>
         </p:txBody>

</xml_diff>

<commit_message>
:bug: fix(tcc): reconcile evidence and claims
</commit_message>
<xml_diff>
--- a/results/tcc/presentation/ensino_personalizado_de_matematica_tcc.pptx
+++ b/results/tcc/presentation/ensino_personalizado_de_matematica_tcc.pptx
@@ -8587,7 +8587,7 @@
                 </a:solidFill>
                 <a:latin typeface="Arial"/>
               </a:rPr>
-              <a:t>Apreciação preliminar por um único revisor: nove registros com texto primário revisado e oito com base em resumo/metadados.</a:t>
+              <a:t>Apreciação preliminar por um revisor: 12 textos primários consultados (9 arquivados e 3 externos) e 5 avaliações com resumo/metadados.</a:t>
             </a:r>
           </a:p>
         </p:txBody>
@@ -17452,7 +17452,7 @@
                 </a:solidFill>
                 <a:latin typeface="Arial"/>
               </a:rPr>
-              <a:t>na elegibilidade</a:t>
+              <a:t>submetidos à priorização</a:t>
             </a:r>
           </a:p>
         </p:txBody>
@@ -17616,7 +17616,7 @@
                 </a:solidFill>
                 <a:latin typeface="Arial"/>
               </a:rPr>
-              <a:t>excluídos na elegibilidade</a:t>
+              <a:t>excluídos nessa etapa</a:t>
             </a:r>
           </a:p>
         </p:txBody>
@@ -17793,8 +17793,8 @@
         </p:nvSpPr>
         <p:spPr>
           <a:xfrm>
-            <a:off x="1005840" y="5669280"/>
-            <a:ext cx="10058400" cy="320040"/>
+            <a:off x="777240" y="5623560"/>
+            <a:ext cx="10607040" cy="411480"/>
           </a:xfrm>
           <a:prstGeom prst="rect">
             <a:avLst/>
@@ -17813,13 +17813,13 @@
               </a:spcAft>
             </a:pPr>
             <a:r>
-              <a:rPr sz="1400" b="0">
+              <a:rPr sz="1150" b="0">
                 <a:solidFill>
                   <a:srgbClr val="64748B"/>
                 </a:solidFill>
                 <a:latin typeface="Arial"/>
               </a:rPr>
-              <a:t>A remoção determinística por DOI/URL precede a triagem. Igualdade de título permaneceu como candidato à auditoria semântica.</a:t>
+              <a:t>A priorização dos 2.486 registros usa metadados/resumos e não equivale à elegibilidade em texto completo; títulos repetidos seguem para auditoria semântica.</a:t>
             </a:r>
           </a:p>
         </p:txBody>
@@ -17884,7 +17884,7 @@
                 </a:solidFill>
                 <a:latin typeface="Arial"/>
               </a:rPr>
-              <a:t>Fluxo PRISMA do snapshot</a:t>
+              <a:t>Fluxo operacional do processo de seleção</a:t>
             </a:r>
           </a:p>
         </p:txBody>
@@ -17947,7 +17947,7 @@
                 </a:solidFill>
                 <a:latin typeface="Arial"/>
               </a:rPr>
-              <a:t>Figura versionada e sincronizada com os artefatos públicos do pipeline.</a:t>
+              <a:t>Representação operacional própria; não reproduz todas as etapas do diagrama PRISMA 2020.</a:t>
             </a:r>
           </a:p>
         </p:txBody>

</xml_diff>

<commit_message>
:books: docs(tcc): align manuscript and defense with evidence
</commit_message>
<xml_diff>
--- a/results/tcc/presentation/ensino_personalizado_de_matematica_tcc.pptx
+++ b/results/tcc/presentation/ensino_personalizado_de_matematica_tcc.pptx
@@ -7174,7 +7174,7 @@
                 </a:solidFill>
                 <a:latin typeface="Arial"/>
               </a:rPr>
-              <a:t>População retida e síntese empírica</a:t>
+              <a:t>Conjunto retido e síntese empírica</a:t>
             </a:r>
           </a:p>
         </p:txBody>
@@ -9615,7 +9615,7 @@
                 </a:solidFill>
                 <a:latin typeface="Arial"/>
               </a:rPr>
-              <a:t>Lacunas documentadas</a:t>
+              <a:t>Limitações localizadas nos estudos consultados</a:t>
             </a:r>
           </a:p>
         </p:txBody>
@@ -9628,8 +9628,8 @@
         </p:nvSpPr>
         <p:spPr>
           <a:xfrm>
-            <a:off x="685800" y="1143000"/>
-            <a:ext cx="3337560" cy="1417320"/>
+            <a:off x="685800" y="1097280"/>
+            <a:ext cx="5257800" cy="1737360"/>
           </a:xfrm>
           <a:prstGeom prst="rect">
             <a:avLst/>
@@ -9671,8 +9671,8 @@
         </p:nvSpPr>
         <p:spPr>
           <a:xfrm>
-            <a:off x="685800" y="1143000"/>
-            <a:ext cx="59436" cy="1417320"/>
+            <a:off x="685800" y="1097280"/>
+            <a:ext cx="59436" cy="1737360"/>
           </a:xfrm>
           <a:prstGeom prst="rect">
             <a:avLst/>
@@ -9714,8 +9714,8 @@
         </p:nvSpPr>
         <p:spPr>
           <a:xfrm>
-            <a:off x="868680" y="1197864"/>
-            <a:ext cx="3063240" cy="384048"/>
+            <a:off x="868680" y="1152144"/>
+            <a:ext cx="4983480" cy="384048"/>
           </a:xfrm>
           <a:prstGeom prst="rect">
             <a:avLst/>
@@ -9734,13 +9734,13 @@
               </a:spcAft>
             </a:pPr>
             <a:r>
-              <a:rPr sz="1500" b="1">
+              <a:rPr sz="1600" b="1">
                 <a:solidFill>
                   <a:srgbClr val="0F0F0F"/>
                 </a:solidFill>
                 <a:latin typeface="Arial"/>
               </a:rPr>
-              <a:t>Explicabilidade</a:t>
+              <a:t>He et al. (2025)</a:t>
             </a:r>
           </a:p>
         </p:txBody>
@@ -9753,8 +9753,8 @@
         </p:nvSpPr>
         <p:spPr>
           <a:xfrm>
-            <a:off x="868680" y="1600200"/>
-            <a:ext cx="3063240" cy="896113"/>
+            <a:off x="868680" y="1554480"/>
+            <a:ext cx="4983480" cy="1216153"/>
           </a:xfrm>
           <a:prstGeom prst="rect">
             <a:avLst/>
@@ -9773,13 +9773,13 @@
               </a:spcAft>
             </a:pPr>
             <a:r>
-              <a:rPr sz="1350" b="0">
+              <a:rPr sz="1300" b="0">
                 <a:solidFill>
                   <a:srgbClr val="232323"/>
                 </a:solidFill>
                 <a:latin typeface="Arial"/>
               </a:rPr>
-              <a:t>Pouca clareza sobre como as saídas chegam à interpretação pedagógica.</a:t>
+              <a:t>Oito turmas de 45 estudantes são descritas, mas a amostra declarada é n=90; docentes também se distribuem de modo desigual entre condições (pp. 1, 16, 31–35). Isso exige cautela com denominadores e possível confundimento.</a:t>
             </a:r>
           </a:p>
         </p:txBody>
@@ -9792,8 +9792,8 @@
         </p:nvSpPr>
         <p:spPr>
           <a:xfrm>
-            <a:off x="4434840" y="1143000"/>
-            <a:ext cx="3337560" cy="1417320"/>
+            <a:off x="6217920" y="1097280"/>
+            <a:ext cx="5257800" cy="1737360"/>
           </a:xfrm>
           <a:prstGeom prst="rect">
             <a:avLst/>
@@ -9835,8 +9835,8 @@
         </p:nvSpPr>
         <p:spPr>
           <a:xfrm>
-            <a:off x="4434840" y="1143000"/>
-            <a:ext cx="59436" cy="1417320"/>
+            <a:off x="6217920" y="1097280"/>
+            <a:ext cx="59436" cy="1737360"/>
           </a:xfrm>
           <a:prstGeom prst="rect">
             <a:avLst/>
@@ -9878,8 +9878,8 @@
         </p:nvSpPr>
         <p:spPr>
           <a:xfrm>
-            <a:off x="4617720" y="1197864"/>
-            <a:ext cx="3063240" cy="384048"/>
+            <a:off x="6400800" y="1152144"/>
+            <a:ext cx="4983480" cy="384048"/>
           </a:xfrm>
           <a:prstGeom prst="rect">
             <a:avLst/>
@@ -9898,13 +9898,13 @@
               </a:spcAft>
             </a:pPr>
             <a:r>
-              <a:rPr sz="1500" b="1">
+              <a:rPr sz="1600" b="1">
                 <a:solidFill>
                   <a:srgbClr val="0F0F0F"/>
                 </a:solidFill>
                 <a:latin typeface="Arial"/>
               </a:rPr>
-              <a:t>Currículo</a:t>
+              <a:t>Villegas-Ch et al. (2025)</a:t>
             </a:r>
           </a:p>
         </p:txBody>
@@ -9917,8 +9917,8 @@
         </p:nvSpPr>
         <p:spPr>
           <a:xfrm>
-            <a:off x="4617720" y="1600200"/>
-            <a:ext cx="3063240" cy="896113"/>
+            <a:off x="6400800" y="1554480"/>
+            <a:ext cx="4983480" cy="1216153"/>
           </a:xfrm>
           <a:prstGeom prst="rect">
             <a:avLst/>
@@ -9937,13 +9937,13 @@
               </a:spcAft>
             </a:pPr>
             <a:r>
-              <a:rPr sz="1350" b="0">
+              <a:rPr sz="1300" b="0">
                 <a:solidFill>
                   <a:srgbClr val="232323"/>
                 </a:solidFill>
                 <a:latin typeface="Arial"/>
               </a:rPr>
-              <a:t>Alinhamento explícito com referenciais curriculares aparece de forma limitada.</a:t>
+              <a:t>Os métodos descrevem seis semanas, mas os resultados chegam à oitava, sem conciliação nos trechos consultados (pp. 14, 22). Não se deve impor duração única à síntese.</a:t>
             </a:r>
           </a:p>
         </p:txBody>
@@ -9956,8 +9956,8 @@
         </p:nvSpPr>
         <p:spPr>
           <a:xfrm>
-            <a:off x="8183879" y="1143000"/>
-            <a:ext cx="3337560" cy="1417320"/>
+            <a:off x="685800" y="3063239"/>
+            <a:ext cx="5257800" cy="1737360"/>
           </a:xfrm>
           <a:prstGeom prst="rect">
             <a:avLst/>
@@ -9999,8 +9999,8 @@
         </p:nvSpPr>
         <p:spPr>
           <a:xfrm>
-            <a:off x="8183879" y="1143000"/>
-            <a:ext cx="59436" cy="1417320"/>
+            <a:off x="685800" y="3063239"/>
+            <a:ext cx="59436" cy="1737360"/>
           </a:xfrm>
           <a:prstGeom prst="rect">
             <a:avLst/>
@@ -10042,8 +10042,8 @@
         </p:nvSpPr>
         <p:spPr>
           <a:xfrm>
-            <a:off x="8366759" y="1197864"/>
-            <a:ext cx="3063240" cy="384048"/>
+            <a:off x="868680" y="3118103"/>
+            <a:ext cx="4983480" cy="384048"/>
           </a:xfrm>
           <a:prstGeom prst="rect">
             <a:avLst/>
@@ -10062,13 +10062,13 @@
               </a:spcAft>
             </a:pPr>
             <a:r>
-              <a:rPr sz="1500" b="1">
+              <a:rPr sz="1600" b="1">
                 <a:solidFill>
                   <a:srgbClr val="0F0F0F"/>
                 </a:solidFill>
                 <a:latin typeface="Arial"/>
               </a:rPr>
-              <a:t>Participação docente</a:t>
+              <a:t>Nyantah et al. (2025)</a:t>
             </a:r>
           </a:p>
         </p:txBody>
@@ -10081,8 +10081,8 @@
         </p:nvSpPr>
         <p:spPr>
           <a:xfrm>
-            <a:off x="8366759" y="1600200"/>
-            <a:ext cx="3063240" cy="896113"/>
+            <a:off x="868680" y="3520439"/>
+            <a:ext cx="4983480" cy="1216153"/>
           </a:xfrm>
           <a:prstGeom prst="rect">
             <a:avLst/>
@@ -10101,13 +10101,13 @@
               </a:spcAft>
             </a:pPr>
             <a:r>
-              <a:rPr sz="1350" b="0">
+              <a:rPr sz="1300" b="0">
                 <a:solidFill>
                   <a:srgbClr val="232323"/>
                 </a:solidFill>
                 <a:latin typeface="Arial"/>
               </a:rPr>
-              <a:t>Decisões de projeto nem sempre incorporam o professor como intérprete.</a:t>
+              <a:t>A alocação é descrita de modo incompatível; há diferença no pré-teste e a intervenção combina animação e jigsaw (pp. 101–105). O resultado não deve ser atribuído à animação isoladamente.</a:t>
             </a:r>
           </a:p>
         </p:txBody>
@@ -10120,8 +10120,8 @@
         </p:nvSpPr>
         <p:spPr>
           <a:xfrm>
-            <a:off x="685800" y="2971800"/>
-            <a:ext cx="3337560" cy="1417320"/>
+            <a:off x="6217920" y="3063239"/>
+            <a:ext cx="5257800" cy="1737360"/>
           </a:xfrm>
           <a:prstGeom prst="rect">
             <a:avLst/>
@@ -10163,8 +10163,8 @@
         </p:nvSpPr>
         <p:spPr>
           <a:xfrm>
-            <a:off x="685800" y="2971800"/>
-            <a:ext cx="59436" cy="1417320"/>
+            <a:off x="6217920" y="3063239"/>
+            <a:ext cx="59436" cy="1737360"/>
           </a:xfrm>
           <a:prstGeom prst="rect">
             <a:avLst/>
@@ -10206,8 +10206,8 @@
         </p:nvSpPr>
         <p:spPr>
           <a:xfrm>
-            <a:off x="868680" y="3026664"/>
-            <a:ext cx="3063240" cy="384048"/>
+            <a:off x="6400800" y="3118103"/>
+            <a:ext cx="4983480" cy="384048"/>
           </a:xfrm>
           <a:prstGeom prst="rect">
             <a:avLst/>
@@ -10226,13 +10226,13 @@
               </a:spcAft>
             </a:pPr>
             <a:r>
-              <a:rPr sz="1500" b="1">
+              <a:rPr sz="1600" b="1">
                 <a:solidFill>
                   <a:srgbClr val="0F0F0F"/>
                 </a:solidFill>
                 <a:latin typeface="Arial"/>
               </a:rPr>
-              <a:t>Equidade</a:t>
+              <a:t>Echeveria et al. (2025)</a:t>
             </a:r>
           </a:p>
         </p:txBody>
@@ -10245,8 +10245,8 @@
         </p:nvSpPr>
         <p:spPr>
           <a:xfrm>
-            <a:off x="868680" y="3429000"/>
-            <a:ext cx="3063240" cy="896113"/>
+            <a:off x="6400800" y="3520439"/>
+            <a:ext cx="4983480" cy="1216153"/>
           </a:xfrm>
           <a:prstGeom prst="rect">
             <a:avLst/>
@@ -10265,113 +10265,27 @@
               </a:spcAft>
             </a:pPr>
             <a:r>
-              <a:rPr sz="1350" b="0">
+              <a:rPr sz="1300" b="0">
                 <a:solidFill>
                   <a:srgbClr val="232323"/>
                 </a:solidFill>
                 <a:latin typeface="Arial"/>
               </a:rPr>
-              <a:t>Análises de possíveis vieses e diferenças entre grupos são escassas.</a:t>
-            </a:r>
-          </a:p>
-        </p:txBody>
-      </p:sp>
-      <p:sp>
-        <p:nvSpPr>
-          <p:cNvPr id="19" name="Rectangle 18"/>
-          <p:cNvSpPr/>
-          <p:nvPr/>
-        </p:nvSpPr>
-        <p:spPr>
-          <a:xfrm>
-            <a:off x="4434840" y="2971800"/>
-            <a:ext cx="3337560" cy="1417320"/>
-          </a:xfrm>
-          <a:prstGeom prst="rect">
-            <a:avLst/>
-          </a:prstGeom>
-          <a:solidFill>
-            <a:srgbClr val="FFFFFF"/>
-          </a:solidFill>
-          <a:ln>
-            <a:noFill/>
-          </a:ln>
-        </p:spPr>
-        <p:style>
-          <a:lnRef idx="1">
-            <a:schemeClr val="accent1"/>
-          </a:lnRef>
-          <a:fillRef idx="3">
-            <a:schemeClr val="accent1"/>
-          </a:fillRef>
-          <a:effectRef idx="2">
-            <a:schemeClr val="accent1"/>
-          </a:effectRef>
-          <a:fontRef idx="minor">
-            <a:schemeClr val="lt1"/>
-          </a:fontRef>
-        </p:style>
-        <p:txBody>
-          <a:bodyPr rtlCol="0" anchor="ctr"/>
-          <a:lstStyle/>
-          <a:p>
-            <a:pPr algn="ctr"/>
-          </a:p>
-        </p:txBody>
-      </p:sp>
-      <p:sp>
-        <p:nvSpPr>
-          <p:cNvPr id="20" name="Rectangle 19"/>
-          <p:cNvSpPr/>
-          <p:nvPr/>
-        </p:nvSpPr>
-        <p:spPr>
-          <a:xfrm>
-            <a:off x="4434840" y="2971800"/>
-            <a:ext cx="59436" cy="1417320"/>
-          </a:xfrm>
-          <a:prstGeom prst="rect">
-            <a:avLst/>
-          </a:prstGeom>
-          <a:solidFill>
-            <a:srgbClr val="EA580C"/>
-          </a:solidFill>
-          <a:ln>
-            <a:noFill/>
-          </a:ln>
-        </p:spPr>
-        <p:style>
-          <a:lnRef idx="1">
-            <a:schemeClr val="accent1"/>
-          </a:lnRef>
-          <a:fillRef idx="3">
-            <a:schemeClr val="accent1"/>
-          </a:fillRef>
-          <a:effectRef idx="2">
-            <a:schemeClr val="accent1"/>
-          </a:effectRef>
-          <a:fontRef idx="minor">
-            <a:schemeClr val="lt1"/>
-          </a:fontRef>
-        </p:style>
-        <p:txBody>
-          <a:bodyPr rtlCol="0" anchor="ctr"/>
-          <a:lstStyle/>
-          <a:p>
-            <a:pPr algn="ctr"/>
-          </a:p>
-        </p:txBody>
-      </p:sp>
-      <p:sp>
-        <p:nvSpPr>
-          <p:cNvPr id="21" name="TextBox 20"/>
+              <a:t>Oito itens usados para formar categorias também aparecem entre os preditores selecionados (pp. 66, 69–70). A classificação não estabelece diagnóstico independente.</a:t>
+            </a:r>
+          </a:p>
+        </p:txBody>
+      </p:sp>
+      <p:sp>
+        <p:nvSpPr>
+          <p:cNvPr id="19" name="TextBox 18"/>
           <p:cNvSpPr txBox="1"/>
           <p:nvPr/>
         </p:nvSpPr>
         <p:spPr>
           <a:xfrm>
-            <a:off x="4617720" y="3026664"/>
-            <a:ext cx="3063240" cy="384048"/>
+            <a:off x="822960" y="5074920"/>
+            <a:ext cx="10561320" cy="640080"/>
           </a:xfrm>
           <a:prstGeom prst="rect">
             <a:avLst/>
@@ -10379,266 +10293,24 @@
           <a:noFill/>
         </p:spPr>
         <p:txBody>
-          <a:bodyPr wrap="square" lIns="54864" rIns="54864" tIns="54864" bIns="54864" anchor="t">
+          <a:bodyPr wrap="square" lIns="54864" rIns="54864" tIns="54864" bIns="54864" anchor="ctr">
             <a:spAutoFit/>
           </a:bodyPr>
           <a:lstStyle/>
           <a:p>
-            <a:pPr algn="l">
+            <a:pPr algn="ctr">
               <a:spcAft>
                 <a:spcPts val="0"/>
               </a:spcAft>
             </a:pPr>
             <a:r>
-              <a:rPr sz="1500" b="1">
-                <a:solidFill>
-                  <a:srgbClr val="0F0F0F"/>
+              <a:rPr sz="1300" b="0">
+                <a:solidFill>
+                  <a:srgbClr val="334155"/>
                 </a:solidFill>
                 <a:latin typeface="Arial"/>
               </a:rPr>
-              <a:t>Reprodutibilidade</a:t>
-            </a:r>
-          </a:p>
-        </p:txBody>
-      </p:sp>
-      <p:sp>
-        <p:nvSpPr>
-          <p:cNvPr id="22" name="TextBox 21"/>
-          <p:cNvSpPr txBox="1"/>
-          <p:nvPr/>
-        </p:nvSpPr>
-        <p:spPr>
-          <a:xfrm>
-            <a:off x="4617720" y="3429000"/>
-            <a:ext cx="3063240" cy="896113"/>
-          </a:xfrm>
-          <a:prstGeom prst="rect">
-            <a:avLst/>
-          </a:prstGeom>
-          <a:noFill/>
-        </p:spPr>
-        <p:txBody>
-          <a:bodyPr wrap="square" lIns="54864" rIns="54864" tIns="54864" bIns="54864" anchor="t">
-            <a:spAutoFit/>
-          </a:bodyPr>
-          <a:lstStyle/>
-          <a:p>
-            <a:pPr algn="l">
-              <a:spcAft>
-                <a:spcPts val="0"/>
-              </a:spcAft>
-            </a:pPr>
-            <a:r>
-              <a:rPr sz="1350" b="0">
-                <a:solidFill>
-                  <a:srgbClr val="232323"/>
-                </a:solidFill>
-                <a:latin typeface="Arial"/>
-              </a:rPr>
-              <a:t>Dados, códigos e detalhes de preparação nem sempre estão disponíveis.</a:t>
-            </a:r>
-          </a:p>
-        </p:txBody>
-      </p:sp>
-      <p:sp>
-        <p:nvSpPr>
-          <p:cNvPr id="23" name="Rectangle 22"/>
-          <p:cNvSpPr/>
-          <p:nvPr/>
-        </p:nvSpPr>
-        <p:spPr>
-          <a:xfrm>
-            <a:off x="8183879" y="2971800"/>
-            <a:ext cx="3337560" cy="1417320"/>
-          </a:xfrm>
-          <a:prstGeom prst="rect">
-            <a:avLst/>
-          </a:prstGeom>
-          <a:solidFill>
-            <a:srgbClr val="FFFFFF"/>
-          </a:solidFill>
-          <a:ln>
-            <a:noFill/>
-          </a:ln>
-        </p:spPr>
-        <p:style>
-          <a:lnRef idx="1">
-            <a:schemeClr val="accent1"/>
-          </a:lnRef>
-          <a:fillRef idx="3">
-            <a:schemeClr val="accent1"/>
-          </a:fillRef>
-          <a:effectRef idx="2">
-            <a:schemeClr val="accent1"/>
-          </a:effectRef>
-          <a:fontRef idx="minor">
-            <a:schemeClr val="lt1"/>
-          </a:fontRef>
-        </p:style>
-        <p:txBody>
-          <a:bodyPr rtlCol="0" anchor="ctr"/>
-          <a:lstStyle/>
-          <a:p>
-            <a:pPr algn="ctr"/>
-          </a:p>
-        </p:txBody>
-      </p:sp>
-      <p:sp>
-        <p:nvSpPr>
-          <p:cNvPr id="24" name="Rectangle 23"/>
-          <p:cNvSpPr/>
-          <p:nvPr/>
-        </p:nvSpPr>
-        <p:spPr>
-          <a:xfrm>
-            <a:off x="8183879" y="2971800"/>
-            <a:ext cx="59436" cy="1417320"/>
-          </a:xfrm>
-          <a:prstGeom prst="rect">
-            <a:avLst/>
-          </a:prstGeom>
-          <a:solidFill>
-            <a:srgbClr val="4F46E5"/>
-          </a:solidFill>
-          <a:ln>
-            <a:noFill/>
-          </a:ln>
-        </p:spPr>
-        <p:style>
-          <a:lnRef idx="1">
-            <a:schemeClr val="accent1"/>
-          </a:lnRef>
-          <a:fillRef idx="3">
-            <a:schemeClr val="accent1"/>
-          </a:fillRef>
-          <a:effectRef idx="2">
-            <a:schemeClr val="accent1"/>
-          </a:effectRef>
-          <a:fontRef idx="minor">
-            <a:schemeClr val="lt1"/>
-          </a:fontRef>
-        </p:style>
-        <p:txBody>
-          <a:bodyPr rtlCol="0" anchor="ctr"/>
-          <a:lstStyle/>
-          <a:p>
-            <a:pPr algn="ctr"/>
-          </a:p>
-        </p:txBody>
-      </p:sp>
-      <p:sp>
-        <p:nvSpPr>
-          <p:cNvPr id="25" name="TextBox 24"/>
-          <p:cNvSpPr txBox="1"/>
-          <p:nvPr/>
-        </p:nvSpPr>
-        <p:spPr>
-          <a:xfrm>
-            <a:off x="8366759" y="3026664"/>
-            <a:ext cx="3063240" cy="384048"/>
-          </a:xfrm>
-          <a:prstGeom prst="rect">
-            <a:avLst/>
-          </a:prstGeom>
-          <a:noFill/>
-        </p:spPr>
-        <p:txBody>
-          <a:bodyPr wrap="square" lIns="54864" rIns="54864" tIns="54864" bIns="54864" anchor="t">
-            <a:spAutoFit/>
-          </a:bodyPr>
-          <a:lstStyle/>
-          <a:p>
-            <a:pPr algn="l">
-              <a:spcAft>
-                <a:spcPts val="0"/>
-              </a:spcAft>
-            </a:pPr>
-            <a:r>
-              <a:rPr sz="1500" b="1">
-                <a:solidFill>
-                  <a:srgbClr val="0F0F0F"/>
-                </a:solidFill>
-                <a:latin typeface="Arial"/>
-              </a:rPr>
-              <a:t>Contexto</a:t>
-            </a:r>
-          </a:p>
-        </p:txBody>
-      </p:sp>
-      <p:sp>
-        <p:nvSpPr>
-          <p:cNvPr id="26" name="TextBox 25"/>
-          <p:cNvSpPr txBox="1"/>
-          <p:nvPr/>
-        </p:nvSpPr>
-        <p:spPr>
-          <a:xfrm>
-            <a:off x="8366759" y="3429000"/>
-            <a:ext cx="3063240" cy="896113"/>
-          </a:xfrm>
-          <a:prstGeom prst="rect">
-            <a:avLst/>
-          </a:prstGeom>
-          <a:noFill/>
-        </p:spPr>
-        <p:txBody>
-          <a:bodyPr wrap="square" lIns="54864" rIns="54864" tIns="54864" bIns="54864" anchor="t">
-            <a:spAutoFit/>
-          </a:bodyPr>
-          <a:lstStyle/>
-          <a:p>
-            <a:pPr algn="l">
-              <a:spcAft>
-                <a:spcPts val="0"/>
-              </a:spcAft>
-            </a:pPr>
-            <a:r>
-              <a:rPr sz="1350" b="0">
-                <a:solidFill>
-                  <a:srgbClr val="232323"/>
-                </a:solidFill>
-                <a:latin typeface="Arial"/>
-              </a:rPr>
-              <a:t>Validações permanecem restritas a populações e cenários específicos.</a:t>
-            </a:r>
-          </a:p>
-        </p:txBody>
-      </p:sp>
-      <p:sp>
-        <p:nvSpPr>
-          <p:cNvPr id="27" name="TextBox 26"/>
-          <p:cNvSpPr txBox="1"/>
-          <p:nvPr/>
-        </p:nvSpPr>
-        <p:spPr>
-          <a:xfrm>
-            <a:off x="914400" y="5806440"/>
-            <a:ext cx="10241280" cy="292608"/>
-          </a:xfrm>
-          <a:prstGeom prst="rect">
-            <a:avLst/>
-          </a:prstGeom>
-          <a:noFill/>
-        </p:spPr>
-        <p:txBody>
-          <a:bodyPr wrap="square" lIns="54864" rIns="54864" tIns="54864" bIns="54864" anchor="t">
-            <a:spAutoFit/>
-          </a:bodyPr>
-          <a:lstStyle/>
-          <a:p>
-            <a:pPr algn="ctr">
-              <a:spcAft>
-                <a:spcPts val="0"/>
-              </a:spcAft>
-            </a:pPr>
-            <a:r>
-              <a:rPr sz="1400" b="0">
-                <a:solidFill>
-                  <a:srgbClr val="64748B"/>
-                </a:solidFill>
-                <a:latin typeface="Arial"/>
-              </a:rPr>
-              <a:t>Essas lacunas foram tratadas como requisitos de projeto — não como prova de que uma solução futura será eficaz.</a:t>
+              <a:t>Exemplos localizados, não estimam a frequência da literatura. Cobertura: 12 de 17 textos primários; os demais foram apreciados por resumo/metadados. MMAT preliminar, por revisor único.</a:t>
             </a:r>
           </a:p>
         </p:txBody>
@@ -16592,7 +16264,7 @@
                 </a:solidFill>
                 <a:latin typeface="Arial"/>
               </a:rPr>
-              <a:t>Do registro bruto à população retida</a:t>
+              <a:t>Do registro bruto ao conjunto retido provisoriamente</a:t>
             </a:r>
           </a:p>
         </p:txBody>

</xml_diff>

<commit_message>
:bug: fix(tcc): align evidence and table pagination
</commit_message>
<xml_diff>
--- a/results/tcc/presentation/ensino_personalizado_de_matematica_tcc.pptx
+++ b/results/tcc/presentation/ensino_personalizado_de_matematica_tcc.pptx
@@ -5806,7 +5806,7 @@
                 <a:latin typeface="Arial"/>
               </a:rPr>
               <a:t>Instituto Federal Catarinense — Campus Videira
-Snapshot adjudicado: 03/09/2026 · recorte temporal: 2015–2026</a:t>
+Revisão atualizada: 12/10/2026 · corte da busca: 31/08/2026</a:t>
             </a:r>
           </a:p>
         </p:txBody>
@@ -6715,8 +6715,8 @@
         </p:blipFill>
         <p:spPr>
           <a:xfrm>
-            <a:off x="548640" y="1275734"/>
-            <a:ext cx="5486400" cy="2203412"/>
+            <a:off x="548640" y="1276227"/>
+            <a:ext cx="5486400" cy="2202425"/>
           </a:xfrm>
           <a:prstGeom prst="rect">
             <a:avLst/>
@@ -7463,7 +7463,7 @@
                 </a:solidFill>
                 <a:latin typeface="Arial"/>
               </a:rPr>
-              <a:t>17</a:t>
+              <a:t>12</a:t>
             </a:r>
           </a:p>
         </p:txBody>
@@ -7502,7 +7502,7 @@
                 </a:solidFill>
                 <a:latin typeface="Arial"/>
               </a:rPr>
-              <a:t>candidatos empíricos provisórios</a:t>
+              <a:t>estudos empíricos incluídos</a:t>
             </a:r>
           </a:p>
         </p:txBody>
@@ -7627,7 +7627,7 @@
                 </a:solidFill>
                 <a:latin typeface="Arial"/>
               </a:rPr>
-              <a:t>1</a:t>
+              <a:t>4</a:t>
             </a:r>
           </a:p>
         </p:txBody>
@@ -7666,7 +7666,7 @@
                 </a:solidFill>
                 <a:latin typeface="Arial"/>
               </a:rPr>
-              <a:t>protocolo ou proposta contextual</a:t>
+              <a:t>textos integrais pendentes</a:t>
             </a:r>
           </a:p>
         </p:txBody>
@@ -7791,7 +7791,7 @@
                 </a:solidFill>
                 <a:latin typeface="Arial"/>
               </a:rPr>
-              <a:t>O que entra na síntese</a:t>
+              <a:t>Desfecho da seleção</a:t>
             </a:r>
           </a:p>
         </p:txBody>
@@ -7830,7 +7830,7 @@
                 </a:solidFill>
                 <a:latin typeface="Arial"/>
               </a:rPr>
-              <a:t>A síntese de evidências e a apreciação MMAT aplicável consideram os 17 candidatos empíricos. O protocolo/proposta contextual foi mantido para rastreabilidade do mapeamento, mas não sustenta resultado empírico concluído.</a:t>
+              <a:t>Dos 18 registros shortlistados, 12 estudos empíricos foram incluídos, quatro relatórios não foram recuperados, um registro foi excluído após o resumo e um protocolo sem resultados concluídos foi excluído após texto completo. Os quatro pendentes não receberam MMAT.</a:t>
             </a:r>
           </a:p>
         </p:txBody>
@@ -8581,13 +8581,13 @@
               </a:spcAft>
             </a:pPr>
             <a:r>
-              <a:rPr sz="1400" b="0">
+              <a:rPr sz="1300" b="0">
                 <a:solidFill>
                   <a:srgbClr val="232323"/>
                 </a:solidFill>
                 <a:latin typeface="Arial"/>
               </a:rPr>
-              <a:t>Apreciação preliminar por um revisor: 12 textos primários consultados (9 arquivados e 3 externos) e 5 avaliações com resumo/metadados.</a:t>
+              <a:t>MMAT preliminar em 12 estudos incluídos, com texto integral consultado, por revisor único. Quatro textos não recuperados não receberam MMAT; um registro foi excluído após resumo e um protocolo após texto completo.</a:t>
             </a:r>
           </a:p>
         </p:txBody>
@@ -10304,13 +10304,13 @@
               </a:spcAft>
             </a:pPr>
             <a:r>
-              <a:rPr sz="1300" b="0">
+              <a:rPr sz="1250" b="0">
                 <a:solidFill>
                   <a:srgbClr val="334155"/>
                 </a:solidFill>
                 <a:latin typeface="Arial"/>
               </a:rPr>
-              <a:t>Exemplos localizados, não estimam a frequência da literatura. Cobertura: 12 de 17 textos primários; os demais foram apreciados por resumo/metadados. MMAT preliminar, por revisor único.</a:t>
+              <a:t>Estes exemplos localizados não estimam a frequência da literatura. O núcleo tem 12 estudos incluídos, avaliados em texto integral por um revisor; quatro relatórios não recuperados não receberam MMAT. Um registro foi excluído após resumo e um protocolo após texto completo.</a:t>
             </a:r>
           </a:p>
         </p:txBody>
@@ -12240,9 +12240,9 @@
                 <a:latin typeface="Arial"/>
               </a:rPr>
               <a:t>• um único pesquisador
-• parte da apreciação baseada em resumo/metadados
+• quatro textos integrais pendentes, sem MMAT
 • fontes e idiomas delimitados
-• MMAT preliminar
+• MMAT preliminar nos 12 estudos incluídos
 • sem aplicação funcional ou eficácia pedagógica própria</a:t>
             </a:r>
           </a:p>
@@ -12548,7 +12548,7 @@
                 <a:latin typeface="Arial"/>
               </a:rPr>
               <a:t>Thales Ferreira Batista · Ciência da Computação · IFC Videira
-Snapshot adjudicado: 03/09/2026 · recorte temporal: 2015–2026</a:t>
+Revisão atualizada: 12/10/2026 · corte da busca: 31/08/2026</a:t>
             </a:r>
           </a:p>
         </p:txBody>
@@ -17705,8 +17705,8 @@
         </p:blipFill>
         <p:spPr>
           <a:xfrm>
-            <a:off x="640080" y="1649086"/>
-            <a:ext cx="5623560" cy="3742707"/>
+            <a:off x="640080" y="1650666"/>
+            <a:ext cx="5623560" cy="3739548"/>
           </a:xfrm>
           <a:prstGeom prst="rect">
             <a:avLst/>

</xml_diff>

<commit_message>
:books: docs(tcc): sync defense deck and public pages
Publish the reviewed MMAT state across the canonical deck, editable export, navigation, and reader-facing pages while preserving the distinction between the TCC and the earlier PTC presentation.
</commit_message>
<xml_diff>
--- a/results/tcc/presentation/ensino_personalizado_de_matematica_tcc.pptx
+++ b/results/tcc/presentation/ensino_personalizado_de_matematica_tcc.pptx
@@ -5806,7 +5806,7 @@
                 <a:latin typeface="Arial"/>
               </a:rPr>
               <a:t>Instituto Federal Catarinense — Campus Videira
-Revisão atualizada: 12/10/2026 · corte da busca: 31/08/2026</a:t>
+Revisão atualizada: 14/10/2026 · corte da busca: 31/08/2026</a:t>
             </a:r>
           </a:p>
         </p:txBody>
@@ -7463,7 +7463,7 @@
                 </a:solidFill>
                 <a:latin typeface="Arial"/>
               </a:rPr>
-              <a:t>12</a:t>
+              <a:t>15</a:t>
             </a:r>
           </a:p>
         </p:txBody>
@@ -7502,7 +7502,7 @@
                 </a:solidFill>
                 <a:latin typeface="Arial"/>
               </a:rPr>
-              <a:t>estudos empíricos incluídos</a:t>
+              <a:t>registros empíricos mantidos provisoriamente</a:t>
             </a:r>
           </a:p>
         </p:txBody>
@@ -7627,7 +7627,7 @@
                 </a:solidFill>
                 <a:latin typeface="Arial"/>
               </a:rPr>
-              <a:t>4</a:t>
+              <a:t>1</a:t>
             </a:r>
           </a:p>
         </p:txBody>
@@ -7666,7 +7666,7 @@
                 </a:solidFill>
                 <a:latin typeface="Arial"/>
               </a:rPr>
-              <a:t>textos integrais pendentes</a:t>
+              <a:t>texto integral pendente</a:t>
             </a:r>
           </a:p>
         </p:txBody>
@@ -7830,7 +7830,7 @@
                 </a:solidFill>
                 <a:latin typeface="Arial"/>
               </a:rPr>
-              <a:t>Dos 18 registros shortlistados, 12 estudos empíricos foram incluídos, quatro relatórios não foram recuperados, um registro foi excluído após o resumo e um protocolo sem resultados concluídos foi excluído após texto completo. Os quatro pendentes não receberam MMAT.</a:t>
+              <a:t>Dos 18 registros shortlistados, 15 permanecem provisoriamente no núcleo empírico; um relatório não foi recuperado, um registro foi excluído após o resumo e um protocolo sem resultados concluídos foi excluído após texto completo. O estudo 8 permanece no fluxo, sem respostas MMAT até adjudicar elegibilidade e unidade; o texto não recuperado também não recebeu MMAT.</a:t>
             </a:r>
           </a:p>
         </p:txBody>
@@ -8587,7 +8587,7 @@
                 </a:solidFill>
                 <a:latin typeface="Arial"/>
               </a:rPr>
-              <a:t>MMAT preliminar em 12 estudos incluídos, com texto integral consultado, por revisor único. Quatro textos não recuperados não receberam MMAT; um registro foi excluído após resumo e um protocolo após texto completo.</a:t>
+              <a:t>MMAT preliminar em 14 dos 15 registros empíricos mantidos provisoriamente, por revisor único. O estudo 8 está sem respostas até adjudicação da elegibilidade/unidade; um texto não recuperado também não recebeu MMAT. Um registro foi excluído após resumo e um protocolo após texto completo.</a:t>
             </a:r>
           </a:p>
         </p:txBody>
@@ -10310,7 +10310,7 @@
                 </a:solidFill>
                 <a:latin typeface="Arial"/>
               </a:rPr>
-              <a:t>Estes exemplos localizados não estimam a frequência da literatura. O núcleo tem 12 estudos incluídos, avaliados em texto integral por um revisor; quatro relatórios não recuperados não receberam MMAT. Um registro foi excluído após resumo e um protocolo após texto completo.</a:t>
+              <a:t>Estes exemplos localizados não estimam a frequência da literatura. Quinze registros permanecem provisoriamente no núcleo; o MMAT preliminar abrange 14, e o estudo 8 segue sem respostas até adjudicação da unidade. Um relatório não recuperado não recebeu MMAT; um registro foi excluído após resumo e um protocolo após texto completo.</a:t>
             </a:r>
           </a:p>
         </p:txBody>
@@ -12240,9 +12240,9 @@
                 <a:latin typeface="Arial"/>
               </a:rPr>
               <a:t>• um único pesquisador
-• quatro textos integrais pendentes, sem MMAT
+• um texto integral pendente, sem MMAT
 • fontes e idiomas delimitados
-• MMAT preliminar nos 12 estudos incluídos
+• MMAT preliminar em 14 de 15 inclusões provisórias; estudo 8 sem avaliação
 • sem aplicação funcional ou eficácia pedagógica própria</a:t>
             </a:r>
           </a:p>
@@ -12548,7 +12548,7 @@
                 <a:latin typeface="Arial"/>
               </a:rPr>
               <a:t>Thales Ferreira Batista · Ciência da Computação · IFC Videira
-Revisão atualizada: 12/10/2026 · corte da busca: 31/08/2026</a:t>
+Revisão atualizada: 14/10/2026 · corte da busca: 31/08/2026</a:t>
             </a:r>
           </a:p>
         </p:txBody>

</xml_diff>

<commit_message>
:mag: fix(tcc): reconcile Study 8 scope and generated outputs
Keep Study 8 provisional until empirical eligibility and MMAT appraisal unit are adjudicated. Refresh evidence hashes, derived visualizations, reproducibility data, PDF, and editable deck.
</commit_message>
<xml_diff>
--- a/results/tcc/presentation/ensino_personalizado_de_matematica_tcc.pptx
+++ b/results/tcc/presentation/ensino_personalizado_de_matematica_tcc.pptx
@@ -5871,7 +5871,7 @@
                 </a:solidFill>
                 <a:latin typeface="Arial"/>
               </a:rPr>
-              <a:t>Panorama descritivo do snapshot</a:t>
+              <a:t>Panorama descritivo do recorte versionado</a:t>
             </a:r>
           </a:p>
         </p:txBody>
@@ -6906,7 +6906,7 @@
                 </a:solidFill>
                 <a:latin typeface="Arial"/>
               </a:rPr>
-              <a:t>O snapshot foi delimitado a 2015–2026, com data de corte em 31 de agosto de 2026. Como 2026 é parcial, sua barra não deve ser comparada diretamente com anos completos.</a:t>
+              <a:t>O recorte foi delimitado a 2015–2026, com data de corte em 31 de agosto de 2026. Como 2026 é parcial, sua barra não deve ser comparada diretamente com anos completos.</a:t>
             </a:r>
           </a:p>
         </p:txBody>
@@ -7830,7 +7830,7 @@
                 </a:solidFill>
                 <a:latin typeface="Arial"/>
               </a:rPr>
-              <a:t>Dos 18 registros shortlistados, 15 permanecem provisoriamente no núcleo empírico; um relatório não foi recuperado, um registro foi excluído após o resumo e um protocolo sem resultados concluídos foi excluído após texto completo. O estudo 8 permanece no fluxo, sem respostas MMAT até adjudicar elegibilidade e unidade; o texto não recuperado também não recebeu MMAT.</a:t>
+              <a:t>Dos 18 registros selecionados preliminarmente, um foi excluído após o resumo. Dos 17 relatórios procurados, um não foi recuperado e 16 foram avaliados em texto completo; um protocolo sem resultados concluídos foi excluído após essa avaliação e 15 registros empíricos permanecem provisoriamente no núcleo. O estudo 8 aguarda adjudicação de elegibilidade e unidade de análise; o relatório não recuperado não recebeu MMAT.</a:t>
             </a:r>
           </a:p>
         </p:txBody>
@@ -16303,7 +16303,7 @@
                 </a:solidFill>
                 <a:latin typeface="Arial"/>
               </a:rPr>
-              <a:t>Contagens do snapshot adjudicado</a:t>
+              <a:t>Contagens do recorte versionado</a:t>
             </a:r>
           </a:p>
         </p:txBody>

</xml_diff>

<commit_message>
:books: docs(tcc): refresh validated defense exports
Compile the manuscript with the requirement traceability quadro.
Refresh the separate editable deck.

Preserve the 25-slide Slidev and 19-slide PPTX distinction.
</commit_message>
<xml_diff>
--- a/results/tcc/presentation/ensino_personalizado_de_matematica_tcc.pptx
+++ b/results/tcc/presentation/ensino_personalizado_de_matematica_tcc.pptx
@@ -5806,7 +5806,7 @@
                 <a:latin typeface="Arial"/>
               </a:rPr>
               <a:t>Instituto Federal Catarinense — Campus Videira
-Revisão atualizada: 14/10/2026 · corte da busca: 31/08/2026</a:t>
+Versão revisada: 15/10/2026 · corte da busca: 31/08/2026</a:t>
             </a:r>
           </a:p>
         </p:txBody>
@@ -8587,7 +8587,7 @@
                 </a:solidFill>
                 <a:latin typeface="Arial"/>
               </a:rPr>
-              <a:t>MMAT preliminar em 14 dos 15 registros empíricos mantidos provisoriamente, por revisor único. O estudo 8 está sem respostas até adjudicação da elegibilidade/unidade; um texto não recuperado também não recebeu MMAT. Um registro foi excluído após resumo e um protocolo após texto completo.</a:t>
+              <a:t>15 empíricos provisórios. S1/S2: 14; Q1–Q5: 11. Estudos 5, 7 e 14 aguardam categoria; estudo 8 aguarda unidade. Um texto não recuperado, sem MMAT. Julgamentos de revisor único.</a:t>
             </a:r>
           </a:p>
         </p:txBody>
@@ -9943,7 +9943,7 @@
                 </a:solidFill>
                 <a:latin typeface="Arial"/>
               </a:rPr>
-              <a:t>Os métodos descrevem seis semanas, mas os resultados chegam à oitava, sem conciliação nos trechos consultados (pp. 14, 22). Não se deve impor duração única à síntese.</a:t>
+              <a:t>Os métodos descrevem seis semanas, mas a subanálise de programação reporta resultados na oitava, sem conciliação nos trechos consultados (pp. 14, 22). Não se deve impor duração única à síntese.</a:t>
             </a:r>
           </a:p>
         </p:txBody>
@@ -10310,7 +10310,7 @@
                 </a:solidFill>
                 <a:latin typeface="Arial"/>
               </a:rPr>
-              <a:t>Estes exemplos localizados não estimam a frequência da literatura. Quinze registros permanecem provisoriamente no núcleo; o MMAT preliminar abrange 14, e o estudo 8 segue sem respostas até adjudicação da unidade. Um relatório não recuperado não recebeu MMAT; um registro foi excluído após resumo e um protocolo após texto completo.</a:t>
+              <a:t>Estes exemplos localizados não estimam a frequência da literatura. Quinze registros permanecem provisoriamente no núcleo; há 14 triagens S1/S2 e 11 apreciações por categoria, e o estudo 8 segue sem respostas até adjudicação da unidade. Um relatório não recuperado não recebeu MMAT; um registro foi excluído após resumo e um protocolo após texto completo.</a:t>
             </a:r>
           </a:p>
         </p:txBody>
@@ -12242,7 +12242,7 @@
               <a:t>• um único pesquisador
 • um texto integral pendente, sem MMAT
 • fontes e idiomas delimitados
-• MMAT preliminar em 14 de 15 inclusões provisórias; estudo 8 sem avaliação
+• MMAT: 14 triagens, 11 apreciações por categoria; estudo 8 sem avaliação
 • sem aplicação funcional ou eficácia pedagógica própria</a:t>
             </a:r>
           </a:p>
@@ -12548,7 +12548,7 @@
                 <a:latin typeface="Arial"/>
               </a:rPr>
               <a:t>Thales Ferreira Batista · Ciência da Computação · IFC Videira
-Revisão atualizada: 14/10/2026 · corte da busca: 31/08/2026</a:t>
+Versão revisada: 15/10/2026 · corte da busca: 31/08/2026</a:t>
             </a:r>
           </a:p>
         </p:txBody>

</xml_diff>

<commit_message>
:bug: fix(presentation): align synthesis and public asset paths
Qualify performance categories without claiming validated proficiency.
Use public-root image URLs for the logo, charts and repository QR.
Run the presentation contract tests in CI.
</commit_message>
<xml_diff>
--- a/results/tcc/presentation/ensino_personalizado_de_matematica_tcc.pptx
+++ b/results/tcc/presentation/ensino_personalizado_de_matematica_tcc.pptx
@@ -7955,7 +7955,7 @@
                 </a:solidFill>
                 <a:latin typeface="Arial"/>
               </a:rPr>
-              <a:t>Padrão observado</a:t>
+              <a:t>Exemplos observados</a:t>
             </a:r>
           </a:p>
         </p:txBody>
@@ -7994,7 +7994,7 @@
                 </a:solidFill>
                 <a:latin typeface="Arial"/>
               </a:rPr>
-              <a:t>Predomínio de aplicações voltadas à predição de desempenho e à estimativa de proficiência, com recorrência de modelos supervisionados como Random Forest, SVM, árvores de decisão e redes neurais.</a:t>
+              <a:t>Há classificação e predição de resultados matemáticos, com RF, SVM, árvores e redes neurais entre as alternativas examinadas. Categorias operacionais de desempenho não equivalem automaticamente a níveis de proficiência validados.</a:t>
             </a:r>
           </a:p>
         </p:txBody>
@@ -9019,7 +9019,7 @@
                 </a:solidFill>
                 <a:latin typeface="Arial"/>
               </a:rPr>
-              <a:t>A literatura oferece um mapa auditável de técnicas, finalidades e formas de avaliação aplicadas à educação matemática.</a:t>
+              <a:t>O recorte examinado oferece exemplos auditáveis de técnicas, finalidades e formas de avaliação aplicadas à educação matemática.</a:t>
             </a:r>
           </a:p>
         </p:txBody>

</xml_diff>

<commit_message>
:mag: fix(tcc): qualify source coverage and conceptual appraisal
Align OE4 with conceptual appraisal; retain pending human decisions.

Bind candidate reading coverage to sources without claiming complete human appraisal.

Keep educational effectiveness and implementation outside the current delivery.
</commit_message>
<xml_diff>
--- a/results/tcc/presentation/ensino_personalizado_de_matematica_tcc.pptx
+++ b/results/tcc/presentation/ensino_personalizado_de_matematica_tcc.pptx
@@ -8587,7 +8587,7 @@
                 </a:solidFill>
                 <a:latin typeface="Arial"/>
               </a:rPr>
-              <a:t>15 empíricos provisórios. S1/S2: 14; Q1–Q5: 11. Estudos 5, 7 e 14 aguardam categoria; estudo 8 aguarda unidade. Um texto não recuperado, sem MMAT. Julgamentos de revisor único.</a:t>
+              <a:t>15 registros provisórios. S1/S2: 14; Q1–Q5: 11. Estudos 5, 7 e 14 aguardam categoria; estudo 8 aguarda unidade. Um texto não recuperado, sem MMAT. Conferência humana pendente.</a:t>
             </a:r>
           </a:p>
         </p:txBody>
@@ -14435,7 +14435,7 @@
                 </a:solidFill>
                 <a:latin typeface="Arial"/>
               </a:rPr>
-              <a:t>Propor um protocolo para avaliação futura dos aspectos técnicos e de adequação pedagógica.</a:t>
+              <a:t>Propor um protocolo para avaliar a viabilidade e a coerência da especificação conceitual; aplicação pendente.</a:t>
             </a:r>
           </a:p>
         </p:txBody>
@@ -14474,7 +14474,7 @@
                 </a:solidFill>
                 <a:latin typeface="Arial"/>
               </a:rPr>
-              <a:t>Revisão, MMAT preliminar e pipeline são meios metodológicos. Propor o protocolo não equivale a executá-lo nem comprova eficácia pedagógica.</a:t>
+              <a:t>Revisão, MMAT preliminar e pipeline são meios. O protocolo proposto avalia a especificação conceitual; aplicação pendente. Experimento do protótipo é contingência.</a:t>
             </a:r>
           </a:p>
         </p:txBody>

</xml_diff>

<commit_message>
:mag: fix(tcc): reconcile evidence and scientific presentation
Keep all corpus denominators and their generated consumers in one atomic review.

Align conceptual appraisal, source coverage, MMAT pending states, and cautious claims.

Restore readable canonical slides and distinguish the historical parallel artifacts.

Leave human reading and institutional decisions explicit; do not prepare speech.
</commit_message>
<xml_diff>
--- a/results/tcc/presentation/ensino_personalizado_de_matematica_tcc.pptx
+++ b/results/tcc/presentation/ensino_personalizado_de_matematica_tcc.pptx
@@ -5806,7 +5806,7 @@
                 <a:latin typeface="Arial"/>
               </a:rPr>
               <a:t>Instituto Federal Catarinense — Campus Videira
-Snapshot adjudicado: 03/09/2026 · recorte temporal: 2015–2026</a:t>
+Versão revisada: 15/10/2026 · corte da busca: 31/08/2026</a:t>
             </a:r>
           </a:p>
         </p:txBody>
@@ -5871,7 +5871,7 @@
                 </a:solidFill>
                 <a:latin typeface="Arial"/>
               </a:rPr>
-              <a:t>Panorama descritivo do snapshot</a:t>
+              <a:t>Panorama descritivo do recorte versionado</a:t>
             </a:r>
           </a:p>
         </p:txBody>
@@ -6715,8 +6715,8 @@
         </p:blipFill>
         <p:spPr>
           <a:xfrm>
-            <a:off x="548640" y="1275734"/>
-            <a:ext cx="5486400" cy="2203412"/>
+            <a:off x="548640" y="1276227"/>
+            <a:ext cx="5486400" cy="2202425"/>
           </a:xfrm>
           <a:prstGeom prst="rect">
             <a:avLst/>
@@ -6739,8 +6739,8 @@
         </p:blipFill>
         <p:spPr>
           <a:xfrm>
-            <a:off x="6172200" y="1230414"/>
-            <a:ext cx="5486400" cy="2294051"/>
+            <a:off x="7187460" y="1143000"/>
+            <a:ext cx="3455879" cy="2468880"/>
           </a:xfrm>
           <a:prstGeom prst="rect">
             <a:avLst/>
@@ -6906,7 +6906,7 @@
                 </a:solidFill>
                 <a:latin typeface="Arial"/>
               </a:rPr>
-              <a:t>O snapshot foi delimitado a 2015–2026, com data de corte em 31 de agosto de 2026. Como 2026 é parcial, sua barra não deve ser comparada diretamente com anos completos.</a:t>
+              <a:t>O recorte foi delimitado a 2015–2026, com data de corte em 31 de agosto de 2026. Como 2026 é parcial, sua barra não deve ser comparada diretamente com anos completos.</a:t>
             </a:r>
           </a:p>
         </p:txBody>
@@ -7174,7 +7174,7 @@
                 </a:solidFill>
                 <a:latin typeface="Arial"/>
               </a:rPr>
-              <a:t>População retida e síntese empírica</a:t>
+              <a:t>Conjunto retido e síntese empírica</a:t>
             </a:r>
           </a:p>
         </p:txBody>
@@ -7463,7 +7463,7 @@
                 </a:solidFill>
                 <a:latin typeface="Arial"/>
               </a:rPr>
-              <a:t>17</a:t>
+              <a:t>15</a:t>
             </a:r>
           </a:p>
         </p:txBody>
@@ -7502,7 +7502,7 @@
                 </a:solidFill>
                 <a:latin typeface="Arial"/>
               </a:rPr>
-              <a:t>candidatos empíricos provisórios</a:t>
+              <a:t>registros empíricos mantidos provisoriamente</a:t>
             </a:r>
           </a:p>
         </p:txBody>
@@ -7666,7 +7666,7 @@
                 </a:solidFill>
                 <a:latin typeface="Arial"/>
               </a:rPr>
-              <a:t>protocolo ou proposta contextual</a:t>
+              <a:t>texto integral pendente</a:t>
             </a:r>
           </a:p>
         </p:txBody>
@@ -7791,7 +7791,7 @@
                 </a:solidFill>
                 <a:latin typeface="Arial"/>
               </a:rPr>
-              <a:t>O que entra na síntese</a:t>
+              <a:t>Desfecho da seleção</a:t>
             </a:r>
           </a:p>
         </p:txBody>
@@ -7830,7 +7830,7 @@
                 </a:solidFill>
                 <a:latin typeface="Arial"/>
               </a:rPr>
-              <a:t>A síntese de evidências e a apreciação MMAT aplicável consideram os 17 candidatos empíricos. O protocolo/proposta contextual foi mantido para rastreabilidade do mapeamento, mas não sustenta resultado empírico concluído.</a:t>
+              <a:t>Dos 18 registros selecionados preliminarmente, um foi excluído após o resumo. Dos 17 relatórios procurados, um não foi recuperado e 16 foram avaliados em texto completo; um protocolo sem resultados concluídos foi excluído após essa avaliação e 15 registros empíricos permanecem provisoriamente no núcleo. O estudo 8 aguarda adjudicação de elegibilidade e unidade de análise; o relatório não recuperado não recebeu MMAT.</a:t>
             </a:r>
           </a:p>
         </p:txBody>
@@ -7955,7 +7955,7 @@
                 </a:solidFill>
                 <a:latin typeface="Arial"/>
               </a:rPr>
-              <a:t>Padrão observado</a:t>
+              <a:t>Exemplos observados</a:t>
             </a:r>
           </a:p>
         </p:txBody>
@@ -7994,7 +7994,7 @@
                 </a:solidFill>
                 <a:latin typeface="Arial"/>
               </a:rPr>
-              <a:t>Predomínio de aplicações voltadas à predição de desempenho e à estimativa de proficiência, com recorrência de modelos supervisionados como Random Forest, SVM, árvores de decisão e redes neurais.</a:t>
+              <a:t>Há classificação e predição de resultados matemáticos, com RF, SVM, árvores e redes neurais entre as alternativas examinadas. Categorias operacionais de desempenho não equivalem automaticamente a níveis de proficiência validados.</a:t>
             </a:r>
           </a:p>
         </p:txBody>
@@ -8581,13 +8581,13 @@
               </a:spcAft>
             </a:pPr>
             <a:r>
-              <a:rPr sz="1400" b="0">
+              <a:rPr sz="1300" b="0">
                 <a:solidFill>
                   <a:srgbClr val="232323"/>
                 </a:solidFill>
                 <a:latin typeface="Arial"/>
               </a:rPr>
-              <a:t>Apreciação preliminar por um único revisor: nove registros com texto primário revisado e oito com base em resumo/metadados.</a:t>
+              <a:t>15 registros provisórios. S1/S2: 14; Q1–Q5: 11. Estudos 5, 7 e 14 aguardam categoria; estudo 8 aguarda unidade. Um texto não recuperado, sem MMAT. Conferência humana pendente.</a:t>
             </a:r>
           </a:p>
         </p:txBody>
@@ -9019,7 +9019,7 @@
                 </a:solidFill>
                 <a:latin typeface="Arial"/>
               </a:rPr>
-              <a:t>A literatura oferece um mapa auditável de técnicas, finalidades e formas de avaliação aplicadas à educação matemática.</a:t>
+              <a:t>O recorte examinado oferece exemplos auditáveis de técnicas, finalidades e formas de avaliação aplicadas à educação matemática.</a:t>
             </a:r>
           </a:p>
         </p:txBody>
@@ -9615,7 +9615,7 @@
                 </a:solidFill>
                 <a:latin typeface="Arial"/>
               </a:rPr>
-              <a:t>Lacunas documentadas</a:t>
+              <a:t>Limitações localizadas nos estudos consultados</a:t>
             </a:r>
           </a:p>
         </p:txBody>
@@ -9628,8 +9628,8 @@
         </p:nvSpPr>
         <p:spPr>
           <a:xfrm>
-            <a:off x="685800" y="1143000"/>
-            <a:ext cx="3337560" cy="1417320"/>
+            <a:off x="685800" y="1097280"/>
+            <a:ext cx="5257800" cy="1737360"/>
           </a:xfrm>
           <a:prstGeom prst="rect">
             <a:avLst/>
@@ -9671,8 +9671,8 @@
         </p:nvSpPr>
         <p:spPr>
           <a:xfrm>
-            <a:off x="685800" y="1143000"/>
-            <a:ext cx="59436" cy="1417320"/>
+            <a:off x="685800" y="1097280"/>
+            <a:ext cx="59436" cy="1737360"/>
           </a:xfrm>
           <a:prstGeom prst="rect">
             <a:avLst/>
@@ -9714,8 +9714,8 @@
         </p:nvSpPr>
         <p:spPr>
           <a:xfrm>
-            <a:off x="868680" y="1197864"/>
-            <a:ext cx="3063240" cy="384048"/>
+            <a:off x="868680" y="1152144"/>
+            <a:ext cx="4983480" cy="384048"/>
           </a:xfrm>
           <a:prstGeom prst="rect">
             <a:avLst/>
@@ -9734,13 +9734,13 @@
               </a:spcAft>
             </a:pPr>
             <a:r>
-              <a:rPr sz="1500" b="1">
+              <a:rPr sz="1600" b="1">
                 <a:solidFill>
                   <a:srgbClr val="0F0F0F"/>
                 </a:solidFill>
                 <a:latin typeface="Arial"/>
               </a:rPr>
-              <a:t>Explicabilidade</a:t>
+              <a:t>He et al. (2025)</a:t>
             </a:r>
           </a:p>
         </p:txBody>
@@ -9753,8 +9753,8 @@
         </p:nvSpPr>
         <p:spPr>
           <a:xfrm>
-            <a:off x="868680" y="1600200"/>
-            <a:ext cx="3063240" cy="896113"/>
+            <a:off x="868680" y="1554480"/>
+            <a:ext cx="4983480" cy="1216153"/>
           </a:xfrm>
           <a:prstGeom prst="rect">
             <a:avLst/>
@@ -9773,13 +9773,13 @@
               </a:spcAft>
             </a:pPr>
             <a:r>
-              <a:rPr sz="1350" b="0">
+              <a:rPr sz="1300" b="0">
                 <a:solidFill>
                   <a:srgbClr val="232323"/>
                 </a:solidFill>
                 <a:latin typeface="Arial"/>
               </a:rPr>
-              <a:t>Pouca clareza sobre como as saídas chegam à interpretação pedagógica.</a:t>
+              <a:t>Oito turmas de 45 estudantes são descritas, mas a amostra declarada é n=90; docentes também se distribuem de modo desigual entre condições (pp. 1, 16, 31–35). Isso exige cautela com denominadores e possível confundimento.</a:t>
             </a:r>
           </a:p>
         </p:txBody>
@@ -9792,8 +9792,8 @@
         </p:nvSpPr>
         <p:spPr>
           <a:xfrm>
-            <a:off x="4434840" y="1143000"/>
-            <a:ext cx="3337560" cy="1417320"/>
+            <a:off x="6217920" y="1097280"/>
+            <a:ext cx="5257800" cy="1737360"/>
           </a:xfrm>
           <a:prstGeom prst="rect">
             <a:avLst/>
@@ -9835,8 +9835,8 @@
         </p:nvSpPr>
         <p:spPr>
           <a:xfrm>
-            <a:off x="4434840" y="1143000"/>
-            <a:ext cx="59436" cy="1417320"/>
+            <a:off x="6217920" y="1097280"/>
+            <a:ext cx="59436" cy="1737360"/>
           </a:xfrm>
           <a:prstGeom prst="rect">
             <a:avLst/>
@@ -9878,8 +9878,8 @@
         </p:nvSpPr>
         <p:spPr>
           <a:xfrm>
-            <a:off x="4617720" y="1197864"/>
-            <a:ext cx="3063240" cy="384048"/>
+            <a:off x="6400800" y="1152144"/>
+            <a:ext cx="4983480" cy="384048"/>
           </a:xfrm>
           <a:prstGeom prst="rect">
             <a:avLst/>
@@ -9898,13 +9898,13 @@
               </a:spcAft>
             </a:pPr>
             <a:r>
-              <a:rPr sz="1500" b="1">
+              <a:rPr sz="1600" b="1">
                 <a:solidFill>
                   <a:srgbClr val="0F0F0F"/>
                 </a:solidFill>
                 <a:latin typeface="Arial"/>
               </a:rPr>
-              <a:t>Currículo</a:t>
+              <a:t>Villegas-Ch et al. (2025)</a:t>
             </a:r>
           </a:p>
         </p:txBody>
@@ -9917,8 +9917,8 @@
         </p:nvSpPr>
         <p:spPr>
           <a:xfrm>
-            <a:off x="4617720" y="1600200"/>
-            <a:ext cx="3063240" cy="896113"/>
+            <a:off x="6400800" y="1554480"/>
+            <a:ext cx="4983480" cy="1216153"/>
           </a:xfrm>
           <a:prstGeom prst="rect">
             <a:avLst/>
@@ -9937,13 +9937,13 @@
               </a:spcAft>
             </a:pPr>
             <a:r>
-              <a:rPr sz="1350" b="0">
+              <a:rPr sz="1300" b="0">
                 <a:solidFill>
                   <a:srgbClr val="232323"/>
                 </a:solidFill>
                 <a:latin typeface="Arial"/>
               </a:rPr>
-              <a:t>Alinhamento explícito com referenciais curriculares aparece de forma limitada.</a:t>
+              <a:t>Os métodos descrevem seis semanas, mas a subanálise de programação reporta resultados na oitava, sem conciliação nos trechos consultados (pp. 14, 22). Não se deve impor duração única à síntese.</a:t>
             </a:r>
           </a:p>
         </p:txBody>
@@ -9956,8 +9956,8 @@
         </p:nvSpPr>
         <p:spPr>
           <a:xfrm>
-            <a:off x="8183879" y="1143000"/>
-            <a:ext cx="3337560" cy="1417320"/>
+            <a:off x="685800" y="3063239"/>
+            <a:ext cx="5257800" cy="1737360"/>
           </a:xfrm>
           <a:prstGeom prst="rect">
             <a:avLst/>
@@ -9999,8 +9999,8 @@
         </p:nvSpPr>
         <p:spPr>
           <a:xfrm>
-            <a:off x="8183879" y="1143000"/>
-            <a:ext cx="59436" cy="1417320"/>
+            <a:off x="685800" y="3063239"/>
+            <a:ext cx="59436" cy="1737360"/>
           </a:xfrm>
           <a:prstGeom prst="rect">
             <a:avLst/>
@@ -10042,8 +10042,8 @@
         </p:nvSpPr>
         <p:spPr>
           <a:xfrm>
-            <a:off x="8366759" y="1197864"/>
-            <a:ext cx="3063240" cy="384048"/>
+            <a:off x="868680" y="3118103"/>
+            <a:ext cx="4983480" cy="384048"/>
           </a:xfrm>
           <a:prstGeom prst="rect">
             <a:avLst/>
@@ -10062,13 +10062,13 @@
               </a:spcAft>
             </a:pPr>
             <a:r>
-              <a:rPr sz="1500" b="1">
+              <a:rPr sz="1600" b="1">
                 <a:solidFill>
                   <a:srgbClr val="0F0F0F"/>
                 </a:solidFill>
                 <a:latin typeface="Arial"/>
               </a:rPr>
-              <a:t>Participação docente</a:t>
+              <a:t>Nyantah et al. (2025)</a:t>
             </a:r>
           </a:p>
         </p:txBody>
@@ -10081,8 +10081,8 @@
         </p:nvSpPr>
         <p:spPr>
           <a:xfrm>
-            <a:off x="8366759" y="1600200"/>
-            <a:ext cx="3063240" cy="896113"/>
+            <a:off x="868680" y="3520439"/>
+            <a:ext cx="4983480" cy="1216153"/>
           </a:xfrm>
           <a:prstGeom prst="rect">
             <a:avLst/>
@@ -10101,13 +10101,13 @@
               </a:spcAft>
             </a:pPr>
             <a:r>
-              <a:rPr sz="1350" b="0">
+              <a:rPr sz="1300" b="0">
                 <a:solidFill>
                   <a:srgbClr val="232323"/>
                 </a:solidFill>
                 <a:latin typeface="Arial"/>
               </a:rPr>
-              <a:t>Decisões de projeto nem sempre incorporam o professor como intérprete.</a:t>
+              <a:t>A alocação é descrita de modo incompatível; há diferença no pré-teste e a intervenção combina animação e jigsaw (pp. 101–105). O resultado não deve ser atribuído à animação isoladamente.</a:t>
             </a:r>
           </a:p>
         </p:txBody>
@@ -10120,8 +10120,8 @@
         </p:nvSpPr>
         <p:spPr>
           <a:xfrm>
-            <a:off x="685800" y="2971800"/>
-            <a:ext cx="3337560" cy="1417320"/>
+            <a:off x="6217920" y="3063239"/>
+            <a:ext cx="5257800" cy="1737360"/>
           </a:xfrm>
           <a:prstGeom prst="rect">
             <a:avLst/>
@@ -10163,8 +10163,8 @@
         </p:nvSpPr>
         <p:spPr>
           <a:xfrm>
-            <a:off x="685800" y="2971800"/>
-            <a:ext cx="59436" cy="1417320"/>
+            <a:off x="6217920" y="3063239"/>
+            <a:ext cx="59436" cy="1737360"/>
           </a:xfrm>
           <a:prstGeom prst="rect">
             <a:avLst/>
@@ -10206,8 +10206,8 @@
         </p:nvSpPr>
         <p:spPr>
           <a:xfrm>
-            <a:off x="868680" y="3026664"/>
-            <a:ext cx="3063240" cy="384048"/>
+            <a:off x="6400800" y="3118103"/>
+            <a:ext cx="4983480" cy="384048"/>
           </a:xfrm>
           <a:prstGeom prst="rect">
             <a:avLst/>
@@ -10226,13 +10226,13 @@
               </a:spcAft>
             </a:pPr>
             <a:r>
-              <a:rPr sz="1500" b="1">
+              <a:rPr sz="1600" b="1">
                 <a:solidFill>
                   <a:srgbClr val="0F0F0F"/>
                 </a:solidFill>
                 <a:latin typeface="Arial"/>
               </a:rPr>
-              <a:t>Equidade</a:t>
+              <a:t>Echeveria et al. (2025)</a:t>
             </a:r>
           </a:p>
         </p:txBody>
@@ -10245,8 +10245,8 @@
         </p:nvSpPr>
         <p:spPr>
           <a:xfrm>
-            <a:off x="868680" y="3429000"/>
-            <a:ext cx="3063240" cy="896113"/>
+            <a:off x="6400800" y="3520439"/>
+            <a:ext cx="4983480" cy="1216153"/>
           </a:xfrm>
           <a:prstGeom prst="rect">
             <a:avLst/>
@@ -10265,113 +10265,27 @@
               </a:spcAft>
             </a:pPr>
             <a:r>
-              <a:rPr sz="1350" b="0">
+              <a:rPr sz="1300" b="0">
                 <a:solidFill>
                   <a:srgbClr val="232323"/>
                 </a:solidFill>
                 <a:latin typeface="Arial"/>
               </a:rPr>
-              <a:t>Análises de possíveis vieses e diferenças entre grupos são escassas.</a:t>
-            </a:r>
-          </a:p>
-        </p:txBody>
-      </p:sp>
-      <p:sp>
-        <p:nvSpPr>
-          <p:cNvPr id="19" name="Rectangle 18"/>
-          <p:cNvSpPr/>
-          <p:nvPr/>
-        </p:nvSpPr>
-        <p:spPr>
-          <a:xfrm>
-            <a:off x="4434840" y="2971800"/>
-            <a:ext cx="3337560" cy="1417320"/>
-          </a:xfrm>
-          <a:prstGeom prst="rect">
-            <a:avLst/>
-          </a:prstGeom>
-          <a:solidFill>
-            <a:srgbClr val="FFFFFF"/>
-          </a:solidFill>
-          <a:ln>
-            <a:noFill/>
-          </a:ln>
-        </p:spPr>
-        <p:style>
-          <a:lnRef idx="1">
-            <a:schemeClr val="accent1"/>
-          </a:lnRef>
-          <a:fillRef idx="3">
-            <a:schemeClr val="accent1"/>
-          </a:fillRef>
-          <a:effectRef idx="2">
-            <a:schemeClr val="accent1"/>
-          </a:effectRef>
-          <a:fontRef idx="minor">
-            <a:schemeClr val="lt1"/>
-          </a:fontRef>
-        </p:style>
-        <p:txBody>
-          <a:bodyPr rtlCol="0" anchor="ctr"/>
-          <a:lstStyle/>
-          <a:p>
-            <a:pPr algn="ctr"/>
-          </a:p>
-        </p:txBody>
-      </p:sp>
-      <p:sp>
-        <p:nvSpPr>
-          <p:cNvPr id="20" name="Rectangle 19"/>
-          <p:cNvSpPr/>
-          <p:nvPr/>
-        </p:nvSpPr>
-        <p:spPr>
-          <a:xfrm>
-            <a:off x="4434840" y="2971800"/>
-            <a:ext cx="59436" cy="1417320"/>
-          </a:xfrm>
-          <a:prstGeom prst="rect">
-            <a:avLst/>
-          </a:prstGeom>
-          <a:solidFill>
-            <a:srgbClr val="EA580C"/>
-          </a:solidFill>
-          <a:ln>
-            <a:noFill/>
-          </a:ln>
-        </p:spPr>
-        <p:style>
-          <a:lnRef idx="1">
-            <a:schemeClr val="accent1"/>
-          </a:lnRef>
-          <a:fillRef idx="3">
-            <a:schemeClr val="accent1"/>
-          </a:fillRef>
-          <a:effectRef idx="2">
-            <a:schemeClr val="accent1"/>
-          </a:effectRef>
-          <a:fontRef idx="minor">
-            <a:schemeClr val="lt1"/>
-          </a:fontRef>
-        </p:style>
-        <p:txBody>
-          <a:bodyPr rtlCol="0" anchor="ctr"/>
-          <a:lstStyle/>
-          <a:p>
-            <a:pPr algn="ctr"/>
-          </a:p>
-        </p:txBody>
-      </p:sp>
-      <p:sp>
-        <p:nvSpPr>
-          <p:cNvPr id="21" name="TextBox 20"/>
+              <a:t>Oito itens usados para formar categorias também aparecem entre os preditores selecionados (pp. 66, 69–70). A classificação não estabelece diagnóstico independente.</a:t>
+            </a:r>
+          </a:p>
+        </p:txBody>
+      </p:sp>
+      <p:sp>
+        <p:nvSpPr>
+          <p:cNvPr id="19" name="TextBox 18"/>
           <p:cNvSpPr txBox="1"/>
           <p:nvPr/>
         </p:nvSpPr>
         <p:spPr>
           <a:xfrm>
-            <a:off x="4617720" y="3026664"/>
-            <a:ext cx="3063240" cy="384048"/>
+            <a:off x="822960" y="5074920"/>
+            <a:ext cx="10561320" cy="640080"/>
           </a:xfrm>
           <a:prstGeom prst="rect">
             <a:avLst/>
@@ -10379,266 +10293,24 @@
           <a:noFill/>
         </p:spPr>
         <p:txBody>
-          <a:bodyPr wrap="square" lIns="54864" rIns="54864" tIns="54864" bIns="54864" anchor="t">
+          <a:bodyPr wrap="square" lIns="54864" rIns="54864" tIns="54864" bIns="54864" anchor="ctr">
             <a:spAutoFit/>
           </a:bodyPr>
           <a:lstStyle/>
           <a:p>
-            <a:pPr algn="l">
+            <a:pPr algn="ctr">
               <a:spcAft>
                 <a:spcPts val="0"/>
               </a:spcAft>
             </a:pPr>
             <a:r>
-              <a:rPr sz="1500" b="1">
-                <a:solidFill>
-                  <a:srgbClr val="0F0F0F"/>
+              <a:rPr sz="1250" b="0">
+                <a:solidFill>
+                  <a:srgbClr val="334155"/>
                 </a:solidFill>
                 <a:latin typeface="Arial"/>
               </a:rPr>
-              <a:t>Reprodutibilidade</a:t>
-            </a:r>
-          </a:p>
-        </p:txBody>
-      </p:sp>
-      <p:sp>
-        <p:nvSpPr>
-          <p:cNvPr id="22" name="TextBox 21"/>
-          <p:cNvSpPr txBox="1"/>
-          <p:nvPr/>
-        </p:nvSpPr>
-        <p:spPr>
-          <a:xfrm>
-            <a:off x="4617720" y="3429000"/>
-            <a:ext cx="3063240" cy="896113"/>
-          </a:xfrm>
-          <a:prstGeom prst="rect">
-            <a:avLst/>
-          </a:prstGeom>
-          <a:noFill/>
-        </p:spPr>
-        <p:txBody>
-          <a:bodyPr wrap="square" lIns="54864" rIns="54864" tIns="54864" bIns="54864" anchor="t">
-            <a:spAutoFit/>
-          </a:bodyPr>
-          <a:lstStyle/>
-          <a:p>
-            <a:pPr algn="l">
-              <a:spcAft>
-                <a:spcPts val="0"/>
-              </a:spcAft>
-            </a:pPr>
-            <a:r>
-              <a:rPr sz="1350" b="0">
-                <a:solidFill>
-                  <a:srgbClr val="232323"/>
-                </a:solidFill>
-                <a:latin typeface="Arial"/>
-              </a:rPr>
-              <a:t>Dados, códigos e detalhes de preparação nem sempre estão disponíveis.</a:t>
-            </a:r>
-          </a:p>
-        </p:txBody>
-      </p:sp>
-      <p:sp>
-        <p:nvSpPr>
-          <p:cNvPr id="23" name="Rectangle 22"/>
-          <p:cNvSpPr/>
-          <p:nvPr/>
-        </p:nvSpPr>
-        <p:spPr>
-          <a:xfrm>
-            <a:off x="8183879" y="2971800"/>
-            <a:ext cx="3337560" cy="1417320"/>
-          </a:xfrm>
-          <a:prstGeom prst="rect">
-            <a:avLst/>
-          </a:prstGeom>
-          <a:solidFill>
-            <a:srgbClr val="FFFFFF"/>
-          </a:solidFill>
-          <a:ln>
-            <a:noFill/>
-          </a:ln>
-        </p:spPr>
-        <p:style>
-          <a:lnRef idx="1">
-            <a:schemeClr val="accent1"/>
-          </a:lnRef>
-          <a:fillRef idx="3">
-            <a:schemeClr val="accent1"/>
-          </a:fillRef>
-          <a:effectRef idx="2">
-            <a:schemeClr val="accent1"/>
-          </a:effectRef>
-          <a:fontRef idx="minor">
-            <a:schemeClr val="lt1"/>
-          </a:fontRef>
-        </p:style>
-        <p:txBody>
-          <a:bodyPr rtlCol="0" anchor="ctr"/>
-          <a:lstStyle/>
-          <a:p>
-            <a:pPr algn="ctr"/>
-          </a:p>
-        </p:txBody>
-      </p:sp>
-      <p:sp>
-        <p:nvSpPr>
-          <p:cNvPr id="24" name="Rectangle 23"/>
-          <p:cNvSpPr/>
-          <p:nvPr/>
-        </p:nvSpPr>
-        <p:spPr>
-          <a:xfrm>
-            <a:off x="8183879" y="2971800"/>
-            <a:ext cx="59436" cy="1417320"/>
-          </a:xfrm>
-          <a:prstGeom prst="rect">
-            <a:avLst/>
-          </a:prstGeom>
-          <a:solidFill>
-            <a:srgbClr val="4F46E5"/>
-          </a:solidFill>
-          <a:ln>
-            <a:noFill/>
-          </a:ln>
-        </p:spPr>
-        <p:style>
-          <a:lnRef idx="1">
-            <a:schemeClr val="accent1"/>
-          </a:lnRef>
-          <a:fillRef idx="3">
-            <a:schemeClr val="accent1"/>
-          </a:fillRef>
-          <a:effectRef idx="2">
-            <a:schemeClr val="accent1"/>
-          </a:effectRef>
-          <a:fontRef idx="minor">
-            <a:schemeClr val="lt1"/>
-          </a:fontRef>
-        </p:style>
-        <p:txBody>
-          <a:bodyPr rtlCol="0" anchor="ctr"/>
-          <a:lstStyle/>
-          <a:p>
-            <a:pPr algn="ctr"/>
-          </a:p>
-        </p:txBody>
-      </p:sp>
-      <p:sp>
-        <p:nvSpPr>
-          <p:cNvPr id="25" name="TextBox 24"/>
-          <p:cNvSpPr txBox="1"/>
-          <p:nvPr/>
-        </p:nvSpPr>
-        <p:spPr>
-          <a:xfrm>
-            <a:off x="8366759" y="3026664"/>
-            <a:ext cx="3063240" cy="384048"/>
-          </a:xfrm>
-          <a:prstGeom prst="rect">
-            <a:avLst/>
-          </a:prstGeom>
-          <a:noFill/>
-        </p:spPr>
-        <p:txBody>
-          <a:bodyPr wrap="square" lIns="54864" rIns="54864" tIns="54864" bIns="54864" anchor="t">
-            <a:spAutoFit/>
-          </a:bodyPr>
-          <a:lstStyle/>
-          <a:p>
-            <a:pPr algn="l">
-              <a:spcAft>
-                <a:spcPts val="0"/>
-              </a:spcAft>
-            </a:pPr>
-            <a:r>
-              <a:rPr sz="1500" b="1">
-                <a:solidFill>
-                  <a:srgbClr val="0F0F0F"/>
-                </a:solidFill>
-                <a:latin typeface="Arial"/>
-              </a:rPr>
-              <a:t>Contexto</a:t>
-            </a:r>
-          </a:p>
-        </p:txBody>
-      </p:sp>
-      <p:sp>
-        <p:nvSpPr>
-          <p:cNvPr id="26" name="TextBox 25"/>
-          <p:cNvSpPr txBox="1"/>
-          <p:nvPr/>
-        </p:nvSpPr>
-        <p:spPr>
-          <a:xfrm>
-            <a:off x="8366759" y="3429000"/>
-            <a:ext cx="3063240" cy="896113"/>
-          </a:xfrm>
-          <a:prstGeom prst="rect">
-            <a:avLst/>
-          </a:prstGeom>
-          <a:noFill/>
-        </p:spPr>
-        <p:txBody>
-          <a:bodyPr wrap="square" lIns="54864" rIns="54864" tIns="54864" bIns="54864" anchor="t">
-            <a:spAutoFit/>
-          </a:bodyPr>
-          <a:lstStyle/>
-          <a:p>
-            <a:pPr algn="l">
-              <a:spcAft>
-                <a:spcPts val="0"/>
-              </a:spcAft>
-            </a:pPr>
-            <a:r>
-              <a:rPr sz="1350" b="0">
-                <a:solidFill>
-                  <a:srgbClr val="232323"/>
-                </a:solidFill>
-                <a:latin typeface="Arial"/>
-              </a:rPr>
-              <a:t>Validações permanecem restritas a populações e cenários específicos.</a:t>
-            </a:r>
-          </a:p>
-        </p:txBody>
-      </p:sp>
-      <p:sp>
-        <p:nvSpPr>
-          <p:cNvPr id="27" name="TextBox 26"/>
-          <p:cNvSpPr txBox="1"/>
-          <p:nvPr/>
-        </p:nvSpPr>
-        <p:spPr>
-          <a:xfrm>
-            <a:off x="914400" y="5806440"/>
-            <a:ext cx="10241280" cy="292608"/>
-          </a:xfrm>
-          <a:prstGeom prst="rect">
-            <a:avLst/>
-          </a:prstGeom>
-          <a:noFill/>
-        </p:spPr>
-        <p:txBody>
-          <a:bodyPr wrap="square" lIns="54864" rIns="54864" tIns="54864" bIns="54864" anchor="t">
-            <a:spAutoFit/>
-          </a:bodyPr>
-          <a:lstStyle/>
-          <a:p>
-            <a:pPr algn="ctr">
-              <a:spcAft>
-                <a:spcPts val="0"/>
-              </a:spcAft>
-            </a:pPr>
-            <a:r>
-              <a:rPr sz="1400" b="0">
-                <a:solidFill>
-                  <a:srgbClr val="64748B"/>
-                </a:solidFill>
-                <a:latin typeface="Arial"/>
-              </a:rPr>
-              <a:t>Essas lacunas foram tratadas como requisitos de projeto — não como prova de que uma solução futura será eficaz.</a:t>
+              <a:t>Estes exemplos localizados não estimam a frequência da literatura. Quinze registros permanecem provisoriamente no núcleo; há 14 triagens S1/S2 e 11 apreciações por categoria, e o estudo 8 segue sem respostas até adjudicação da unidade. Um relatório não recuperado não recebeu MMAT; um registro foi excluído após resumo e um protocolo após texto completo.</a:t>
             </a:r>
           </a:p>
         </p:txBody>
@@ -12568,9 +12240,9 @@
                 <a:latin typeface="Arial"/>
               </a:rPr>
               <a:t>• um único pesquisador
-• parte da apreciação baseada em resumo/metadados
+• um texto integral pendente, sem MMAT
 • fontes e idiomas delimitados
-• MMAT preliminar
+• MMAT: 14 triagens, 11 apreciações por categoria; estudo 8 sem avaliação
 • sem aplicação funcional ou eficácia pedagógica própria</a:t>
             </a:r>
           </a:p>
@@ -12876,7 +12548,7 @@
                 <a:latin typeface="Arial"/>
               </a:rPr>
               <a:t>Thales Ferreira Batista · Ciência da Computação · IFC Videira
-Snapshot adjudicado: 03/09/2026 · recorte temporal: 2015–2026</a:t>
+Versão revisada: 15/10/2026 · corte da busca: 31/08/2026</a:t>
             </a:r>
           </a:p>
         </p:txBody>
@@ -13740,7 +13412,7 @@
                 </a:solidFill>
                 <a:latin typeface="Arial"/>
               </a:rPr>
-              <a:t>Como identificar e sintetizar, por meio de revisão sistemática, as principais técnicas computacionais aplicadas ao ensino de matemática e converter essas evidências em uma especificação de protótipo que apoie o professor?</a:t>
+              <a:t>Como estruturar uma especificação técnica e pedagógica de protótipo para apoiar a interpretação docente da aprendizagem matemática a partir das evidências e técnicas computacionais identificadas na literatura?</a:t>
             </a:r>
           </a:p>
         </p:txBody>
@@ -13904,7 +13576,7 @@
                 </a:solidFill>
                 <a:latin typeface="Arial"/>
               </a:rPr>
-              <a:t>Mapear e analisar sistematicamente as aplicações e elaborar uma especificação técnica e pedagógica para apoiar a interpretação de evidências sobre competências.</a:t>
+              <a:t>Propor uma especificação técnica e pedagógica de protótipo para apoiar a interpretação docente da aprendizagem matemática, fundamentada no mapeamento e na análise da literatura científica.</a:t>
             </a:r>
           </a:p>
         </p:txBody>
@@ -14120,8 +13792,8 @@
         </p:nvSpPr>
         <p:spPr>
           <a:xfrm>
-            <a:off x="685800" y="1143000"/>
-            <a:ext cx="5166360" cy="868680"/>
+            <a:off x="685800" y="1325880"/>
+            <a:ext cx="5166360" cy="1645920"/>
           </a:xfrm>
           <a:prstGeom prst="rect">
             <a:avLst/>
@@ -14163,8 +13835,8 @@
         </p:nvSpPr>
         <p:spPr>
           <a:xfrm>
-            <a:off x="685800" y="1143000"/>
-            <a:ext cx="59436" cy="868680"/>
+            <a:off x="685800" y="1325880"/>
+            <a:ext cx="59436" cy="1645920"/>
           </a:xfrm>
           <a:prstGeom prst="rect">
             <a:avLst/>
@@ -14206,7 +13878,7 @@
         </p:nvSpPr>
         <p:spPr>
           <a:xfrm>
-            <a:off x="868680" y="1197864"/>
+            <a:off x="868680" y="1380744"/>
             <a:ext cx="4892040" cy="384048"/>
           </a:xfrm>
           <a:prstGeom prst="rect">
@@ -14226,7 +13898,7 @@
               </a:spcAft>
             </a:pPr>
             <a:r>
-              <a:rPr sz="1500" b="1">
+              <a:rPr sz="1900" b="1">
                 <a:solidFill>
                   <a:srgbClr val="0F0F0F"/>
                 </a:solidFill>
@@ -14245,8 +13917,8 @@
         </p:nvSpPr>
         <p:spPr>
           <a:xfrm>
-            <a:off x="868680" y="1600200"/>
-            <a:ext cx="4892040" cy="347473"/>
+            <a:off x="868680" y="1783080"/>
+            <a:ext cx="4892040" cy="1124713"/>
           </a:xfrm>
           <a:prstGeom prst="rect">
             <a:avLst/>
@@ -14265,13 +13937,13 @@
               </a:spcAft>
             </a:pPr>
             <a:r>
-              <a:rPr sz="1350" b="0">
+              <a:rPr sz="1800" b="0">
                 <a:solidFill>
                   <a:srgbClr val="232323"/>
                 </a:solidFill>
                 <a:latin typeface="Arial"/>
               </a:rPr>
-              <a:t>Revisão sistemática, relatada com apoio do PRISMA 2020, sobre estudos de 2015–2026.</a:t>
+              <a:t>Categorizar técnicas computacionais e finalidades pedagógicas na literatura mapeada.</a:t>
             </a:r>
           </a:p>
         </p:txBody>
@@ -14284,8 +13956,8 @@
         </p:nvSpPr>
         <p:spPr>
           <a:xfrm>
-            <a:off x="685800" y="2286000"/>
-            <a:ext cx="5166360" cy="868680"/>
+            <a:off x="685800" y="3337560"/>
+            <a:ext cx="5166360" cy="1645920"/>
           </a:xfrm>
           <a:prstGeom prst="rect">
             <a:avLst/>
@@ -14327,8 +13999,8 @@
         </p:nvSpPr>
         <p:spPr>
           <a:xfrm>
-            <a:off x="685800" y="2286000"/>
-            <a:ext cx="59436" cy="868680"/>
+            <a:off x="685800" y="3337560"/>
+            <a:ext cx="59436" cy="1645920"/>
           </a:xfrm>
           <a:prstGeom prst="rect">
             <a:avLst/>
@@ -14370,7 +14042,7 @@
         </p:nvSpPr>
         <p:spPr>
           <a:xfrm>
-            <a:off x="868680" y="2340864"/>
+            <a:off x="868680" y="3392424"/>
             <a:ext cx="4892040" cy="384048"/>
           </a:xfrm>
           <a:prstGeom prst="rect">
@@ -14390,7 +14062,7 @@
               </a:spcAft>
             </a:pPr>
             <a:r>
-              <a:rPr sz="1500" b="1">
+              <a:rPr sz="1900" b="1">
                 <a:solidFill>
                   <a:srgbClr val="0F0F0F"/>
                 </a:solidFill>
@@ -14409,8 +14081,8 @@
         </p:nvSpPr>
         <p:spPr>
           <a:xfrm>
-            <a:off x="868680" y="2743200"/>
-            <a:ext cx="4892040" cy="347473"/>
+            <a:off x="868680" y="3794760"/>
+            <a:ext cx="4892040" cy="1124713"/>
           </a:xfrm>
           <a:prstGeom prst="rect">
             <a:avLst/>
@@ -14429,13 +14101,13 @@
               </a:spcAft>
             </a:pPr>
             <a:r>
-              <a:rPr sz="1350" b="0">
+              <a:rPr sz="1800" b="0">
                 <a:solidFill>
                   <a:srgbClr val="232323"/>
                 </a:solidFill>
                 <a:latin typeface="Arial"/>
               </a:rPr>
-              <a:t>Identificação e categorização das abordagens computacionais.</a:t>
+              <a:t>Identificar limitações e lacunas técnicas, pedagógicas, metodológicas e éticas.</a:t>
             </a:r>
           </a:p>
         </p:txBody>
@@ -14448,8 +14120,8 @@
         </p:nvSpPr>
         <p:spPr>
           <a:xfrm>
-            <a:off x="685800" y="3429000"/>
-            <a:ext cx="5166360" cy="868680"/>
+            <a:off x="6309360" y="1325880"/>
+            <a:ext cx="5166360" cy="1645920"/>
           </a:xfrm>
           <a:prstGeom prst="rect">
             <a:avLst/>
@@ -14491,14 +14163,14 @@
         </p:nvSpPr>
         <p:spPr>
           <a:xfrm>
-            <a:off x="685800" y="3429000"/>
-            <a:ext cx="59436" cy="868680"/>
-          </a:xfrm>
-          <a:prstGeom prst="rect">
-            <a:avLst/>
-          </a:prstGeom>
-          <a:solidFill>
-            <a:srgbClr val="2563EB"/>
+            <a:off x="6309360" y="1325880"/>
+            <a:ext cx="59436" cy="1645920"/>
+          </a:xfrm>
+          <a:prstGeom prst="rect">
+            <a:avLst/>
+          </a:prstGeom>
+          <a:solidFill>
+            <a:srgbClr val="0D9488"/>
           </a:solidFill>
           <a:ln>
             <a:noFill/>
@@ -14534,7 +14206,7 @@
         </p:nvSpPr>
         <p:spPr>
           <a:xfrm>
-            <a:off x="868680" y="3483864"/>
+            <a:off x="6492240" y="1380744"/>
             <a:ext cx="4892040" cy="384048"/>
           </a:xfrm>
           <a:prstGeom prst="rect">
@@ -14554,7 +14226,7 @@
               </a:spcAft>
             </a:pPr>
             <a:r>
-              <a:rPr sz="1500" b="1">
+              <a:rPr sz="1900" b="1">
                 <a:solidFill>
                   <a:srgbClr val="0F0F0F"/>
                 </a:solidFill>
@@ -14573,8 +14245,8 @@
         </p:nvSpPr>
         <p:spPr>
           <a:xfrm>
-            <a:off x="868680" y="3886200"/>
-            <a:ext cx="4892040" cy="347473"/>
+            <a:off x="6492240" y="1783080"/>
+            <a:ext cx="4892040" cy="1124713"/>
           </a:xfrm>
           <a:prstGeom prst="rect">
             <a:avLst/>
@@ -14593,13 +14265,13 @@
               </a:spcAft>
             </a:pPr>
             <a:r>
-              <a:rPr sz="1350" b="0">
+              <a:rPr sz="1800" b="0">
                 <a:solidFill>
                   <a:srgbClr val="232323"/>
                 </a:solidFill>
                 <a:latin typeface="Arial"/>
               </a:rPr>
-              <a:t>Classificação das finalidades pedagógicas das aplicações.</a:t>
+              <a:t>Formular requisitos, critérios de dados e modelos e arquitetura de referência para o protótipo.</a:t>
             </a:r>
           </a:p>
         </p:txBody>
@@ -14612,8 +14284,8 @@
         </p:nvSpPr>
         <p:spPr>
           <a:xfrm>
-            <a:off x="685800" y="4572000"/>
-            <a:ext cx="5166360" cy="868680"/>
+            <a:off x="6309360" y="3337560"/>
+            <a:ext cx="5166360" cy="1645920"/>
           </a:xfrm>
           <a:prstGeom prst="rect">
             <a:avLst/>
@@ -14655,14 +14327,14 @@
         </p:nvSpPr>
         <p:spPr>
           <a:xfrm>
-            <a:off x="685800" y="4572000"/>
-            <a:ext cx="59436" cy="868680"/>
-          </a:xfrm>
-          <a:prstGeom prst="rect">
-            <a:avLst/>
-          </a:prstGeom>
-          <a:solidFill>
-            <a:srgbClr val="2563EB"/>
+            <a:off x="6309360" y="3337560"/>
+            <a:ext cx="59436" cy="1645920"/>
+          </a:xfrm>
+          <a:prstGeom prst="rect">
+            <a:avLst/>
+          </a:prstGeom>
+          <a:solidFill>
+            <a:srgbClr val="0D9488"/>
           </a:solidFill>
           <a:ln>
             <a:noFill/>
@@ -14698,7 +14370,7 @@
         </p:nvSpPr>
         <p:spPr>
           <a:xfrm>
-            <a:off x="868680" y="4626864"/>
+            <a:off x="6492240" y="3392424"/>
             <a:ext cx="4892040" cy="384048"/>
           </a:xfrm>
           <a:prstGeom prst="rect">
@@ -14718,7 +14390,7 @@
               </a:spcAft>
             </a:pPr>
             <a:r>
-              <a:rPr sz="1500" b="1">
+              <a:rPr sz="1900" b="1">
                 <a:solidFill>
                   <a:srgbClr val="0F0F0F"/>
                 </a:solidFill>
@@ -14737,8 +14409,8 @@
         </p:nvSpPr>
         <p:spPr>
           <a:xfrm>
-            <a:off x="868680" y="5029200"/>
-            <a:ext cx="4892040" cy="347473"/>
+            <a:off x="6492240" y="3794760"/>
+            <a:ext cx="4892040" cy="1124713"/>
           </a:xfrm>
           <a:prstGeom prst="rect">
             <a:avLst/>
@@ -14757,113 +14429,27 @@
               </a:spcAft>
             </a:pPr>
             <a:r>
-              <a:rPr sz="1350" b="0">
+              <a:rPr sz="1800" b="0">
                 <a:solidFill>
                   <a:srgbClr val="232323"/>
                 </a:solidFill>
                 <a:latin typeface="Arial"/>
               </a:rPr>
-              <a:t>Análise crítica das metodologias e limitações dos estudos.</a:t>
-            </a:r>
-          </a:p>
-        </p:txBody>
-      </p:sp>
-      <p:sp>
-        <p:nvSpPr>
-          <p:cNvPr id="19" name="Rectangle 18"/>
-          <p:cNvSpPr/>
-          <p:nvPr/>
-        </p:nvSpPr>
-        <p:spPr>
-          <a:xfrm>
-            <a:off x="6309360" y="1143000"/>
-            <a:ext cx="5166360" cy="1143000"/>
-          </a:xfrm>
-          <a:prstGeom prst="rect">
-            <a:avLst/>
-          </a:prstGeom>
-          <a:solidFill>
-            <a:srgbClr val="FFFFFF"/>
-          </a:solidFill>
-          <a:ln>
-            <a:noFill/>
-          </a:ln>
-        </p:spPr>
-        <p:style>
-          <a:lnRef idx="1">
-            <a:schemeClr val="accent1"/>
-          </a:lnRef>
-          <a:fillRef idx="3">
-            <a:schemeClr val="accent1"/>
-          </a:fillRef>
-          <a:effectRef idx="2">
-            <a:schemeClr val="accent1"/>
-          </a:effectRef>
-          <a:fontRef idx="minor">
-            <a:schemeClr val="lt1"/>
-          </a:fontRef>
-        </p:style>
-        <p:txBody>
-          <a:bodyPr rtlCol="0" anchor="ctr"/>
-          <a:lstStyle/>
-          <a:p>
-            <a:pPr algn="ctr"/>
-          </a:p>
-        </p:txBody>
-      </p:sp>
-      <p:sp>
-        <p:nvSpPr>
-          <p:cNvPr id="20" name="Rectangle 19"/>
-          <p:cNvSpPr/>
-          <p:nvPr/>
-        </p:nvSpPr>
-        <p:spPr>
-          <a:xfrm>
-            <a:off x="6309360" y="1143000"/>
-            <a:ext cx="59436" cy="1143000"/>
-          </a:xfrm>
-          <a:prstGeom prst="rect">
-            <a:avLst/>
-          </a:prstGeom>
-          <a:solidFill>
-            <a:srgbClr val="0D9488"/>
-          </a:solidFill>
-          <a:ln>
-            <a:noFill/>
-          </a:ln>
-        </p:spPr>
-        <p:style>
-          <a:lnRef idx="1">
-            <a:schemeClr val="accent1"/>
-          </a:lnRef>
-          <a:fillRef idx="3">
-            <a:schemeClr val="accent1"/>
-          </a:fillRef>
-          <a:effectRef idx="2">
-            <a:schemeClr val="accent1"/>
-          </a:effectRef>
-          <a:fontRef idx="minor">
-            <a:schemeClr val="lt1"/>
-          </a:fontRef>
-        </p:style>
-        <p:txBody>
-          <a:bodyPr rtlCol="0" anchor="ctr"/>
-          <a:lstStyle/>
-          <a:p>
-            <a:pPr algn="ctr"/>
-          </a:p>
-        </p:txBody>
-      </p:sp>
-      <p:sp>
-        <p:nvSpPr>
-          <p:cNvPr id="21" name="TextBox 20"/>
+              <a:t>Propor um protocolo para avaliar a viabilidade e a coerência da especificação conceitual; aplicação pendente.</a:t>
+            </a:r>
+          </a:p>
+        </p:txBody>
+      </p:sp>
+      <p:sp>
+        <p:nvSpPr>
+          <p:cNvPr id="19" name="TextBox 18"/>
           <p:cNvSpPr txBox="1"/>
           <p:nvPr/>
         </p:nvSpPr>
         <p:spPr>
           <a:xfrm>
-            <a:off x="6492240" y="1197864"/>
-            <a:ext cx="4892040" cy="384048"/>
+            <a:off x="914400" y="5669280"/>
+            <a:ext cx="10287000" cy="594360"/>
           </a:xfrm>
           <a:prstGeom prst="rect">
             <a:avLst/>
@@ -14876,425 +14462,19 @@
           </a:bodyPr>
           <a:lstStyle/>
           <a:p>
-            <a:pPr algn="l">
+            <a:pPr algn="ctr">
               <a:spcAft>
                 <a:spcPts val="0"/>
               </a:spcAft>
             </a:pPr>
             <a:r>
-              <a:rPr sz="1500" b="1">
-                <a:solidFill>
-                  <a:srgbClr val="0F0F0F"/>
+              <a:rPr sz="1400" b="0">
+                <a:solidFill>
+                  <a:srgbClr val="64748B"/>
                 </a:solidFill>
                 <a:latin typeface="Arial"/>
               </a:rPr>
-              <a:t>OE5</a:t>
-            </a:r>
-          </a:p>
-        </p:txBody>
-      </p:sp>
-      <p:sp>
-        <p:nvSpPr>
-          <p:cNvPr id="22" name="TextBox 21"/>
-          <p:cNvSpPr txBox="1"/>
-          <p:nvPr/>
-        </p:nvSpPr>
-        <p:spPr>
-          <a:xfrm>
-            <a:off x="6492240" y="1600200"/>
-            <a:ext cx="4892040" cy="621793"/>
-          </a:xfrm>
-          <a:prstGeom prst="rect">
-            <a:avLst/>
-          </a:prstGeom>
-          <a:noFill/>
-        </p:spPr>
-        <p:txBody>
-          <a:bodyPr wrap="square" lIns="54864" rIns="54864" tIns="54864" bIns="54864" anchor="t">
-            <a:spAutoFit/>
-          </a:bodyPr>
-          <a:lstStyle/>
-          <a:p>
-            <a:pPr algn="l">
-              <a:spcAft>
-                <a:spcPts val="0"/>
-              </a:spcAft>
-            </a:pPr>
-            <a:r>
-              <a:rPr sz="1350" b="0">
-                <a:solidFill>
-                  <a:srgbClr val="232323"/>
-                </a:solidFill>
-                <a:latin typeface="Arial"/>
-              </a:rPr>
-              <a:t>Mapeamento de lacunas técnicas, pedagógicas, metodológicas e éticas.</a:t>
-            </a:r>
-          </a:p>
-        </p:txBody>
-      </p:sp>
-      <p:sp>
-        <p:nvSpPr>
-          <p:cNvPr id="23" name="Rectangle 22"/>
-          <p:cNvSpPr/>
-          <p:nvPr/>
-        </p:nvSpPr>
-        <p:spPr>
-          <a:xfrm>
-            <a:off x="6309360" y="2560320"/>
-            <a:ext cx="5166360" cy="1143000"/>
-          </a:xfrm>
-          <a:prstGeom prst="rect">
-            <a:avLst/>
-          </a:prstGeom>
-          <a:solidFill>
-            <a:srgbClr val="FFFFFF"/>
-          </a:solidFill>
-          <a:ln>
-            <a:noFill/>
-          </a:ln>
-        </p:spPr>
-        <p:style>
-          <a:lnRef idx="1">
-            <a:schemeClr val="accent1"/>
-          </a:lnRef>
-          <a:fillRef idx="3">
-            <a:schemeClr val="accent1"/>
-          </a:fillRef>
-          <a:effectRef idx="2">
-            <a:schemeClr val="accent1"/>
-          </a:effectRef>
-          <a:fontRef idx="minor">
-            <a:schemeClr val="lt1"/>
-          </a:fontRef>
-        </p:style>
-        <p:txBody>
-          <a:bodyPr rtlCol="0" anchor="ctr"/>
-          <a:lstStyle/>
-          <a:p>
-            <a:pPr algn="ctr"/>
-          </a:p>
-        </p:txBody>
-      </p:sp>
-      <p:sp>
-        <p:nvSpPr>
-          <p:cNvPr id="24" name="Rectangle 23"/>
-          <p:cNvSpPr/>
-          <p:nvPr/>
-        </p:nvSpPr>
-        <p:spPr>
-          <a:xfrm>
-            <a:off x="6309360" y="2560320"/>
-            <a:ext cx="59436" cy="1143000"/>
-          </a:xfrm>
-          <a:prstGeom prst="rect">
-            <a:avLst/>
-          </a:prstGeom>
-          <a:solidFill>
-            <a:srgbClr val="0D9488"/>
-          </a:solidFill>
-          <a:ln>
-            <a:noFill/>
-          </a:ln>
-        </p:spPr>
-        <p:style>
-          <a:lnRef idx="1">
-            <a:schemeClr val="accent1"/>
-          </a:lnRef>
-          <a:fillRef idx="3">
-            <a:schemeClr val="accent1"/>
-          </a:fillRef>
-          <a:effectRef idx="2">
-            <a:schemeClr val="accent1"/>
-          </a:effectRef>
-          <a:fontRef idx="minor">
-            <a:schemeClr val="lt1"/>
-          </a:fontRef>
-        </p:style>
-        <p:txBody>
-          <a:bodyPr rtlCol="0" anchor="ctr"/>
-          <a:lstStyle/>
-          <a:p>
-            <a:pPr algn="ctr"/>
-          </a:p>
-        </p:txBody>
-      </p:sp>
-      <p:sp>
-        <p:nvSpPr>
-          <p:cNvPr id="25" name="TextBox 24"/>
-          <p:cNvSpPr txBox="1"/>
-          <p:nvPr/>
-        </p:nvSpPr>
-        <p:spPr>
-          <a:xfrm>
-            <a:off x="6492240" y="2615184"/>
-            <a:ext cx="4892040" cy="384048"/>
-          </a:xfrm>
-          <a:prstGeom prst="rect">
-            <a:avLst/>
-          </a:prstGeom>
-          <a:noFill/>
-        </p:spPr>
-        <p:txBody>
-          <a:bodyPr wrap="square" lIns="54864" rIns="54864" tIns="54864" bIns="54864" anchor="t">
-            <a:spAutoFit/>
-          </a:bodyPr>
-          <a:lstStyle/>
-          <a:p>
-            <a:pPr algn="l">
-              <a:spcAft>
-                <a:spcPts val="0"/>
-              </a:spcAft>
-            </a:pPr>
-            <a:r>
-              <a:rPr sz="1500" b="1">
-                <a:solidFill>
-                  <a:srgbClr val="0F0F0F"/>
-                </a:solidFill>
-                <a:latin typeface="Arial"/>
-              </a:rPr>
-              <a:t>OE6</a:t>
-            </a:r>
-          </a:p>
-        </p:txBody>
-      </p:sp>
-      <p:sp>
-        <p:nvSpPr>
-          <p:cNvPr id="26" name="TextBox 25"/>
-          <p:cNvSpPr txBox="1"/>
-          <p:nvPr/>
-        </p:nvSpPr>
-        <p:spPr>
-          <a:xfrm>
-            <a:off x="6492240" y="3017520"/>
-            <a:ext cx="4892040" cy="621793"/>
-          </a:xfrm>
-          <a:prstGeom prst="rect">
-            <a:avLst/>
-          </a:prstGeom>
-          <a:noFill/>
-        </p:spPr>
-        <p:txBody>
-          <a:bodyPr wrap="square" lIns="54864" rIns="54864" tIns="54864" bIns="54864" anchor="t">
-            <a:spAutoFit/>
-          </a:bodyPr>
-          <a:lstStyle/>
-          <a:p>
-            <a:pPr algn="l">
-              <a:spcAft>
-                <a:spcPts val="0"/>
-              </a:spcAft>
-            </a:pPr>
-            <a:r>
-              <a:rPr sz="1350" b="0">
-                <a:solidFill>
-                  <a:srgbClr val="232323"/>
-                </a:solidFill>
-                <a:latin typeface="Arial"/>
-              </a:rPr>
-              <a:t>Manutenção de um pipeline automatizado e auditável para coleta, processamento e exportação.</a:t>
-            </a:r>
-          </a:p>
-        </p:txBody>
-      </p:sp>
-      <p:sp>
-        <p:nvSpPr>
-          <p:cNvPr id="27" name="Rectangle 26"/>
-          <p:cNvSpPr/>
-          <p:nvPr/>
-        </p:nvSpPr>
-        <p:spPr>
-          <a:xfrm>
-            <a:off x="6309360" y="3977639"/>
-            <a:ext cx="5166360" cy="1143000"/>
-          </a:xfrm>
-          <a:prstGeom prst="rect">
-            <a:avLst/>
-          </a:prstGeom>
-          <a:solidFill>
-            <a:srgbClr val="FFFFFF"/>
-          </a:solidFill>
-          <a:ln>
-            <a:noFill/>
-          </a:ln>
-        </p:spPr>
-        <p:style>
-          <a:lnRef idx="1">
-            <a:schemeClr val="accent1"/>
-          </a:lnRef>
-          <a:fillRef idx="3">
-            <a:schemeClr val="accent1"/>
-          </a:fillRef>
-          <a:effectRef idx="2">
-            <a:schemeClr val="accent1"/>
-          </a:effectRef>
-          <a:fontRef idx="minor">
-            <a:schemeClr val="lt1"/>
-          </a:fontRef>
-        </p:style>
-        <p:txBody>
-          <a:bodyPr rtlCol="0" anchor="ctr"/>
-          <a:lstStyle/>
-          <a:p>
-            <a:pPr algn="ctr"/>
-          </a:p>
-        </p:txBody>
-      </p:sp>
-      <p:sp>
-        <p:nvSpPr>
-          <p:cNvPr id="28" name="Rectangle 27"/>
-          <p:cNvSpPr/>
-          <p:nvPr/>
-        </p:nvSpPr>
-        <p:spPr>
-          <a:xfrm>
-            <a:off x="6309360" y="3977639"/>
-            <a:ext cx="59436" cy="1143000"/>
-          </a:xfrm>
-          <a:prstGeom prst="rect">
-            <a:avLst/>
-          </a:prstGeom>
-          <a:solidFill>
-            <a:srgbClr val="0D9488"/>
-          </a:solidFill>
-          <a:ln>
-            <a:noFill/>
-          </a:ln>
-        </p:spPr>
-        <p:style>
-          <a:lnRef idx="1">
-            <a:schemeClr val="accent1"/>
-          </a:lnRef>
-          <a:fillRef idx="3">
-            <a:schemeClr val="accent1"/>
-          </a:fillRef>
-          <a:effectRef idx="2">
-            <a:schemeClr val="accent1"/>
-          </a:effectRef>
-          <a:fontRef idx="minor">
-            <a:schemeClr val="lt1"/>
-          </a:fontRef>
-        </p:style>
-        <p:txBody>
-          <a:bodyPr rtlCol="0" anchor="ctr"/>
-          <a:lstStyle/>
-          <a:p>
-            <a:pPr algn="ctr"/>
-          </a:p>
-        </p:txBody>
-      </p:sp>
-      <p:sp>
-        <p:nvSpPr>
-          <p:cNvPr id="29" name="TextBox 28"/>
-          <p:cNvSpPr txBox="1"/>
-          <p:nvPr/>
-        </p:nvSpPr>
-        <p:spPr>
-          <a:xfrm>
-            <a:off x="6492240" y="4032503"/>
-            <a:ext cx="4892040" cy="384048"/>
-          </a:xfrm>
-          <a:prstGeom prst="rect">
-            <a:avLst/>
-          </a:prstGeom>
-          <a:noFill/>
-        </p:spPr>
-        <p:txBody>
-          <a:bodyPr wrap="square" lIns="54864" rIns="54864" tIns="54864" bIns="54864" anchor="t">
-            <a:spAutoFit/>
-          </a:bodyPr>
-          <a:lstStyle/>
-          <a:p>
-            <a:pPr algn="l">
-              <a:spcAft>
-                <a:spcPts val="0"/>
-              </a:spcAft>
-            </a:pPr>
-            <a:r>
-              <a:rPr sz="1500" b="1">
-                <a:solidFill>
-                  <a:srgbClr val="0F0F0F"/>
-                </a:solidFill>
-                <a:latin typeface="Arial"/>
-              </a:rPr>
-              <a:t>OE7</a:t>
-            </a:r>
-          </a:p>
-        </p:txBody>
-      </p:sp>
-      <p:sp>
-        <p:nvSpPr>
-          <p:cNvPr id="30" name="TextBox 29"/>
-          <p:cNvSpPr txBox="1"/>
-          <p:nvPr/>
-        </p:nvSpPr>
-        <p:spPr>
-          <a:xfrm>
-            <a:off x="6492240" y="4434839"/>
-            <a:ext cx="4892040" cy="621793"/>
-          </a:xfrm>
-          <a:prstGeom prst="rect">
-            <a:avLst/>
-          </a:prstGeom>
-          <a:noFill/>
-        </p:spPr>
-        <p:txBody>
-          <a:bodyPr wrap="square" lIns="54864" rIns="54864" tIns="54864" bIns="54864" anchor="t">
-            <a:spAutoFit/>
-          </a:bodyPr>
-          <a:lstStyle/>
-          <a:p>
-            <a:pPr algn="l">
-              <a:spcAft>
-                <a:spcPts val="0"/>
-              </a:spcAft>
-            </a:pPr>
-            <a:r>
-              <a:rPr sz="1350" b="0">
-                <a:solidFill>
-                  <a:srgbClr val="232323"/>
-                </a:solidFill>
-                <a:latin typeface="Arial"/>
-              </a:rPr>
-              <a:t>Derivação de requisitos, critérios de dados e modelos, protocolo de avaliação e arquitetura de referência.</a:t>
-            </a:r>
-          </a:p>
-        </p:txBody>
-      </p:sp>
-      <p:sp>
-        <p:nvSpPr>
-          <p:cNvPr id="31" name="TextBox 30"/>
-          <p:cNvSpPr txBox="1"/>
-          <p:nvPr/>
-        </p:nvSpPr>
-        <p:spPr>
-          <a:xfrm>
-            <a:off x="914400" y="5897880"/>
-            <a:ext cx="10287000" cy="384048"/>
-          </a:xfrm>
-          <a:prstGeom prst="rect">
-            <a:avLst/>
-          </a:prstGeom>
-          <a:noFill/>
-        </p:spPr>
-        <p:txBody>
-          <a:bodyPr wrap="square" lIns="54864" rIns="54864" tIns="54864" bIns="54864" anchor="t">
-            <a:spAutoFit/>
-          </a:bodyPr>
-          <a:lstStyle/>
-          <a:p>
-            <a:pPr algn="ctr">
-              <a:spcAft>
-                <a:spcPts val="0"/>
-              </a:spcAft>
-            </a:pPr>
-            <a:r>
-              <a:rPr sz="1400" b="0">
-                <a:solidFill>
-                  <a:srgbClr val="64748B"/>
-                </a:solidFill>
-                <a:latin typeface="Arial"/>
-              </a:rPr>
-              <a:t>A apresentação distingue objetivos executados de atividades que permanecem fora do escopo, como implementação funcional e validação com participantes.</a:t>
+              <a:t>Revisão, MMAT preliminar e pipeline são meios. O protocolo proposto avalia a especificação conceitual; aplicação pendente. Experimento do protótipo é contingência.</a:t>
             </a:r>
           </a:p>
         </p:txBody>
@@ -15892,7 +15072,7 @@
                 </a:solidFill>
                 <a:latin typeface="Arial"/>
               </a:rPr>
-              <a:t>Mobilização integrada de conhecimentos, procedimentos, estratégias e atitudes.</a:t>
+              <a:t>Mobilização de conhecimentos, habilidades, atitudes e valores para resolver demandas.</a:t>
             </a:r>
           </a:p>
         </p:txBody>
@@ -16056,7 +15236,7 @@
                 </a:solidFill>
                 <a:latin typeface="Arial"/>
               </a:rPr>
-              <a:t>Transformação construída ao longo do tempo, com compreensão, autonomia e transferência.</a:t>
+              <a:t>Neste TCC: mudanças no que o estudante sabe e consegue fazer ao longo do tempo.</a:t>
             </a:r>
           </a:p>
         </p:txBody>
@@ -17084,7 +16264,7 @@
                 </a:solidFill>
                 <a:latin typeface="Arial"/>
               </a:rPr>
-              <a:t>Do registro bruto à população retida</a:t>
+              <a:t>Do registro bruto ao conjunto retido provisoriamente</a:t>
             </a:r>
           </a:p>
         </p:txBody>
@@ -17123,7 +16303,7 @@
                 </a:solidFill>
                 <a:latin typeface="Arial"/>
               </a:rPr>
-              <a:t>Contagens do snapshot adjudicado</a:t>
+              <a:t>Contagens do recorte versionado</a:t>
             </a:r>
           </a:p>
         </p:txBody>
@@ -17944,7 +17124,7 @@
                 </a:solidFill>
                 <a:latin typeface="Arial"/>
               </a:rPr>
-              <a:t>na elegibilidade</a:t>
+              <a:t>submetidos à priorização</a:t>
             </a:r>
           </a:p>
         </p:txBody>
@@ -18108,7 +17288,7 @@
                 </a:solidFill>
                 <a:latin typeface="Arial"/>
               </a:rPr>
-              <a:t>excluídos na elegibilidade</a:t>
+              <a:t>excluídos nessa etapa</a:t>
             </a:r>
           </a:p>
         </p:txBody>
@@ -18285,8 +17465,8 @@
         </p:nvSpPr>
         <p:spPr>
           <a:xfrm>
-            <a:off x="1005840" y="5669280"/>
-            <a:ext cx="10058400" cy="320040"/>
+            <a:off x="777240" y="5623560"/>
+            <a:ext cx="10607040" cy="411480"/>
           </a:xfrm>
           <a:prstGeom prst="rect">
             <a:avLst/>
@@ -18305,13 +17485,13 @@
               </a:spcAft>
             </a:pPr>
             <a:r>
-              <a:rPr sz="1400" b="0">
+              <a:rPr sz="1150" b="0">
                 <a:solidFill>
                   <a:srgbClr val="64748B"/>
                 </a:solidFill>
                 <a:latin typeface="Arial"/>
               </a:rPr>
-              <a:t>A remoção determinística por DOI/URL precede a triagem. Igualdade de título permaneceu como candidato à auditoria semântica.</a:t>
+              <a:t>A priorização dos 2.486 registros usa metadados/resumos e não equivale à elegibilidade em texto completo; títulos repetidos seguem para auditoria semântica.</a:t>
             </a:r>
           </a:p>
         </p:txBody>
@@ -18376,7 +17556,7 @@
                 </a:solidFill>
                 <a:latin typeface="Arial"/>
               </a:rPr>
-              <a:t>Fluxo PRISMA do snapshot</a:t>
+              <a:t>Fluxo operacional do processo de seleção</a:t>
             </a:r>
           </a:p>
         </p:txBody>
@@ -18397,8 +17577,8 @@
         </p:blipFill>
         <p:spPr>
           <a:xfrm>
-            <a:off x="2359571" y="960120"/>
-            <a:ext cx="7488097" cy="5212080"/>
+            <a:off x="1470660" y="960120"/>
+            <a:ext cx="9265920" cy="5212080"/>
           </a:xfrm>
           <a:prstGeom prst="rect">
             <a:avLst/>
@@ -18439,7 +17619,7 @@
                 </a:solidFill>
                 <a:latin typeface="Arial"/>
               </a:rPr>
-              <a:t>Figura versionada e sincronizada com os artefatos públicos do pipeline.</a:t>
+              <a:t>Representação operacional própria; não reproduz todas as etapas do diagrama PRISMA 2020.</a:t>
             </a:r>
           </a:p>
         </p:txBody>
@@ -18525,8 +17705,8 @@
         </p:blipFill>
         <p:spPr>
           <a:xfrm>
-            <a:off x="640080" y="1649878"/>
-            <a:ext cx="5623560" cy="3741123"/>
+            <a:off x="640080" y="1650666"/>
+            <a:ext cx="5623560" cy="3739548"/>
           </a:xfrm>
           <a:prstGeom prst="rect">
             <a:avLst/>

</xml_diff>

<commit_message>
:lipstick: feat(presentation): align slides with thesis text
</commit_message>
<xml_diff>
--- a/results/tcc/presentation/ensino_personalizado_de_matematica_tcc.pptx
+++ b/results/tcc/presentation/ensino_personalizado_de_matematica_tcc.pptx
@@ -5806,7 +5806,7 @@
                 <a:latin typeface="Arial"/>
               </a:rPr>
               <a:t>Instituto Federal Catarinense — Campus Videira
-Snapshot adjudicado: 03/09/2026 · recorte temporal: 2015–2026</a:t>
+Versão revisada: 15/10/2026 · corte da busca: 31/08/2026</a:t>
             </a:r>
           </a:p>
         </p:txBody>
@@ -5871,7 +5871,7 @@
                 </a:solidFill>
                 <a:latin typeface="Arial"/>
               </a:rPr>
-              <a:t>Panorama descritivo do snapshot</a:t>
+              <a:t>Panorama descritivo do recorte versionado</a:t>
             </a:r>
           </a:p>
         </p:txBody>
@@ -6715,8 +6715,8 @@
         </p:blipFill>
         <p:spPr>
           <a:xfrm>
-            <a:off x="548640" y="1275734"/>
-            <a:ext cx="5486400" cy="2203412"/>
+            <a:off x="548640" y="1276227"/>
+            <a:ext cx="5486400" cy="2202425"/>
           </a:xfrm>
           <a:prstGeom prst="rect">
             <a:avLst/>
@@ -6739,8 +6739,8 @@
         </p:blipFill>
         <p:spPr>
           <a:xfrm>
-            <a:off x="6172200" y="1230414"/>
-            <a:ext cx="5486400" cy="2294051"/>
+            <a:off x="7187460" y="1143000"/>
+            <a:ext cx="3455879" cy="2468880"/>
           </a:xfrm>
           <a:prstGeom prst="rect">
             <a:avLst/>
@@ -6906,7 +6906,7 @@
                 </a:solidFill>
                 <a:latin typeface="Arial"/>
               </a:rPr>
-              <a:t>O snapshot foi delimitado a 2015–2026, com data de corte em 31 de agosto de 2026. Como 2026 é parcial, sua barra não deve ser comparada diretamente com anos completos.</a:t>
+              <a:t>O recorte foi delimitado a 2015–2026, com data de corte em 31 de agosto de 2026. Como 2026 é parcial, sua barra não deve ser comparada diretamente com anos completos.</a:t>
             </a:r>
           </a:p>
         </p:txBody>
@@ -7174,7 +7174,7 @@
                 </a:solidFill>
                 <a:latin typeface="Arial"/>
               </a:rPr>
-              <a:t>População retida e síntese empírica</a:t>
+              <a:t>Conjunto retido e síntese empírica</a:t>
             </a:r>
           </a:p>
         </p:txBody>
@@ -7463,7 +7463,7 @@
                 </a:solidFill>
                 <a:latin typeface="Arial"/>
               </a:rPr>
-              <a:t>17</a:t>
+              <a:t>15</a:t>
             </a:r>
           </a:p>
         </p:txBody>
@@ -7502,7 +7502,7 @@
                 </a:solidFill>
                 <a:latin typeface="Arial"/>
               </a:rPr>
-              <a:t>candidatos empíricos provisórios</a:t>
+              <a:t>registros empíricos mantidos provisoriamente</a:t>
             </a:r>
           </a:p>
         </p:txBody>
@@ -7666,7 +7666,7 @@
                 </a:solidFill>
                 <a:latin typeface="Arial"/>
               </a:rPr>
-              <a:t>protocolo ou proposta contextual</a:t>
+              <a:t>texto integral pendente</a:t>
             </a:r>
           </a:p>
         </p:txBody>
@@ -7791,7 +7791,7 @@
                 </a:solidFill>
                 <a:latin typeface="Arial"/>
               </a:rPr>
-              <a:t>O que entra na síntese</a:t>
+              <a:t>Desfecho da seleção</a:t>
             </a:r>
           </a:p>
         </p:txBody>
@@ -7830,7 +7830,7 @@
                 </a:solidFill>
                 <a:latin typeface="Arial"/>
               </a:rPr>
-              <a:t>A síntese de evidências e a apreciação MMAT aplicável consideram os 17 candidatos empíricos. O protocolo/proposta contextual foi mantido para rastreabilidade do mapeamento, mas não sustenta resultado empírico concluído.</a:t>
+              <a:t>Dos 18 registros selecionados preliminarmente, um foi excluído após o resumo. Dos 17 relatórios procurados, um não foi recuperado e 16 foram avaliados em texto completo; um protocolo sem resultados concluídos foi excluído após essa avaliação e 15 registros empíricos permanecem provisoriamente no núcleo. O estudo 8 aguarda adjudicação de elegibilidade e unidade de análise; o relatório não recuperado não recebeu MMAT.</a:t>
             </a:r>
           </a:p>
         </p:txBody>
@@ -7955,7 +7955,7 @@
                 </a:solidFill>
                 <a:latin typeface="Arial"/>
               </a:rPr>
-              <a:t>Padrão observado</a:t>
+              <a:t>Exemplos observados</a:t>
             </a:r>
           </a:p>
         </p:txBody>
@@ -7994,7 +7994,7 @@
                 </a:solidFill>
                 <a:latin typeface="Arial"/>
               </a:rPr>
-              <a:t>Predomínio de aplicações voltadas à predição de desempenho e à estimativa de proficiência, com recorrência de modelos supervisionados como Random Forest, SVM, árvores de decisão e redes neurais.</a:t>
+              <a:t>Há classificação e predição de resultados matemáticos, com RF, SVM, árvores e redes neurais entre as alternativas examinadas. Categorias operacionais de desempenho não equivalem automaticamente a níveis de proficiência validados.</a:t>
             </a:r>
           </a:p>
         </p:txBody>
@@ -8581,13 +8581,13 @@
               </a:spcAft>
             </a:pPr>
             <a:r>
-              <a:rPr sz="1400" b="0">
+              <a:rPr sz="1300" b="0">
                 <a:solidFill>
                   <a:srgbClr val="232323"/>
                 </a:solidFill>
                 <a:latin typeface="Arial"/>
               </a:rPr>
-              <a:t>Apreciação preliminar por um único revisor: nove registros com texto primário revisado e oito com base em resumo/metadados.</a:t>
+              <a:t>15 registros provisórios. S1/S2: 14; Q1–Q5: 11. Estudos 5, 7 e 14 aguardam categoria; estudo 8 aguarda unidade. Um texto não recuperado, sem MMAT. Conferência humana pendente.</a:t>
             </a:r>
           </a:p>
         </p:txBody>
@@ -9019,7 +9019,7 @@
                 </a:solidFill>
                 <a:latin typeface="Arial"/>
               </a:rPr>
-              <a:t>A literatura oferece um mapa auditável de técnicas, finalidades e formas de avaliação aplicadas à educação matemática.</a:t>
+              <a:t>O recorte examinado oferece exemplos auditáveis de técnicas, finalidades e formas de avaliação aplicadas à educação matemática.</a:t>
             </a:r>
           </a:p>
         </p:txBody>
@@ -9615,7 +9615,7 @@
                 </a:solidFill>
                 <a:latin typeface="Arial"/>
               </a:rPr>
-              <a:t>Lacunas documentadas</a:t>
+              <a:t>Limitações localizadas nos estudos consultados</a:t>
             </a:r>
           </a:p>
         </p:txBody>
@@ -9628,8 +9628,8 @@
         </p:nvSpPr>
         <p:spPr>
           <a:xfrm>
-            <a:off x="685800" y="1143000"/>
-            <a:ext cx="3337560" cy="1417320"/>
+            <a:off x="685800" y="1097280"/>
+            <a:ext cx="5257800" cy="1737360"/>
           </a:xfrm>
           <a:prstGeom prst="rect">
             <a:avLst/>
@@ -9671,8 +9671,8 @@
         </p:nvSpPr>
         <p:spPr>
           <a:xfrm>
-            <a:off x="685800" y="1143000"/>
-            <a:ext cx="59436" cy="1417320"/>
+            <a:off x="685800" y="1097280"/>
+            <a:ext cx="59436" cy="1737360"/>
           </a:xfrm>
           <a:prstGeom prst="rect">
             <a:avLst/>
@@ -9714,8 +9714,8 @@
         </p:nvSpPr>
         <p:spPr>
           <a:xfrm>
-            <a:off x="868680" y="1197864"/>
-            <a:ext cx="3063240" cy="384048"/>
+            <a:off x="868680" y="1152144"/>
+            <a:ext cx="4983480" cy="384048"/>
           </a:xfrm>
           <a:prstGeom prst="rect">
             <a:avLst/>
@@ -9734,13 +9734,13 @@
               </a:spcAft>
             </a:pPr>
             <a:r>
-              <a:rPr sz="1500" b="1">
+              <a:rPr sz="1600" b="1">
                 <a:solidFill>
                   <a:srgbClr val="0F0F0F"/>
                 </a:solidFill>
                 <a:latin typeface="Arial"/>
               </a:rPr>
-              <a:t>Explicabilidade</a:t>
+              <a:t>He et al. (2025)</a:t>
             </a:r>
           </a:p>
         </p:txBody>
@@ -9753,8 +9753,8 @@
         </p:nvSpPr>
         <p:spPr>
           <a:xfrm>
-            <a:off x="868680" y="1600200"/>
-            <a:ext cx="3063240" cy="896113"/>
+            <a:off x="868680" y="1554480"/>
+            <a:ext cx="4983480" cy="1216153"/>
           </a:xfrm>
           <a:prstGeom prst="rect">
             <a:avLst/>
@@ -9773,13 +9773,13 @@
               </a:spcAft>
             </a:pPr>
             <a:r>
-              <a:rPr sz="1350" b="0">
+              <a:rPr sz="1300" b="0">
                 <a:solidFill>
                   <a:srgbClr val="232323"/>
                 </a:solidFill>
                 <a:latin typeface="Arial"/>
               </a:rPr>
-              <a:t>Pouca clareza sobre como as saídas chegam à interpretação pedagógica.</a:t>
+              <a:t>Oito turmas de 45 estudantes são descritas, mas a amostra declarada é n=90; docentes também se distribuem de modo desigual entre condições (pp. 1, 16, 31–35). Isso exige cautela com denominadores e possível confundimento.</a:t>
             </a:r>
           </a:p>
         </p:txBody>
@@ -9792,8 +9792,8 @@
         </p:nvSpPr>
         <p:spPr>
           <a:xfrm>
-            <a:off x="4434840" y="1143000"/>
-            <a:ext cx="3337560" cy="1417320"/>
+            <a:off x="6217920" y="1097280"/>
+            <a:ext cx="5257800" cy="1737360"/>
           </a:xfrm>
           <a:prstGeom prst="rect">
             <a:avLst/>
@@ -9835,8 +9835,8 @@
         </p:nvSpPr>
         <p:spPr>
           <a:xfrm>
-            <a:off x="4434840" y="1143000"/>
-            <a:ext cx="59436" cy="1417320"/>
+            <a:off x="6217920" y="1097280"/>
+            <a:ext cx="59436" cy="1737360"/>
           </a:xfrm>
           <a:prstGeom prst="rect">
             <a:avLst/>
@@ -9878,8 +9878,8 @@
         </p:nvSpPr>
         <p:spPr>
           <a:xfrm>
-            <a:off x="4617720" y="1197864"/>
-            <a:ext cx="3063240" cy="384048"/>
+            <a:off x="6400800" y="1152144"/>
+            <a:ext cx="4983480" cy="384048"/>
           </a:xfrm>
           <a:prstGeom prst="rect">
             <a:avLst/>
@@ -9898,13 +9898,13 @@
               </a:spcAft>
             </a:pPr>
             <a:r>
-              <a:rPr sz="1500" b="1">
+              <a:rPr sz="1600" b="1">
                 <a:solidFill>
                   <a:srgbClr val="0F0F0F"/>
                 </a:solidFill>
                 <a:latin typeface="Arial"/>
               </a:rPr>
-              <a:t>Currículo</a:t>
+              <a:t>Villegas-Ch et al. (2025)</a:t>
             </a:r>
           </a:p>
         </p:txBody>
@@ -9917,8 +9917,8 @@
         </p:nvSpPr>
         <p:spPr>
           <a:xfrm>
-            <a:off x="4617720" y="1600200"/>
-            <a:ext cx="3063240" cy="896113"/>
+            <a:off x="6400800" y="1554480"/>
+            <a:ext cx="4983480" cy="1216153"/>
           </a:xfrm>
           <a:prstGeom prst="rect">
             <a:avLst/>
@@ -9937,13 +9937,13 @@
               </a:spcAft>
             </a:pPr>
             <a:r>
-              <a:rPr sz="1350" b="0">
+              <a:rPr sz="1300" b="0">
                 <a:solidFill>
                   <a:srgbClr val="232323"/>
                 </a:solidFill>
                 <a:latin typeface="Arial"/>
               </a:rPr>
-              <a:t>Alinhamento explícito com referenciais curriculares aparece de forma limitada.</a:t>
+              <a:t>Os métodos descrevem seis semanas, mas a subanálise de programação reporta resultados na oitava, sem conciliação nos trechos consultados (pp. 14, 22). Não se deve impor duração única à síntese.</a:t>
             </a:r>
           </a:p>
         </p:txBody>
@@ -9956,8 +9956,8 @@
         </p:nvSpPr>
         <p:spPr>
           <a:xfrm>
-            <a:off x="8183879" y="1143000"/>
-            <a:ext cx="3337560" cy="1417320"/>
+            <a:off x="685800" y="3063239"/>
+            <a:ext cx="5257800" cy="1737360"/>
           </a:xfrm>
           <a:prstGeom prst="rect">
             <a:avLst/>
@@ -9999,8 +9999,8 @@
         </p:nvSpPr>
         <p:spPr>
           <a:xfrm>
-            <a:off x="8183879" y="1143000"/>
-            <a:ext cx="59436" cy="1417320"/>
+            <a:off x="685800" y="3063239"/>
+            <a:ext cx="59436" cy="1737360"/>
           </a:xfrm>
           <a:prstGeom prst="rect">
             <a:avLst/>
@@ -10042,8 +10042,8 @@
         </p:nvSpPr>
         <p:spPr>
           <a:xfrm>
-            <a:off x="8366759" y="1197864"/>
-            <a:ext cx="3063240" cy="384048"/>
+            <a:off x="868680" y="3118103"/>
+            <a:ext cx="4983480" cy="384048"/>
           </a:xfrm>
           <a:prstGeom prst="rect">
             <a:avLst/>
@@ -10062,13 +10062,13 @@
               </a:spcAft>
             </a:pPr>
             <a:r>
-              <a:rPr sz="1500" b="1">
+              <a:rPr sz="1600" b="1">
                 <a:solidFill>
                   <a:srgbClr val="0F0F0F"/>
                 </a:solidFill>
                 <a:latin typeface="Arial"/>
               </a:rPr>
-              <a:t>Participação docente</a:t>
+              <a:t>Nyantah et al. (2025)</a:t>
             </a:r>
           </a:p>
         </p:txBody>
@@ -10081,8 +10081,8 @@
         </p:nvSpPr>
         <p:spPr>
           <a:xfrm>
-            <a:off x="8366759" y="1600200"/>
-            <a:ext cx="3063240" cy="896113"/>
+            <a:off x="868680" y="3520439"/>
+            <a:ext cx="4983480" cy="1216153"/>
           </a:xfrm>
           <a:prstGeom prst="rect">
             <a:avLst/>
@@ -10101,13 +10101,13 @@
               </a:spcAft>
             </a:pPr>
             <a:r>
-              <a:rPr sz="1350" b="0">
+              <a:rPr sz="1300" b="0">
                 <a:solidFill>
                   <a:srgbClr val="232323"/>
                 </a:solidFill>
                 <a:latin typeface="Arial"/>
               </a:rPr>
-              <a:t>Decisões de projeto nem sempre incorporam o professor como intérprete.</a:t>
+              <a:t>A alocação é descrita de modo incompatível; há diferença no pré-teste e a intervenção combina animação e jigsaw (pp. 101–105). O resultado não deve ser atribuído à animação isoladamente.</a:t>
             </a:r>
           </a:p>
         </p:txBody>
@@ -10120,8 +10120,8 @@
         </p:nvSpPr>
         <p:spPr>
           <a:xfrm>
-            <a:off x="685800" y="2971800"/>
-            <a:ext cx="3337560" cy="1417320"/>
+            <a:off x="6217920" y="3063239"/>
+            <a:ext cx="5257800" cy="1737360"/>
           </a:xfrm>
           <a:prstGeom prst="rect">
             <a:avLst/>
@@ -10163,8 +10163,8 @@
         </p:nvSpPr>
         <p:spPr>
           <a:xfrm>
-            <a:off x="685800" y="2971800"/>
-            <a:ext cx="59436" cy="1417320"/>
+            <a:off x="6217920" y="3063239"/>
+            <a:ext cx="59436" cy="1737360"/>
           </a:xfrm>
           <a:prstGeom prst="rect">
             <a:avLst/>
@@ -10206,8 +10206,8 @@
         </p:nvSpPr>
         <p:spPr>
           <a:xfrm>
-            <a:off x="868680" y="3026664"/>
-            <a:ext cx="3063240" cy="384048"/>
+            <a:off x="6400800" y="3118103"/>
+            <a:ext cx="4983480" cy="384048"/>
           </a:xfrm>
           <a:prstGeom prst="rect">
             <a:avLst/>
@@ -10226,13 +10226,13 @@
               </a:spcAft>
             </a:pPr>
             <a:r>
-              <a:rPr sz="1500" b="1">
+              <a:rPr sz="1600" b="1">
                 <a:solidFill>
                   <a:srgbClr val="0F0F0F"/>
                 </a:solidFill>
                 <a:latin typeface="Arial"/>
               </a:rPr>
-              <a:t>Equidade</a:t>
+              <a:t>Echeveria et al. (2025)</a:t>
             </a:r>
           </a:p>
         </p:txBody>
@@ -10245,8 +10245,8 @@
         </p:nvSpPr>
         <p:spPr>
           <a:xfrm>
-            <a:off x="868680" y="3429000"/>
-            <a:ext cx="3063240" cy="896113"/>
+            <a:off x="6400800" y="3520439"/>
+            <a:ext cx="4983480" cy="1216153"/>
           </a:xfrm>
           <a:prstGeom prst="rect">
             <a:avLst/>
@@ -10265,113 +10265,27 @@
               </a:spcAft>
             </a:pPr>
             <a:r>
-              <a:rPr sz="1350" b="0">
+              <a:rPr sz="1300" b="0">
                 <a:solidFill>
                   <a:srgbClr val="232323"/>
                 </a:solidFill>
                 <a:latin typeface="Arial"/>
               </a:rPr>
-              <a:t>Análises de possíveis vieses e diferenças entre grupos são escassas.</a:t>
-            </a:r>
-          </a:p>
-        </p:txBody>
-      </p:sp>
-      <p:sp>
-        <p:nvSpPr>
-          <p:cNvPr id="19" name="Rectangle 18"/>
-          <p:cNvSpPr/>
-          <p:nvPr/>
-        </p:nvSpPr>
-        <p:spPr>
-          <a:xfrm>
-            <a:off x="4434840" y="2971800"/>
-            <a:ext cx="3337560" cy="1417320"/>
-          </a:xfrm>
-          <a:prstGeom prst="rect">
-            <a:avLst/>
-          </a:prstGeom>
-          <a:solidFill>
-            <a:srgbClr val="FFFFFF"/>
-          </a:solidFill>
-          <a:ln>
-            <a:noFill/>
-          </a:ln>
-        </p:spPr>
-        <p:style>
-          <a:lnRef idx="1">
-            <a:schemeClr val="accent1"/>
-          </a:lnRef>
-          <a:fillRef idx="3">
-            <a:schemeClr val="accent1"/>
-          </a:fillRef>
-          <a:effectRef idx="2">
-            <a:schemeClr val="accent1"/>
-          </a:effectRef>
-          <a:fontRef idx="minor">
-            <a:schemeClr val="lt1"/>
-          </a:fontRef>
-        </p:style>
-        <p:txBody>
-          <a:bodyPr rtlCol="0" anchor="ctr"/>
-          <a:lstStyle/>
-          <a:p>
-            <a:pPr algn="ctr"/>
-          </a:p>
-        </p:txBody>
-      </p:sp>
-      <p:sp>
-        <p:nvSpPr>
-          <p:cNvPr id="20" name="Rectangle 19"/>
-          <p:cNvSpPr/>
-          <p:nvPr/>
-        </p:nvSpPr>
-        <p:spPr>
-          <a:xfrm>
-            <a:off x="4434840" y="2971800"/>
-            <a:ext cx="59436" cy="1417320"/>
-          </a:xfrm>
-          <a:prstGeom prst="rect">
-            <a:avLst/>
-          </a:prstGeom>
-          <a:solidFill>
-            <a:srgbClr val="EA580C"/>
-          </a:solidFill>
-          <a:ln>
-            <a:noFill/>
-          </a:ln>
-        </p:spPr>
-        <p:style>
-          <a:lnRef idx="1">
-            <a:schemeClr val="accent1"/>
-          </a:lnRef>
-          <a:fillRef idx="3">
-            <a:schemeClr val="accent1"/>
-          </a:fillRef>
-          <a:effectRef idx="2">
-            <a:schemeClr val="accent1"/>
-          </a:effectRef>
-          <a:fontRef idx="minor">
-            <a:schemeClr val="lt1"/>
-          </a:fontRef>
-        </p:style>
-        <p:txBody>
-          <a:bodyPr rtlCol="0" anchor="ctr"/>
-          <a:lstStyle/>
-          <a:p>
-            <a:pPr algn="ctr"/>
-          </a:p>
-        </p:txBody>
-      </p:sp>
-      <p:sp>
-        <p:nvSpPr>
-          <p:cNvPr id="21" name="TextBox 20"/>
+              <a:t>Oito itens usados para formar categorias também aparecem entre os preditores selecionados (pp. 66, 69–70). A classificação não estabelece diagnóstico independente.</a:t>
+            </a:r>
+          </a:p>
+        </p:txBody>
+      </p:sp>
+      <p:sp>
+        <p:nvSpPr>
+          <p:cNvPr id="19" name="TextBox 18"/>
           <p:cNvSpPr txBox="1"/>
           <p:nvPr/>
         </p:nvSpPr>
         <p:spPr>
           <a:xfrm>
-            <a:off x="4617720" y="3026664"/>
-            <a:ext cx="3063240" cy="384048"/>
+            <a:off x="822960" y="5074920"/>
+            <a:ext cx="10561320" cy="640080"/>
           </a:xfrm>
           <a:prstGeom prst="rect">
             <a:avLst/>
@@ -10379,266 +10293,24 @@
           <a:noFill/>
         </p:spPr>
         <p:txBody>
-          <a:bodyPr wrap="square" lIns="54864" rIns="54864" tIns="54864" bIns="54864" anchor="t">
+          <a:bodyPr wrap="square" lIns="54864" rIns="54864" tIns="54864" bIns="54864" anchor="ctr">
             <a:spAutoFit/>
           </a:bodyPr>
           <a:lstStyle/>
           <a:p>
-            <a:pPr algn="l">
+            <a:pPr algn="ctr">
               <a:spcAft>
                 <a:spcPts val="0"/>
               </a:spcAft>
             </a:pPr>
             <a:r>
-              <a:rPr sz="1500" b="1">
-                <a:solidFill>
-                  <a:srgbClr val="0F0F0F"/>
+              <a:rPr sz="1250" b="0">
+                <a:solidFill>
+                  <a:srgbClr val="334155"/>
                 </a:solidFill>
                 <a:latin typeface="Arial"/>
               </a:rPr>
-              <a:t>Reprodutibilidade</a:t>
-            </a:r>
-          </a:p>
-        </p:txBody>
-      </p:sp>
-      <p:sp>
-        <p:nvSpPr>
-          <p:cNvPr id="22" name="TextBox 21"/>
-          <p:cNvSpPr txBox="1"/>
-          <p:nvPr/>
-        </p:nvSpPr>
-        <p:spPr>
-          <a:xfrm>
-            <a:off x="4617720" y="3429000"/>
-            <a:ext cx="3063240" cy="896113"/>
-          </a:xfrm>
-          <a:prstGeom prst="rect">
-            <a:avLst/>
-          </a:prstGeom>
-          <a:noFill/>
-        </p:spPr>
-        <p:txBody>
-          <a:bodyPr wrap="square" lIns="54864" rIns="54864" tIns="54864" bIns="54864" anchor="t">
-            <a:spAutoFit/>
-          </a:bodyPr>
-          <a:lstStyle/>
-          <a:p>
-            <a:pPr algn="l">
-              <a:spcAft>
-                <a:spcPts val="0"/>
-              </a:spcAft>
-            </a:pPr>
-            <a:r>
-              <a:rPr sz="1350" b="0">
-                <a:solidFill>
-                  <a:srgbClr val="232323"/>
-                </a:solidFill>
-                <a:latin typeface="Arial"/>
-              </a:rPr>
-              <a:t>Dados, códigos e detalhes de preparação nem sempre estão disponíveis.</a:t>
-            </a:r>
-          </a:p>
-        </p:txBody>
-      </p:sp>
-      <p:sp>
-        <p:nvSpPr>
-          <p:cNvPr id="23" name="Rectangle 22"/>
-          <p:cNvSpPr/>
-          <p:nvPr/>
-        </p:nvSpPr>
-        <p:spPr>
-          <a:xfrm>
-            <a:off x="8183879" y="2971800"/>
-            <a:ext cx="3337560" cy="1417320"/>
-          </a:xfrm>
-          <a:prstGeom prst="rect">
-            <a:avLst/>
-          </a:prstGeom>
-          <a:solidFill>
-            <a:srgbClr val="FFFFFF"/>
-          </a:solidFill>
-          <a:ln>
-            <a:noFill/>
-          </a:ln>
-        </p:spPr>
-        <p:style>
-          <a:lnRef idx="1">
-            <a:schemeClr val="accent1"/>
-          </a:lnRef>
-          <a:fillRef idx="3">
-            <a:schemeClr val="accent1"/>
-          </a:fillRef>
-          <a:effectRef idx="2">
-            <a:schemeClr val="accent1"/>
-          </a:effectRef>
-          <a:fontRef idx="minor">
-            <a:schemeClr val="lt1"/>
-          </a:fontRef>
-        </p:style>
-        <p:txBody>
-          <a:bodyPr rtlCol="0" anchor="ctr"/>
-          <a:lstStyle/>
-          <a:p>
-            <a:pPr algn="ctr"/>
-          </a:p>
-        </p:txBody>
-      </p:sp>
-      <p:sp>
-        <p:nvSpPr>
-          <p:cNvPr id="24" name="Rectangle 23"/>
-          <p:cNvSpPr/>
-          <p:nvPr/>
-        </p:nvSpPr>
-        <p:spPr>
-          <a:xfrm>
-            <a:off x="8183879" y="2971800"/>
-            <a:ext cx="59436" cy="1417320"/>
-          </a:xfrm>
-          <a:prstGeom prst="rect">
-            <a:avLst/>
-          </a:prstGeom>
-          <a:solidFill>
-            <a:srgbClr val="4F46E5"/>
-          </a:solidFill>
-          <a:ln>
-            <a:noFill/>
-          </a:ln>
-        </p:spPr>
-        <p:style>
-          <a:lnRef idx="1">
-            <a:schemeClr val="accent1"/>
-          </a:lnRef>
-          <a:fillRef idx="3">
-            <a:schemeClr val="accent1"/>
-          </a:fillRef>
-          <a:effectRef idx="2">
-            <a:schemeClr val="accent1"/>
-          </a:effectRef>
-          <a:fontRef idx="minor">
-            <a:schemeClr val="lt1"/>
-          </a:fontRef>
-        </p:style>
-        <p:txBody>
-          <a:bodyPr rtlCol="0" anchor="ctr"/>
-          <a:lstStyle/>
-          <a:p>
-            <a:pPr algn="ctr"/>
-          </a:p>
-        </p:txBody>
-      </p:sp>
-      <p:sp>
-        <p:nvSpPr>
-          <p:cNvPr id="25" name="TextBox 24"/>
-          <p:cNvSpPr txBox="1"/>
-          <p:nvPr/>
-        </p:nvSpPr>
-        <p:spPr>
-          <a:xfrm>
-            <a:off x="8366759" y="3026664"/>
-            <a:ext cx="3063240" cy="384048"/>
-          </a:xfrm>
-          <a:prstGeom prst="rect">
-            <a:avLst/>
-          </a:prstGeom>
-          <a:noFill/>
-        </p:spPr>
-        <p:txBody>
-          <a:bodyPr wrap="square" lIns="54864" rIns="54864" tIns="54864" bIns="54864" anchor="t">
-            <a:spAutoFit/>
-          </a:bodyPr>
-          <a:lstStyle/>
-          <a:p>
-            <a:pPr algn="l">
-              <a:spcAft>
-                <a:spcPts val="0"/>
-              </a:spcAft>
-            </a:pPr>
-            <a:r>
-              <a:rPr sz="1500" b="1">
-                <a:solidFill>
-                  <a:srgbClr val="0F0F0F"/>
-                </a:solidFill>
-                <a:latin typeface="Arial"/>
-              </a:rPr>
-              <a:t>Contexto</a:t>
-            </a:r>
-          </a:p>
-        </p:txBody>
-      </p:sp>
-      <p:sp>
-        <p:nvSpPr>
-          <p:cNvPr id="26" name="TextBox 25"/>
-          <p:cNvSpPr txBox="1"/>
-          <p:nvPr/>
-        </p:nvSpPr>
-        <p:spPr>
-          <a:xfrm>
-            <a:off x="8366759" y="3429000"/>
-            <a:ext cx="3063240" cy="896113"/>
-          </a:xfrm>
-          <a:prstGeom prst="rect">
-            <a:avLst/>
-          </a:prstGeom>
-          <a:noFill/>
-        </p:spPr>
-        <p:txBody>
-          <a:bodyPr wrap="square" lIns="54864" rIns="54864" tIns="54864" bIns="54864" anchor="t">
-            <a:spAutoFit/>
-          </a:bodyPr>
-          <a:lstStyle/>
-          <a:p>
-            <a:pPr algn="l">
-              <a:spcAft>
-                <a:spcPts val="0"/>
-              </a:spcAft>
-            </a:pPr>
-            <a:r>
-              <a:rPr sz="1350" b="0">
-                <a:solidFill>
-                  <a:srgbClr val="232323"/>
-                </a:solidFill>
-                <a:latin typeface="Arial"/>
-              </a:rPr>
-              <a:t>Validações permanecem restritas a populações e cenários específicos.</a:t>
-            </a:r>
-          </a:p>
-        </p:txBody>
-      </p:sp>
-      <p:sp>
-        <p:nvSpPr>
-          <p:cNvPr id="27" name="TextBox 26"/>
-          <p:cNvSpPr txBox="1"/>
-          <p:nvPr/>
-        </p:nvSpPr>
-        <p:spPr>
-          <a:xfrm>
-            <a:off x="914400" y="5806440"/>
-            <a:ext cx="10241280" cy="292608"/>
-          </a:xfrm>
-          <a:prstGeom prst="rect">
-            <a:avLst/>
-          </a:prstGeom>
-          <a:noFill/>
-        </p:spPr>
-        <p:txBody>
-          <a:bodyPr wrap="square" lIns="54864" rIns="54864" tIns="54864" bIns="54864" anchor="t">
-            <a:spAutoFit/>
-          </a:bodyPr>
-          <a:lstStyle/>
-          <a:p>
-            <a:pPr algn="ctr">
-              <a:spcAft>
-                <a:spcPts val="0"/>
-              </a:spcAft>
-            </a:pPr>
-            <a:r>
-              <a:rPr sz="1400" b="0">
-                <a:solidFill>
-                  <a:srgbClr val="64748B"/>
-                </a:solidFill>
-                <a:latin typeface="Arial"/>
-              </a:rPr>
-              <a:t>Essas lacunas foram tratadas como requisitos de projeto — não como prova de que uma solução futura será eficaz.</a:t>
+              <a:t>Estes exemplos localizados não estimam a frequência da literatura. Quinze registros permanecem provisoriamente no núcleo; há 14 triagens S1/S2 e 11 apreciações por categoria, e o estudo 8 segue sem respostas até adjudicação da unidade. Um relatório não recuperado não recebeu MMAT; um registro foi excluído após resumo e um protocolo após texto completo.</a:t>
             </a:r>
           </a:p>
         </p:txBody>
@@ -12568,9 +12240,9 @@
                 <a:latin typeface="Arial"/>
               </a:rPr>
               <a:t>• um único pesquisador
-• parte da apreciação baseada em resumo/metadados
+• um texto integral pendente, sem MMAT
 • fontes e idiomas delimitados
-• MMAT preliminar
+• MMAT: 14 triagens, 11 apreciações por categoria; estudo 8 sem avaliação
 • sem aplicação funcional ou eficácia pedagógica própria</a:t>
             </a:r>
           </a:p>
@@ -12876,7 +12548,7 @@
                 <a:latin typeface="Arial"/>
               </a:rPr>
               <a:t>Thales Ferreira Batista · Ciência da Computação · IFC Videira
-Snapshot adjudicado: 03/09/2026 · recorte temporal: 2015–2026</a:t>
+Versão revisada: 15/10/2026 · corte da busca: 31/08/2026</a:t>
             </a:r>
           </a:p>
         </p:txBody>
@@ -13740,7 +13412,7 @@
                 </a:solidFill>
                 <a:latin typeface="Arial"/>
               </a:rPr>
-              <a:t>Como identificar e sintetizar, por meio de revisão sistemática, as principais técnicas computacionais aplicadas ao ensino de matemática e converter essas evidências em uma especificação de protótipo que apoie o professor?</a:t>
+              <a:t>Como estruturar uma especificação técnica e pedagógica de protótipo para apoiar a interpretação docente da aprendizagem matemática a partir das evidências e técnicas computacionais identificadas na literatura?</a:t>
             </a:r>
           </a:p>
         </p:txBody>
@@ -13904,7 +13576,7 @@
                 </a:solidFill>
                 <a:latin typeface="Arial"/>
               </a:rPr>
-              <a:t>Mapear e analisar sistematicamente as aplicações e elaborar uma especificação técnica e pedagógica para apoiar a interpretação de evidências sobre competências.</a:t>
+              <a:t>Propor uma especificação técnica e pedagógica de protótipo para apoiar a interpretação docente da aprendizagem matemática, fundamentada no mapeamento e na análise da literatura científica.</a:t>
             </a:r>
           </a:p>
         </p:txBody>
@@ -14120,8 +13792,8 @@
         </p:nvSpPr>
         <p:spPr>
           <a:xfrm>
-            <a:off x="685800" y="1143000"/>
-            <a:ext cx="5166360" cy="868680"/>
+            <a:off x="685800" y="1325880"/>
+            <a:ext cx="5166360" cy="1645920"/>
           </a:xfrm>
           <a:prstGeom prst="rect">
             <a:avLst/>
@@ -14163,8 +13835,8 @@
         </p:nvSpPr>
         <p:spPr>
           <a:xfrm>
-            <a:off x="685800" y="1143000"/>
-            <a:ext cx="59436" cy="868680"/>
+            <a:off x="685800" y="1325880"/>
+            <a:ext cx="59436" cy="1645920"/>
           </a:xfrm>
           <a:prstGeom prst="rect">
             <a:avLst/>
@@ -14206,7 +13878,7 @@
         </p:nvSpPr>
         <p:spPr>
           <a:xfrm>
-            <a:off x="868680" y="1197864"/>
+            <a:off x="868680" y="1380744"/>
             <a:ext cx="4892040" cy="384048"/>
           </a:xfrm>
           <a:prstGeom prst="rect">
@@ -14226,7 +13898,7 @@
               </a:spcAft>
             </a:pPr>
             <a:r>
-              <a:rPr sz="1500" b="1">
+              <a:rPr sz="1900" b="1">
                 <a:solidFill>
                   <a:srgbClr val="0F0F0F"/>
                 </a:solidFill>
@@ -14245,8 +13917,8 @@
         </p:nvSpPr>
         <p:spPr>
           <a:xfrm>
-            <a:off x="868680" y="1600200"/>
-            <a:ext cx="4892040" cy="347473"/>
+            <a:off x="868680" y="1783080"/>
+            <a:ext cx="4892040" cy="1124713"/>
           </a:xfrm>
           <a:prstGeom prst="rect">
             <a:avLst/>
@@ -14265,13 +13937,13 @@
               </a:spcAft>
             </a:pPr>
             <a:r>
-              <a:rPr sz="1350" b="0">
+              <a:rPr sz="1800" b="0">
                 <a:solidFill>
                   <a:srgbClr val="232323"/>
                 </a:solidFill>
                 <a:latin typeface="Arial"/>
               </a:rPr>
-              <a:t>Revisão sistemática, relatada com apoio do PRISMA 2020, sobre estudos de 2015–2026.</a:t>
+              <a:t>Categorizar técnicas computacionais e finalidades pedagógicas na literatura mapeada.</a:t>
             </a:r>
           </a:p>
         </p:txBody>
@@ -14284,8 +13956,8 @@
         </p:nvSpPr>
         <p:spPr>
           <a:xfrm>
-            <a:off x="685800" y="2286000"/>
-            <a:ext cx="5166360" cy="868680"/>
+            <a:off x="685800" y="3337560"/>
+            <a:ext cx="5166360" cy="1645920"/>
           </a:xfrm>
           <a:prstGeom prst="rect">
             <a:avLst/>
@@ -14327,8 +13999,8 @@
         </p:nvSpPr>
         <p:spPr>
           <a:xfrm>
-            <a:off x="685800" y="2286000"/>
-            <a:ext cx="59436" cy="868680"/>
+            <a:off x="685800" y="3337560"/>
+            <a:ext cx="59436" cy="1645920"/>
           </a:xfrm>
           <a:prstGeom prst="rect">
             <a:avLst/>
@@ -14370,7 +14042,7 @@
         </p:nvSpPr>
         <p:spPr>
           <a:xfrm>
-            <a:off x="868680" y="2340864"/>
+            <a:off x="868680" y="3392424"/>
             <a:ext cx="4892040" cy="384048"/>
           </a:xfrm>
           <a:prstGeom prst="rect">
@@ -14390,7 +14062,7 @@
               </a:spcAft>
             </a:pPr>
             <a:r>
-              <a:rPr sz="1500" b="1">
+              <a:rPr sz="1900" b="1">
                 <a:solidFill>
                   <a:srgbClr val="0F0F0F"/>
                 </a:solidFill>
@@ -14409,8 +14081,8 @@
         </p:nvSpPr>
         <p:spPr>
           <a:xfrm>
-            <a:off x="868680" y="2743200"/>
-            <a:ext cx="4892040" cy="347473"/>
+            <a:off x="868680" y="3794760"/>
+            <a:ext cx="4892040" cy="1124713"/>
           </a:xfrm>
           <a:prstGeom prst="rect">
             <a:avLst/>
@@ -14429,13 +14101,13 @@
               </a:spcAft>
             </a:pPr>
             <a:r>
-              <a:rPr sz="1350" b="0">
+              <a:rPr sz="1800" b="0">
                 <a:solidFill>
                   <a:srgbClr val="232323"/>
                 </a:solidFill>
                 <a:latin typeface="Arial"/>
               </a:rPr>
-              <a:t>Identificação e categorização das abordagens computacionais.</a:t>
+              <a:t>Identificar limitações e lacunas técnicas, pedagógicas, metodológicas e éticas.</a:t>
             </a:r>
           </a:p>
         </p:txBody>
@@ -14448,8 +14120,8 @@
         </p:nvSpPr>
         <p:spPr>
           <a:xfrm>
-            <a:off x="685800" y="3429000"/>
-            <a:ext cx="5166360" cy="868680"/>
+            <a:off x="6309360" y="1325880"/>
+            <a:ext cx="5166360" cy="1645920"/>
           </a:xfrm>
           <a:prstGeom prst="rect">
             <a:avLst/>
@@ -14491,14 +14163,14 @@
         </p:nvSpPr>
         <p:spPr>
           <a:xfrm>
-            <a:off x="685800" y="3429000"/>
-            <a:ext cx="59436" cy="868680"/>
-          </a:xfrm>
-          <a:prstGeom prst="rect">
-            <a:avLst/>
-          </a:prstGeom>
-          <a:solidFill>
-            <a:srgbClr val="2563EB"/>
+            <a:off x="6309360" y="1325880"/>
+            <a:ext cx="59436" cy="1645920"/>
+          </a:xfrm>
+          <a:prstGeom prst="rect">
+            <a:avLst/>
+          </a:prstGeom>
+          <a:solidFill>
+            <a:srgbClr val="0D9488"/>
           </a:solidFill>
           <a:ln>
             <a:noFill/>
@@ -14534,7 +14206,7 @@
         </p:nvSpPr>
         <p:spPr>
           <a:xfrm>
-            <a:off x="868680" y="3483864"/>
+            <a:off x="6492240" y="1380744"/>
             <a:ext cx="4892040" cy="384048"/>
           </a:xfrm>
           <a:prstGeom prst="rect">
@@ -14554,7 +14226,7 @@
               </a:spcAft>
             </a:pPr>
             <a:r>
-              <a:rPr sz="1500" b="1">
+              <a:rPr sz="1900" b="1">
                 <a:solidFill>
                   <a:srgbClr val="0F0F0F"/>
                 </a:solidFill>
@@ -14573,8 +14245,8 @@
         </p:nvSpPr>
         <p:spPr>
           <a:xfrm>
-            <a:off x="868680" y="3886200"/>
-            <a:ext cx="4892040" cy="347473"/>
+            <a:off x="6492240" y="1783080"/>
+            <a:ext cx="4892040" cy="1124713"/>
           </a:xfrm>
           <a:prstGeom prst="rect">
             <a:avLst/>
@@ -14593,13 +14265,13 @@
               </a:spcAft>
             </a:pPr>
             <a:r>
-              <a:rPr sz="1350" b="0">
+              <a:rPr sz="1800" b="0">
                 <a:solidFill>
                   <a:srgbClr val="232323"/>
                 </a:solidFill>
                 <a:latin typeface="Arial"/>
               </a:rPr>
-              <a:t>Classificação das finalidades pedagógicas das aplicações.</a:t>
+              <a:t>Formular requisitos, critérios de dados e modelos e arquitetura de referência para o protótipo.</a:t>
             </a:r>
           </a:p>
         </p:txBody>
@@ -14612,8 +14284,8 @@
         </p:nvSpPr>
         <p:spPr>
           <a:xfrm>
-            <a:off x="685800" y="4572000"/>
-            <a:ext cx="5166360" cy="868680"/>
+            <a:off x="6309360" y="3337560"/>
+            <a:ext cx="5166360" cy="1645920"/>
           </a:xfrm>
           <a:prstGeom prst="rect">
             <a:avLst/>
@@ -14655,14 +14327,14 @@
         </p:nvSpPr>
         <p:spPr>
           <a:xfrm>
-            <a:off x="685800" y="4572000"/>
-            <a:ext cx="59436" cy="868680"/>
-          </a:xfrm>
-          <a:prstGeom prst="rect">
-            <a:avLst/>
-          </a:prstGeom>
-          <a:solidFill>
-            <a:srgbClr val="2563EB"/>
+            <a:off x="6309360" y="3337560"/>
+            <a:ext cx="59436" cy="1645920"/>
+          </a:xfrm>
+          <a:prstGeom prst="rect">
+            <a:avLst/>
+          </a:prstGeom>
+          <a:solidFill>
+            <a:srgbClr val="0D9488"/>
           </a:solidFill>
           <a:ln>
             <a:noFill/>
@@ -14698,7 +14370,7 @@
         </p:nvSpPr>
         <p:spPr>
           <a:xfrm>
-            <a:off x="868680" y="4626864"/>
+            <a:off x="6492240" y="3392424"/>
             <a:ext cx="4892040" cy="384048"/>
           </a:xfrm>
           <a:prstGeom prst="rect">
@@ -14718,7 +14390,7 @@
               </a:spcAft>
             </a:pPr>
             <a:r>
-              <a:rPr sz="1500" b="1">
+              <a:rPr sz="1900" b="1">
                 <a:solidFill>
                   <a:srgbClr val="0F0F0F"/>
                 </a:solidFill>
@@ -14737,8 +14409,8 @@
         </p:nvSpPr>
         <p:spPr>
           <a:xfrm>
-            <a:off x="868680" y="5029200"/>
-            <a:ext cx="4892040" cy="347473"/>
+            <a:off x="6492240" y="3794760"/>
+            <a:ext cx="4892040" cy="1124713"/>
           </a:xfrm>
           <a:prstGeom prst="rect">
             <a:avLst/>
@@ -14757,113 +14429,27 @@
               </a:spcAft>
             </a:pPr>
             <a:r>
-              <a:rPr sz="1350" b="0">
+              <a:rPr sz="1800" b="0">
                 <a:solidFill>
                   <a:srgbClr val="232323"/>
                 </a:solidFill>
                 <a:latin typeface="Arial"/>
               </a:rPr>
-              <a:t>Análise crítica das metodologias e limitações dos estudos.</a:t>
-            </a:r>
-          </a:p>
-        </p:txBody>
-      </p:sp>
-      <p:sp>
-        <p:nvSpPr>
-          <p:cNvPr id="19" name="Rectangle 18"/>
-          <p:cNvSpPr/>
-          <p:nvPr/>
-        </p:nvSpPr>
-        <p:spPr>
-          <a:xfrm>
-            <a:off x="6309360" y="1143000"/>
-            <a:ext cx="5166360" cy="1143000"/>
-          </a:xfrm>
-          <a:prstGeom prst="rect">
-            <a:avLst/>
-          </a:prstGeom>
-          <a:solidFill>
-            <a:srgbClr val="FFFFFF"/>
-          </a:solidFill>
-          <a:ln>
-            <a:noFill/>
-          </a:ln>
-        </p:spPr>
-        <p:style>
-          <a:lnRef idx="1">
-            <a:schemeClr val="accent1"/>
-          </a:lnRef>
-          <a:fillRef idx="3">
-            <a:schemeClr val="accent1"/>
-          </a:fillRef>
-          <a:effectRef idx="2">
-            <a:schemeClr val="accent1"/>
-          </a:effectRef>
-          <a:fontRef idx="minor">
-            <a:schemeClr val="lt1"/>
-          </a:fontRef>
-        </p:style>
-        <p:txBody>
-          <a:bodyPr rtlCol="0" anchor="ctr"/>
-          <a:lstStyle/>
-          <a:p>
-            <a:pPr algn="ctr"/>
-          </a:p>
-        </p:txBody>
-      </p:sp>
-      <p:sp>
-        <p:nvSpPr>
-          <p:cNvPr id="20" name="Rectangle 19"/>
-          <p:cNvSpPr/>
-          <p:nvPr/>
-        </p:nvSpPr>
-        <p:spPr>
-          <a:xfrm>
-            <a:off x="6309360" y="1143000"/>
-            <a:ext cx="59436" cy="1143000"/>
-          </a:xfrm>
-          <a:prstGeom prst="rect">
-            <a:avLst/>
-          </a:prstGeom>
-          <a:solidFill>
-            <a:srgbClr val="0D9488"/>
-          </a:solidFill>
-          <a:ln>
-            <a:noFill/>
-          </a:ln>
-        </p:spPr>
-        <p:style>
-          <a:lnRef idx="1">
-            <a:schemeClr val="accent1"/>
-          </a:lnRef>
-          <a:fillRef idx="3">
-            <a:schemeClr val="accent1"/>
-          </a:fillRef>
-          <a:effectRef idx="2">
-            <a:schemeClr val="accent1"/>
-          </a:effectRef>
-          <a:fontRef idx="minor">
-            <a:schemeClr val="lt1"/>
-          </a:fontRef>
-        </p:style>
-        <p:txBody>
-          <a:bodyPr rtlCol="0" anchor="ctr"/>
-          <a:lstStyle/>
-          <a:p>
-            <a:pPr algn="ctr"/>
-          </a:p>
-        </p:txBody>
-      </p:sp>
-      <p:sp>
-        <p:nvSpPr>
-          <p:cNvPr id="21" name="TextBox 20"/>
+              <a:t>Propor um protocolo para avaliar a viabilidade e a coerência da especificação conceitual; aplicação pendente.</a:t>
+            </a:r>
+          </a:p>
+        </p:txBody>
+      </p:sp>
+      <p:sp>
+        <p:nvSpPr>
+          <p:cNvPr id="19" name="TextBox 18"/>
           <p:cNvSpPr txBox="1"/>
           <p:nvPr/>
         </p:nvSpPr>
         <p:spPr>
           <a:xfrm>
-            <a:off x="6492240" y="1197864"/>
-            <a:ext cx="4892040" cy="384048"/>
+            <a:off x="914400" y="5669280"/>
+            <a:ext cx="10287000" cy="594360"/>
           </a:xfrm>
           <a:prstGeom prst="rect">
             <a:avLst/>
@@ -14876,425 +14462,19 @@
           </a:bodyPr>
           <a:lstStyle/>
           <a:p>
-            <a:pPr algn="l">
+            <a:pPr algn="ctr">
               <a:spcAft>
                 <a:spcPts val="0"/>
               </a:spcAft>
             </a:pPr>
             <a:r>
-              <a:rPr sz="1500" b="1">
-                <a:solidFill>
-                  <a:srgbClr val="0F0F0F"/>
+              <a:rPr sz="1400" b="0">
+                <a:solidFill>
+                  <a:srgbClr val="64748B"/>
                 </a:solidFill>
                 <a:latin typeface="Arial"/>
               </a:rPr>
-              <a:t>OE5</a:t>
-            </a:r>
-          </a:p>
-        </p:txBody>
-      </p:sp>
-      <p:sp>
-        <p:nvSpPr>
-          <p:cNvPr id="22" name="TextBox 21"/>
-          <p:cNvSpPr txBox="1"/>
-          <p:nvPr/>
-        </p:nvSpPr>
-        <p:spPr>
-          <a:xfrm>
-            <a:off x="6492240" y="1600200"/>
-            <a:ext cx="4892040" cy="621793"/>
-          </a:xfrm>
-          <a:prstGeom prst="rect">
-            <a:avLst/>
-          </a:prstGeom>
-          <a:noFill/>
-        </p:spPr>
-        <p:txBody>
-          <a:bodyPr wrap="square" lIns="54864" rIns="54864" tIns="54864" bIns="54864" anchor="t">
-            <a:spAutoFit/>
-          </a:bodyPr>
-          <a:lstStyle/>
-          <a:p>
-            <a:pPr algn="l">
-              <a:spcAft>
-                <a:spcPts val="0"/>
-              </a:spcAft>
-            </a:pPr>
-            <a:r>
-              <a:rPr sz="1350" b="0">
-                <a:solidFill>
-                  <a:srgbClr val="232323"/>
-                </a:solidFill>
-                <a:latin typeface="Arial"/>
-              </a:rPr>
-              <a:t>Mapeamento de lacunas técnicas, pedagógicas, metodológicas e éticas.</a:t>
-            </a:r>
-          </a:p>
-        </p:txBody>
-      </p:sp>
-      <p:sp>
-        <p:nvSpPr>
-          <p:cNvPr id="23" name="Rectangle 22"/>
-          <p:cNvSpPr/>
-          <p:nvPr/>
-        </p:nvSpPr>
-        <p:spPr>
-          <a:xfrm>
-            <a:off x="6309360" y="2560320"/>
-            <a:ext cx="5166360" cy="1143000"/>
-          </a:xfrm>
-          <a:prstGeom prst="rect">
-            <a:avLst/>
-          </a:prstGeom>
-          <a:solidFill>
-            <a:srgbClr val="FFFFFF"/>
-          </a:solidFill>
-          <a:ln>
-            <a:noFill/>
-          </a:ln>
-        </p:spPr>
-        <p:style>
-          <a:lnRef idx="1">
-            <a:schemeClr val="accent1"/>
-          </a:lnRef>
-          <a:fillRef idx="3">
-            <a:schemeClr val="accent1"/>
-          </a:fillRef>
-          <a:effectRef idx="2">
-            <a:schemeClr val="accent1"/>
-          </a:effectRef>
-          <a:fontRef idx="minor">
-            <a:schemeClr val="lt1"/>
-          </a:fontRef>
-        </p:style>
-        <p:txBody>
-          <a:bodyPr rtlCol="0" anchor="ctr"/>
-          <a:lstStyle/>
-          <a:p>
-            <a:pPr algn="ctr"/>
-          </a:p>
-        </p:txBody>
-      </p:sp>
-      <p:sp>
-        <p:nvSpPr>
-          <p:cNvPr id="24" name="Rectangle 23"/>
-          <p:cNvSpPr/>
-          <p:nvPr/>
-        </p:nvSpPr>
-        <p:spPr>
-          <a:xfrm>
-            <a:off x="6309360" y="2560320"/>
-            <a:ext cx="59436" cy="1143000"/>
-          </a:xfrm>
-          <a:prstGeom prst="rect">
-            <a:avLst/>
-          </a:prstGeom>
-          <a:solidFill>
-            <a:srgbClr val="0D9488"/>
-          </a:solidFill>
-          <a:ln>
-            <a:noFill/>
-          </a:ln>
-        </p:spPr>
-        <p:style>
-          <a:lnRef idx="1">
-            <a:schemeClr val="accent1"/>
-          </a:lnRef>
-          <a:fillRef idx="3">
-            <a:schemeClr val="accent1"/>
-          </a:fillRef>
-          <a:effectRef idx="2">
-            <a:schemeClr val="accent1"/>
-          </a:effectRef>
-          <a:fontRef idx="minor">
-            <a:schemeClr val="lt1"/>
-          </a:fontRef>
-        </p:style>
-        <p:txBody>
-          <a:bodyPr rtlCol="0" anchor="ctr"/>
-          <a:lstStyle/>
-          <a:p>
-            <a:pPr algn="ctr"/>
-          </a:p>
-        </p:txBody>
-      </p:sp>
-      <p:sp>
-        <p:nvSpPr>
-          <p:cNvPr id="25" name="TextBox 24"/>
-          <p:cNvSpPr txBox="1"/>
-          <p:nvPr/>
-        </p:nvSpPr>
-        <p:spPr>
-          <a:xfrm>
-            <a:off x="6492240" y="2615184"/>
-            <a:ext cx="4892040" cy="384048"/>
-          </a:xfrm>
-          <a:prstGeom prst="rect">
-            <a:avLst/>
-          </a:prstGeom>
-          <a:noFill/>
-        </p:spPr>
-        <p:txBody>
-          <a:bodyPr wrap="square" lIns="54864" rIns="54864" tIns="54864" bIns="54864" anchor="t">
-            <a:spAutoFit/>
-          </a:bodyPr>
-          <a:lstStyle/>
-          <a:p>
-            <a:pPr algn="l">
-              <a:spcAft>
-                <a:spcPts val="0"/>
-              </a:spcAft>
-            </a:pPr>
-            <a:r>
-              <a:rPr sz="1500" b="1">
-                <a:solidFill>
-                  <a:srgbClr val="0F0F0F"/>
-                </a:solidFill>
-                <a:latin typeface="Arial"/>
-              </a:rPr>
-              <a:t>OE6</a:t>
-            </a:r>
-          </a:p>
-        </p:txBody>
-      </p:sp>
-      <p:sp>
-        <p:nvSpPr>
-          <p:cNvPr id="26" name="TextBox 25"/>
-          <p:cNvSpPr txBox="1"/>
-          <p:nvPr/>
-        </p:nvSpPr>
-        <p:spPr>
-          <a:xfrm>
-            <a:off x="6492240" y="3017520"/>
-            <a:ext cx="4892040" cy="621793"/>
-          </a:xfrm>
-          <a:prstGeom prst="rect">
-            <a:avLst/>
-          </a:prstGeom>
-          <a:noFill/>
-        </p:spPr>
-        <p:txBody>
-          <a:bodyPr wrap="square" lIns="54864" rIns="54864" tIns="54864" bIns="54864" anchor="t">
-            <a:spAutoFit/>
-          </a:bodyPr>
-          <a:lstStyle/>
-          <a:p>
-            <a:pPr algn="l">
-              <a:spcAft>
-                <a:spcPts val="0"/>
-              </a:spcAft>
-            </a:pPr>
-            <a:r>
-              <a:rPr sz="1350" b="0">
-                <a:solidFill>
-                  <a:srgbClr val="232323"/>
-                </a:solidFill>
-                <a:latin typeface="Arial"/>
-              </a:rPr>
-              <a:t>Manutenção de um pipeline automatizado e auditável para coleta, processamento e exportação.</a:t>
-            </a:r>
-          </a:p>
-        </p:txBody>
-      </p:sp>
-      <p:sp>
-        <p:nvSpPr>
-          <p:cNvPr id="27" name="Rectangle 26"/>
-          <p:cNvSpPr/>
-          <p:nvPr/>
-        </p:nvSpPr>
-        <p:spPr>
-          <a:xfrm>
-            <a:off x="6309360" y="3977639"/>
-            <a:ext cx="5166360" cy="1143000"/>
-          </a:xfrm>
-          <a:prstGeom prst="rect">
-            <a:avLst/>
-          </a:prstGeom>
-          <a:solidFill>
-            <a:srgbClr val="FFFFFF"/>
-          </a:solidFill>
-          <a:ln>
-            <a:noFill/>
-          </a:ln>
-        </p:spPr>
-        <p:style>
-          <a:lnRef idx="1">
-            <a:schemeClr val="accent1"/>
-          </a:lnRef>
-          <a:fillRef idx="3">
-            <a:schemeClr val="accent1"/>
-          </a:fillRef>
-          <a:effectRef idx="2">
-            <a:schemeClr val="accent1"/>
-          </a:effectRef>
-          <a:fontRef idx="minor">
-            <a:schemeClr val="lt1"/>
-          </a:fontRef>
-        </p:style>
-        <p:txBody>
-          <a:bodyPr rtlCol="0" anchor="ctr"/>
-          <a:lstStyle/>
-          <a:p>
-            <a:pPr algn="ctr"/>
-          </a:p>
-        </p:txBody>
-      </p:sp>
-      <p:sp>
-        <p:nvSpPr>
-          <p:cNvPr id="28" name="Rectangle 27"/>
-          <p:cNvSpPr/>
-          <p:nvPr/>
-        </p:nvSpPr>
-        <p:spPr>
-          <a:xfrm>
-            <a:off x="6309360" y="3977639"/>
-            <a:ext cx="59436" cy="1143000"/>
-          </a:xfrm>
-          <a:prstGeom prst="rect">
-            <a:avLst/>
-          </a:prstGeom>
-          <a:solidFill>
-            <a:srgbClr val="0D9488"/>
-          </a:solidFill>
-          <a:ln>
-            <a:noFill/>
-          </a:ln>
-        </p:spPr>
-        <p:style>
-          <a:lnRef idx="1">
-            <a:schemeClr val="accent1"/>
-          </a:lnRef>
-          <a:fillRef idx="3">
-            <a:schemeClr val="accent1"/>
-          </a:fillRef>
-          <a:effectRef idx="2">
-            <a:schemeClr val="accent1"/>
-          </a:effectRef>
-          <a:fontRef idx="minor">
-            <a:schemeClr val="lt1"/>
-          </a:fontRef>
-        </p:style>
-        <p:txBody>
-          <a:bodyPr rtlCol="0" anchor="ctr"/>
-          <a:lstStyle/>
-          <a:p>
-            <a:pPr algn="ctr"/>
-          </a:p>
-        </p:txBody>
-      </p:sp>
-      <p:sp>
-        <p:nvSpPr>
-          <p:cNvPr id="29" name="TextBox 28"/>
-          <p:cNvSpPr txBox="1"/>
-          <p:nvPr/>
-        </p:nvSpPr>
-        <p:spPr>
-          <a:xfrm>
-            <a:off x="6492240" y="4032503"/>
-            <a:ext cx="4892040" cy="384048"/>
-          </a:xfrm>
-          <a:prstGeom prst="rect">
-            <a:avLst/>
-          </a:prstGeom>
-          <a:noFill/>
-        </p:spPr>
-        <p:txBody>
-          <a:bodyPr wrap="square" lIns="54864" rIns="54864" tIns="54864" bIns="54864" anchor="t">
-            <a:spAutoFit/>
-          </a:bodyPr>
-          <a:lstStyle/>
-          <a:p>
-            <a:pPr algn="l">
-              <a:spcAft>
-                <a:spcPts val="0"/>
-              </a:spcAft>
-            </a:pPr>
-            <a:r>
-              <a:rPr sz="1500" b="1">
-                <a:solidFill>
-                  <a:srgbClr val="0F0F0F"/>
-                </a:solidFill>
-                <a:latin typeface="Arial"/>
-              </a:rPr>
-              <a:t>OE7</a:t>
-            </a:r>
-          </a:p>
-        </p:txBody>
-      </p:sp>
-      <p:sp>
-        <p:nvSpPr>
-          <p:cNvPr id="30" name="TextBox 29"/>
-          <p:cNvSpPr txBox="1"/>
-          <p:nvPr/>
-        </p:nvSpPr>
-        <p:spPr>
-          <a:xfrm>
-            <a:off x="6492240" y="4434839"/>
-            <a:ext cx="4892040" cy="621793"/>
-          </a:xfrm>
-          <a:prstGeom prst="rect">
-            <a:avLst/>
-          </a:prstGeom>
-          <a:noFill/>
-        </p:spPr>
-        <p:txBody>
-          <a:bodyPr wrap="square" lIns="54864" rIns="54864" tIns="54864" bIns="54864" anchor="t">
-            <a:spAutoFit/>
-          </a:bodyPr>
-          <a:lstStyle/>
-          <a:p>
-            <a:pPr algn="l">
-              <a:spcAft>
-                <a:spcPts val="0"/>
-              </a:spcAft>
-            </a:pPr>
-            <a:r>
-              <a:rPr sz="1350" b="0">
-                <a:solidFill>
-                  <a:srgbClr val="232323"/>
-                </a:solidFill>
-                <a:latin typeface="Arial"/>
-              </a:rPr>
-              <a:t>Derivação de requisitos, critérios de dados e modelos, protocolo de avaliação e arquitetura de referência.</a:t>
-            </a:r>
-          </a:p>
-        </p:txBody>
-      </p:sp>
-      <p:sp>
-        <p:nvSpPr>
-          <p:cNvPr id="31" name="TextBox 30"/>
-          <p:cNvSpPr txBox="1"/>
-          <p:nvPr/>
-        </p:nvSpPr>
-        <p:spPr>
-          <a:xfrm>
-            <a:off x="914400" y="5897880"/>
-            <a:ext cx="10287000" cy="384048"/>
-          </a:xfrm>
-          <a:prstGeom prst="rect">
-            <a:avLst/>
-          </a:prstGeom>
-          <a:noFill/>
-        </p:spPr>
-        <p:txBody>
-          <a:bodyPr wrap="square" lIns="54864" rIns="54864" tIns="54864" bIns="54864" anchor="t">
-            <a:spAutoFit/>
-          </a:bodyPr>
-          <a:lstStyle/>
-          <a:p>
-            <a:pPr algn="ctr">
-              <a:spcAft>
-                <a:spcPts val="0"/>
-              </a:spcAft>
-            </a:pPr>
-            <a:r>
-              <a:rPr sz="1400" b="0">
-                <a:solidFill>
-                  <a:srgbClr val="64748B"/>
-                </a:solidFill>
-                <a:latin typeface="Arial"/>
-              </a:rPr>
-              <a:t>A apresentação distingue objetivos executados de atividades que permanecem fora do escopo, como implementação funcional e validação com participantes.</a:t>
+              <a:t>Revisão, MMAT preliminar e pipeline são meios. O protocolo proposto avalia a especificação conceitual; aplicação pendente. Experimento do protótipo é contingência.</a:t>
             </a:r>
           </a:p>
         </p:txBody>
@@ -15892,7 +15072,7 @@
                 </a:solidFill>
                 <a:latin typeface="Arial"/>
               </a:rPr>
-              <a:t>Mobilização integrada de conhecimentos, procedimentos, estratégias e atitudes.</a:t>
+              <a:t>Mobilização de conhecimentos, habilidades, atitudes e valores para resolver demandas.</a:t>
             </a:r>
           </a:p>
         </p:txBody>
@@ -16056,7 +15236,7 @@
                 </a:solidFill>
                 <a:latin typeface="Arial"/>
               </a:rPr>
-              <a:t>Transformação construída ao longo do tempo, com compreensão, autonomia e transferência.</a:t>
+              <a:t>Neste TCC: mudanças no que o estudante sabe e consegue fazer ao longo do tempo.</a:t>
             </a:r>
           </a:p>
         </p:txBody>
@@ -17084,7 +16264,7 @@
                 </a:solidFill>
                 <a:latin typeface="Arial"/>
               </a:rPr>
-              <a:t>Do registro bruto à população retida</a:t>
+              <a:t>Do registro bruto ao conjunto retido provisoriamente</a:t>
             </a:r>
           </a:p>
         </p:txBody>
@@ -17123,7 +16303,7 @@
                 </a:solidFill>
                 <a:latin typeface="Arial"/>
               </a:rPr>
-              <a:t>Contagens do snapshot adjudicado</a:t>
+              <a:t>Contagens do recorte versionado</a:t>
             </a:r>
           </a:p>
         </p:txBody>
@@ -17944,7 +17124,7 @@
                 </a:solidFill>
                 <a:latin typeface="Arial"/>
               </a:rPr>
-              <a:t>na elegibilidade</a:t>
+              <a:t>submetidos à priorização</a:t>
             </a:r>
           </a:p>
         </p:txBody>
@@ -18108,7 +17288,7 @@
                 </a:solidFill>
                 <a:latin typeface="Arial"/>
               </a:rPr>
-              <a:t>excluídos na elegibilidade</a:t>
+              <a:t>excluídos nessa etapa</a:t>
             </a:r>
           </a:p>
         </p:txBody>
@@ -18285,8 +17465,8 @@
         </p:nvSpPr>
         <p:spPr>
           <a:xfrm>
-            <a:off x="1005840" y="5669280"/>
-            <a:ext cx="10058400" cy="320040"/>
+            <a:off x="777240" y="5623560"/>
+            <a:ext cx="10607040" cy="411480"/>
           </a:xfrm>
           <a:prstGeom prst="rect">
             <a:avLst/>
@@ -18305,13 +17485,13 @@
               </a:spcAft>
             </a:pPr>
             <a:r>
-              <a:rPr sz="1400" b="0">
+              <a:rPr sz="1150" b="0">
                 <a:solidFill>
                   <a:srgbClr val="64748B"/>
                 </a:solidFill>
                 <a:latin typeface="Arial"/>
               </a:rPr>
-              <a:t>A remoção determinística por DOI/URL precede a triagem. Igualdade de título permaneceu como candidato à auditoria semântica.</a:t>
+              <a:t>A priorização dos 2.486 registros usa metadados/resumos e não equivale à elegibilidade em texto completo; títulos repetidos seguem para auditoria semântica.</a:t>
             </a:r>
           </a:p>
         </p:txBody>
@@ -18376,7 +17556,7 @@
                 </a:solidFill>
                 <a:latin typeface="Arial"/>
               </a:rPr>
-              <a:t>Fluxo PRISMA do snapshot</a:t>
+              <a:t>Fluxo operacional do processo de seleção</a:t>
             </a:r>
           </a:p>
         </p:txBody>
@@ -18397,8 +17577,8 @@
         </p:blipFill>
         <p:spPr>
           <a:xfrm>
-            <a:off x="2359571" y="960120"/>
-            <a:ext cx="7488097" cy="5212080"/>
+            <a:off x="1470660" y="960120"/>
+            <a:ext cx="9265920" cy="5212080"/>
           </a:xfrm>
           <a:prstGeom prst="rect">
             <a:avLst/>
@@ -18439,7 +17619,7 @@
                 </a:solidFill>
                 <a:latin typeface="Arial"/>
               </a:rPr>
-              <a:t>Figura versionada e sincronizada com os artefatos públicos do pipeline.</a:t>
+              <a:t>Representação operacional própria; não reproduz todas as etapas do diagrama PRISMA 2020.</a:t>
             </a:r>
           </a:p>
         </p:txBody>
@@ -18525,8 +17705,8 @@
         </p:blipFill>
         <p:spPr>
           <a:xfrm>
-            <a:off x="640080" y="1649878"/>
-            <a:ext cx="5623560" cy="3741123"/>
+            <a:off x="640080" y="1650666"/>
+            <a:ext cx="5623560" cy="3739548"/>
           </a:xfrm>
           <a:prstGeom prst="rect">
             <a:avLst/>

</xml_diff>

<commit_message>
:books: docs(tcc): align thesis text with reconciled evidence (#111)
* :books: docs(tcc): align thesis text with reconciled evidence

* :lipstick: feat(presentation): align slides with thesis text
</commit_message>
<xml_diff>
--- a/results/tcc/presentation/ensino_personalizado_de_matematica_tcc.pptx
+++ b/results/tcc/presentation/ensino_personalizado_de_matematica_tcc.pptx
@@ -5806,7 +5806,7 @@
                 <a:latin typeface="Arial"/>
               </a:rPr>
               <a:t>Instituto Federal Catarinense — Campus Videira
-Snapshot adjudicado: 03/09/2026 · recorte temporal: 2015–2026</a:t>
+Versão revisada: 15/10/2026 · corte da busca: 31/08/2026</a:t>
             </a:r>
           </a:p>
         </p:txBody>
@@ -5871,7 +5871,7 @@
                 </a:solidFill>
                 <a:latin typeface="Arial"/>
               </a:rPr>
-              <a:t>Panorama descritivo do snapshot</a:t>
+              <a:t>Panorama descritivo do recorte versionado</a:t>
             </a:r>
           </a:p>
         </p:txBody>
@@ -6715,8 +6715,8 @@
         </p:blipFill>
         <p:spPr>
           <a:xfrm>
-            <a:off x="548640" y="1275734"/>
-            <a:ext cx="5486400" cy="2203412"/>
+            <a:off x="548640" y="1276227"/>
+            <a:ext cx="5486400" cy="2202425"/>
           </a:xfrm>
           <a:prstGeom prst="rect">
             <a:avLst/>
@@ -6739,8 +6739,8 @@
         </p:blipFill>
         <p:spPr>
           <a:xfrm>
-            <a:off x="6172200" y="1230414"/>
-            <a:ext cx="5486400" cy="2294051"/>
+            <a:off x="7187460" y="1143000"/>
+            <a:ext cx="3455879" cy="2468880"/>
           </a:xfrm>
           <a:prstGeom prst="rect">
             <a:avLst/>
@@ -6906,7 +6906,7 @@
                 </a:solidFill>
                 <a:latin typeface="Arial"/>
               </a:rPr>
-              <a:t>O snapshot foi delimitado a 2015–2026, com data de corte em 31 de agosto de 2026. Como 2026 é parcial, sua barra não deve ser comparada diretamente com anos completos.</a:t>
+              <a:t>O recorte foi delimitado a 2015–2026, com data de corte em 31 de agosto de 2026. Como 2026 é parcial, sua barra não deve ser comparada diretamente com anos completos.</a:t>
             </a:r>
           </a:p>
         </p:txBody>
@@ -7174,7 +7174,7 @@
                 </a:solidFill>
                 <a:latin typeface="Arial"/>
               </a:rPr>
-              <a:t>População retida e síntese empírica</a:t>
+              <a:t>Conjunto retido e síntese empírica</a:t>
             </a:r>
           </a:p>
         </p:txBody>
@@ -7463,7 +7463,7 @@
                 </a:solidFill>
                 <a:latin typeface="Arial"/>
               </a:rPr>
-              <a:t>17</a:t>
+              <a:t>15</a:t>
             </a:r>
           </a:p>
         </p:txBody>
@@ -7502,7 +7502,7 @@
                 </a:solidFill>
                 <a:latin typeface="Arial"/>
               </a:rPr>
-              <a:t>candidatos empíricos provisórios</a:t>
+              <a:t>registros empíricos mantidos provisoriamente</a:t>
             </a:r>
           </a:p>
         </p:txBody>
@@ -7666,7 +7666,7 @@
                 </a:solidFill>
                 <a:latin typeface="Arial"/>
               </a:rPr>
-              <a:t>protocolo ou proposta contextual</a:t>
+              <a:t>texto integral pendente</a:t>
             </a:r>
           </a:p>
         </p:txBody>
@@ -7791,7 +7791,7 @@
                 </a:solidFill>
                 <a:latin typeface="Arial"/>
               </a:rPr>
-              <a:t>O que entra na síntese</a:t>
+              <a:t>Desfecho da seleção</a:t>
             </a:r>
           </a:p>
         </p:txBody>
@@ -7830,7 +7830,7 @@
                 </a:solidFill>
                 <a:latin typeface="Arial"/>
               </a:rPr>
-              <a:t>A síntese de evidências e a apreciação MMAT aplicável consideram os 17 candidatos empíricos. O protocolo/proposta contextual foi mantido para rastreabilidade do mapeamento, mas não sustenta resultado empírico concluído.</a:t>
+              <a:t>Dos 18 registros selecionados preliminarmente, um foi excluído após o resumo. Dos 17 relatórios procurados, um não foi recuperado e 16 foram avaliados em texto completo; um protocolo sem resultados concluídos foi excluído após essa avaliação e 15 registros empíricos permanecem provisoriamente no núcleo. O estudo 8 aguarda adjudicação de elegibilidade e unidade de análise; o relatório não recuperado não recebeu MMAT.</a:t>
             </a:r>
           </a:p>
         </p:txBody>
@@ -7955,7 +7955,7 @@
                 </a:solidFill>
                 <a:latin typeface="Arial"/>
               </a:rPr>
-              <a:t>Padrão observado</a:t>
+              <a:t>Exemplos observados</a:t>
             </a:r>
           </a:p>
         </p:txBody>
@@ -7994,7 +7994,7 @@
                 </a:solidFill>
                 <a:latin typeface="Arial"/>
               </a:rPr>
-              <a:t>Predomínio de aplicações voltadas à predição de desempenho e à estimativa de proficiência, com recorrência de modelos supervisionados como Random Forest, SVM, árvores de decisão e redes neurais.</a:t>
+              <a:t>Há classificação e predição de resultados matemáticos, com RF, SVM, árvores e redes neurais entre as alternativas examinadas. Categorias operacionais de desempenho não equivalem automaticamente a níveis de proficiência validados.</a:t>
             </a:r>
           </a:p>
         </p:txBody>
@@ -8581,13 +8581,13 @@
               </a:spcAft>
             </a:pPr>
             <a:r>
-              <a:rPr sz="1400" b="0">
+              <a:rPr sz="1300" b="0">
                 <a:solidFill>
                   <a:srgbClr val="232323"/>
                 </a:solidFill>
                 <a:latin typeface="Arial"/>
               </a:rPr>
-              <a:t>Apreciação preliminar por um único revisor: nove registros com texto primário revisado e oito com base em resumo/metadados.</a:t>
+              <a:t>15 registros provisórios. S1/S2: 14; Q1–Q5: 11. Estudos 5, 7 e 14 aguardam categoria; estudo 8 aguarda unidade. Um texto não recuperado, sem MMAT. Conferência humana pendente.</a:t>
             </a:r>
           </a:p>
         </p:txBody>
@@ -9019,7 +9019,7 @@
                 </a:solidFill>
                 <a:latin typeface="Arial"/>
               </a:rPr>
-              <a:t>A literatura oferece um mapa auditável de técnicas, finalidades e formas de avaliação aplicadas à educação matemática.</a:t>
+              <a:t>O recorte examinado oferece exemplos auditáveis de técnicas, finalidades e formas de avaliação aplicadas à educação matemática.</a:t>
             </a:r>
           </a:p>
         </p:txBody>
@@ -9615,7 +9615,7 @@
                 </a:solidFill>
                 <a:latin typeface="Arial"/>
               </a:rPr>
-              <a:t>Lacunas documentadas</a:t>
+              <a:t>Limitações localizadas nos estudos consultados</a:t>
             </a:r>
           </a:p>
         </p:txBody>
@@ -9628,8 +9628,8 @@
         </p:nvSpPr>
         <p:spPr>
           <a:xfrm>
-            <a:off x="685800" y="1143000"/>
-            <a:ext cx="3337560" cy="1417320"/>
+            <a:off x="685800" y="1097280"/>
+            <a:ext cx="5257800" cy="1737360"/>
           </a:xfrm>
           <a:prstGeom prst="rect">
             <a:avLst/>
@@ -9671,8 +9671,8 @@
         </p:nvSpPr>
         <p:spPr>
           <a:xfrm>
-            <a:off x="685800" y="1143000"/>
-            <a:ext cx="59436" cy="1417320"/>
+            <a:off x="685800" y="1097280"/>
+            <a:ext cx="59436" cy="1737360"/>
           </a:xfrm>
           <a:prstGeom prst="rect">
             <a:avLst/>
@@ -9714,8 +9714,8 @@
         </p:nvSpPr>
         <p:spPr>
           <a:xfrm>
-            <a:off x="868680" y="1197864"/>
-            <a:ext cx="3063240" cy="384048"/>
+            <a:off x="868680" y="1152144"/>
+            <a:ext cx="4983480" cy="384048"/>
           </a:xfrm>
           <a:prstGeom prst="rect">
             <a:avLst/>
@@ -9734,13 +9734,13 @@
               </a:spcAft>
             </a:pPr>
             <a:r>
-              <a:rPr sz="1500" b="1">
+              <a:rPr sz="1600" b="1">
                 <a:solidFill>
                   <a:srgbClr val="0F0F0F"/>
                 </a:solidFill>
                 <a:latin typeface="Arial"/>
               </a:rPr>
-              <a:t>Explicabilidade</a:t>
+              <a:t>He et al. (2025)</a:t>
             </a:r>
           </a:p>
         </p:txBody>
@@ -9753,8 +9753,8 @@
         </p:nvSpPr>
         <p:spPr>
           <a:xfrm>
-            <a:off x="868680" y="1600200"/>
-            <a:ext cx="3063240" cy="896113"/>
+            <a:off x="868680" y="1554480"/>
+            <a:ext cx="4983480" cy="1216153"/>
           </a:xfrm>
           <a:prstGeom prst="rect">
             <a:avLst/>
@@ -9773,13 +9773,13 @@
               </a:spcAft>
             </a:pPr>
             <a:r>
-              <a:rPr sz="1350" b="0">
+              <a:rPr sz="1300" b="0">
                 <a:solidFill>
                   <a:srgbClr val="232323"/>
                 </a:solidFill>
                 <a:latin typeface="Arial"/>
               </a:rPr>
-              <a:t>Pouca clareza sobre como as saídas chegam à interpretação pedagógica.</a:t>
+              <a:t>Oito turmas de 45 estudantes são descritas, mas a amostra declarada é n=90; docentes também se distribuem de modo desigual entre condições (pp. 1, 16, 31–35). Isso exige cautela com denominadores e possível confundimento.</a:t>
             </a:r>
           </a:p>
         </p:txBody>
@@ -9792,8 +9792,8 @@
         </p:nvSpPr>
         <p:spPr>
           <a:xfrm>
-            <a:off x="4434840" y="1143000"/>
-            <a:ext cx="3337560" cy="1417320"/>
+            <a:off x="6217920" y="1097280"/>
+            <a:ext cx="5257800" cy="1737360"/>
           </a:xfrm>
           <a:prstGeom prst="rect">
             <a:avLst/>
@@ -9835,8 +9835,8 @@
         </p:nvSpPr>
         <p:spPr>
           <a:xfrm>
-            <a:off x="4434840" y="1143000"/>
-            <a:ext cx="59436" cy="1417320"/>
+            <a:off x="6217920" y="1097280"/>
+            <a:ext cx="59436" cy="1737360"/>
           </a:xfrm>
           <a:prstGeom prst="rect">
             <a:avLst/>
@@ -9878,8 +9878,8 @@
         </p:nvSpPr>
         <p:spPr>
           <a:xfrm>
-            <a:off x="4617720" y="1197864"/>
-            <a:ext cx="3063240" cy="384048"/>
+            <a:off x="6400800" y="1152144"/>
+            <a:ext cx="4983480" cy="384048"/>
           </a:xfrm>
           <a:prstGeom prst="rect">
             <a:avLst/>
@@ -9898,13 +9898,13 @@
               </a:spcAft>
             </a:pPr>
             <a:r>
-              <a:rPr sz="1500" b="1">
+              <a:rPr sz="1600" b="1">
                 <a:solidFill>
                   <a:srgbClr val="0F0F0F"/>
                 </a:solidFill>
                 <a:latin typeface="Arial"/>
               </a:rPr>
-              <a:t>Currículo</a:t>
+              <a:t>Villegas-Ch et al. (2025)</a:t>
             </a:r>
           </a:p>
         </p:txBody>
@@ -9917,8 +9917,8 @@
         </p:nvSpPr>
         <p:spPr>
           <a:xfrm>
-            <a:off x="4617720" y="1600200"/>
-            <a:ext cx="3063240" cy="896113"/>
+            <a:off x="6400800" y="1554480"/>
+            <a:ext cx="4983480" cy="1216153"/>
           </a:xfrm>
           <a:prstGeom prst="rect">
             <a:avLst/>
@@ -9937,13 +9937,13 @@
               </a:spcAft>
             </a:pPr>
             <a:r>
-              <a:rPr sz="1350" b="0">
+              <a:rPr sz="1300" b="0">
                 <a:solidFill>
                   <a:srgbClr val="232323"/>
                 </a:solidFill>
                 <a:latin typeface="Arial"/>
               </a:rPr>
-              <a:t>Alinhamento explícito com referenciais curriculares aparece de forma limitada.</a:t>
+              <a:t>Os métodos descrevem seis semanas, mas a subanálise de programação reporta resultados na oitava, sem conciliação nos trechos consultados (pp. 14, 22). Não se deve impor duração única à síntese.</a:t>
             </a:r>
           </a:p>
         </p:txBody>
@@ -9956,8 +9956,8 @@
         </p:nvSpPr>
         <p:spPr>
           <a:xfrm>
-            <a:off x="8183879" y="1143000"/>
-            <a:ext cx="3337560" cy="1417320"/>
+            <a:off x="685800" y="3063239"/>
+            <a:ext cx="5257800" cy="1737360"/>
           </a:xfrm>
           <a:prstGeom prst="rect">
             <a:avLst/>
@@ -9999,8 +9999,8 @@
         </p:nvSpPr>
         <p:spPr>
           <a:xfrm>
-            <a:off x="8183879" y="1143000"/>
-            <a:ext cx="59436" cy="1417320"/>
+            <a:off x="685800" y="3063239"/>
+            <a:ext cx="59436" cy="1737360"/>
           </a:xfrm>
           <a:prstGeom prst="rect">
             <a:avLst/>
@@ -10042,8 +10042,8 @@
         </p:nvSpPr>
         <p:spPr>
           <a:xfrm>
-            <a:off x="8366759" y="1197864"/>
-            <a:ext cx="3063240" cy="384048"/>
+            <a:off x="868680" y="3118103"/>
+            <a:ext cx="4983480" cy="384048"/>
           </a:xfrm>
           <a:prstGeom prst="rect">
             <a:avLst/>
@@ -10062,13 +10062,13 @@
               </a:spcAft>
             </a:pPr>
             <a:r>
-              <a:rPr sz="1500" b="1">
+              <a:rPr sz="1600" b="1">
                 <a:solidFill>
                   <a:srgbClr val="0F0F0F"/>
                 </a:solidFill>
                 <a:latin typeface="Arial"/>
               </a:rPr>
-              <a:t>Participação docente</a:t>
+              <a:t>Nyantah et al. (2025)</a:t>
             </a:r>
           </a:p>
         </p:txBody>
@@ -10081,8 +10081,8 @@
         </p:nvSpPr>
         <p:spPr>
           <a:xfrm>
-            <a:off x="8366759" y="1600200"/>
-            <a:ext cx="3063240" cy="896113"/>
+            <a:off x="868680" y="3520439"/>
+            <a:ext cx="4983480" cy="1216153"/>
           </a:xfrm>
           <a:prstGeom prst="rect">
             <a:avLst/>
@@ -10101,13 +10101,13 @@
               </a:spcAft>
             </a:pPr>
             <a:r>
-              <a:rPr sz="1350" b="0">
+              <a:rPr sz="1300" b="0">
                 <a:solidFill>
                   <a:srgbClr val="232323"/>
                 </a:solidFill>
                 <a:latin typeface="Arial"/>
               </a:rPr>
-              <a:t>Decisões de projeto nem sempre incorporam o professor como intérprete.</a:t>
+              <a:t>A alocação é descrita de modo incompatível; há diferença no pré-teste e a intervenção combina animação e jigsaw (pp. 101–105). O resultado não deve ser atribuído à animação isoladamente.</a:t>
             </a:r>
           </a:p>
         </p:txBody>
@@ -10120,8 +10120,8 @@
         </p:nvSpPr>
         <p:spPr>
           <a:xfrm>
-            <a:off x="685800" y="2971800"/>
-            <a:ext cx="3337560" cy="1417320"/>
+            <a:off x="6217920" y="3063239"/>
+            <a:ext cx="5257800" cy="1737360"/>
           </a:xfrm>
           <a:prstGeom prst="rect">
             <a:avLst/>
@@ -10163,8 +10163,8 @@
         </p:nvSpPr>
         <p:spPr>
           <a:xfrm>
-            <a:off x="685800" y="2971800"/>
-            <a:ext cx="59436" cy="1417320"/>
+            <a:off x="6217920" y="3063239"/>
+            <a:ext cx="59436" cy="1737360"/>
           </a:xfrm>
           <a:prstGeom prst="rect">
             <a:avLst/>
@@ -10206,8 +10206,8 @@
         </p:nvSpPr>
         <p:spPr>
           <a:xfrm>
-            <a:off x="868680" y="3026664"/>
-            <a:ext cx="3063240" cy="384048"/>
+            <a:off x="6400800" y="3118103"/>
+            <a:ext cx="4983480" cy="384048"/>
           </a:xfrm>
           <a:prstGeom prst="rect">
             <a:avLst/>
@@ -10226,13 +10226,13 @@
               </a:spcAft>
             </a:pPr>
             <a:r>
-              <a:rPr sz="1500" b="1">
+              <a:rPr sz="1600" b="1">
                 <a:solidFill>
                   <a:srgbClr val="0F0F0F"/>
                 </a:solidFill>
                 <a:latin typeface="Arial"/>
               </a:rPr>
-              <a:t>Equidade</a:t>
+              <a:t>Echeveria et al. (2025)</a:t>
             </a:r>
           </a:p>
         </p:txBody>
@@ -10245,8 +10245,8 @@
         </p:nvSpPr>
         <p:spPr>
           <a:xfrm>
-            <a:off x="868680" y="3429000"/>
-            <a:ext cx="3063240" cy="896113"/>
+            <a:off x="6400800" y="3520439"/>
+            <a:ext cx="4983480" cy="1216153"/>
           </a:xfrm>
           <a:prstGeom prst="rect">
             <a:avLst/>
@@ -10265,113 +10265,27 @@
               </a:spcAft>
             </a:pPr>
             <a:r>
-              <a:rPr sz="1350" b="0">
+              <a:rPr sz="1300" b="0">
                 <a:solidFill>
                   <a:srgbClr val="232323"/>
                 </a:solidFill>
                 <a:latin typeface="Arial"/>
               </a:rPr>
-              <a:t>Análises de possíveis vieses e diferenças entre grupos são escassas.</a:t>
-            </a:r>
-          </a:p>
-        </p:txBody>
-      </p:sp>
-      <p:sp>
-        <p:nvSpPr>
-          <p:cNvPr id="19" name="Rectangle 18"/>
-          <p:cNvSpPr/>
-          <p:nvPr/>
-        </p:nvSpPr>
-        <p:spPr>
-          <a:xfrm>
-            <a:off x="4434840" y="2971800"/>
-            <a:ext cx="3337560" cy="1417320"/>
-          </a:xfrm>
-          <a:prstGeom prst="rect">
-            <a:avLst/>
-          </a:prstGeom>
-          <a:solidFill>
-            <a:srgbClr val="FFFFFF"/>
-          </a:solidFill>
-          <a:ln>
-            <a:noFill/>
-          </a:ln>
-        </p:spPr>
-        <p:style>
-          <a:lnRef idx="1">
-            <a:schemeClr val="accent1"/>
-          </a:lnRef>
-          <a:fillRef idx="3">
-            <a:schemeClr val="accent1"/>
-          </a:fillRef>
-          <a:effectRef idx="2">
-            <a:schemeClr val="accent1"/>
-          </a:effectRef>
-          <a:fontRef idx="minor">
-            <a:schemeClr val="lt1"/>
-          </a:fontRef>
-        </p:style>
-        <p:txBody>
-          <a:bodyPr rtlCol="0" anchor="ctr"/>
-          <a:lstStyle/>
-          <a:p>
-            <a:pPr algn="ctr"/>
-          </a:p>
-        </p:txBody>
-      </p:sp>
-      <p:sp>
-        <p:nvSpPr>
-          <p:cNvPr id="20" name="Rectangle 19"/>
-          <p:cNvSpPr/>
-          <p:nvPr/>
-        </p:nvSpPr>
-        <p:spPr>
-          <a:xfrm>
-            <a:off x="4434840" y="2971800"/>
-            <a:ext cx="59436" cy="1417320"/>
-          </a:xfrm>
-          <a:prstGeom prst="rect">
-            <a:avLst/>
-          </a:prstGeom>
-          <a:solidFill>
-            <a:srgbClr val="EA580C"/>
-          </a:solidFill>
-          <a:ln>
-            <a:noFill/>
-          </a:ln>
-        </p:spPr>
-        <p:style>
-          <a:lnRef idx="1">
-            <a:schemeClr val="accent1"/>
-          </a:lnRef>
-          <a:fillRef idx="3">
-            <a:schemeClr val="accent1"/>
-          </a:fillRef>
-          <a:effectRef idx="2">
-            <a:schemeClr val="accent1"/>
-          </a:effectRef>
-          <a:fontRef idx="minor">
-            <a:schemeClr val="lt1"/>
-          </a:fontRef>
-        </p:style>
-        <p:txBody>
-          <a:bodyPr rtlCol="0" anchor="ctr"/>
-          <a:lstStyle/>
-          <a:p>
-            <a:pPr algn="ctr"/>
-          </a:p>
-        </p:txBody>
-      </p:sp>
-      <p:sp>
-        <p:nvSpPr>
-          <p:cNvPr id="21" name="TextBox 20"/>
+              <a:t>Oito itens usados para formar categorias também aparecem entre os preditores selecionados (pp. 66, 69–70). A classificação não estabelece diagnóstico independente.</a:t>
+            </a:r>
+          </a:p>
+        </p:txBody>
+      </p:sp>
+      <p:sp>
+        <p:nvSpPr>
+          <p:cNvPr id="19" name="TextBox 18"/>
           <p:cNvSpPr txBox="1"/>
           <p:nvPr/>
         </p:nvSpPr>
         <p:spPr>
           <a:xfrm>
-            <a:off x="4617720" y="3026664"/>
-            <a:ext cx="3063240" cy="384048"/>
+            <a:off x="822960" y="5074920"/>
+            <a:ext cx="10561320" cy="640080"/>
           </a:xfrm>
           <a:prstGeom prst="rect">
             <a:avLst/>
@@ -10379,266 +10293,24 @@
           <a:noFill/>
         </p:spPr>
         <p:txBody>
-          <a:bodyPr wrap="square" lIns="54864" rIns="54864" tIns="54864" bIns="54864" anchor="t">
+          <a:bodyPr wrap="square" lIns="54864" rIns="54864" tIns="54864" bIns="54864" anchor="ctr">
             <a:spAutoFit/>
           </a:bodyPr>
           <a:lstStyle/>
           <a:p>
-            <a:pPr algn="l">
+            <a:pPr algn="ctr">
               <a:spcAft>
                 <a:spcPts val="0"/>
               </a:spcAft>
             </a:pPr>
             <a:r>
-              <a:rPr sz="1500" b="1">
-                <a:solidFill>
-                  <a:srgbClr val="0F0F0F"/>
+              <a:rPr sz="1250" b="0">
+                <a:solidFill>
+                  <a:srgbClr val="334155"/>
                 </a:solidFill>
                 <a:latin typeface="Arial"/>
               </a:rPr>
-              <a:t>Reprodutibilidade</a:t>
-            </a:r>
-          </a:p>
-        </p:txBody>
-      </p:sp>
-      <p:sp>
-        <p:nvSpPr>
-          <p:cNvPr id="22" name="TextBox 21"/>
-          <p:cNvSpPr txBox="1"/>
-          <p:nvPr/>
-        </p:nvSpPr>
-        <p:spPr>
-          <a:xfrm>
-            <a:off x="4617720" y="3429000"/>
-            <a:ext cx="3063240" cy="896113"/>
-          </a:xfrm>
-          <a:prstGeom prst="rect">
-            <a:avLst/>
-          </a:prstGeom>
-          <a:noFill/>
-        </p:spPr>
-        <p:txBody>
-          <a:bodyPr wrap="square" lIns="54864" rIns="54864" tIns="54864" bIns="54864" anchor="t">
-            <a:spAutoFit/>
-          </a:bodyPr>
-          <a:lstStyle/>
-          <a:p>
-            <a:pPr algn="l">
-              <a:spcAft>
-                <a:spcPts val="0"/>
-              </a:spcAft>
-            </a:pPr>
-            <a:r>
-              <a:rPr sz="1350" b="0">
-                <a:solidFill>
-                  <a:srgbClr val="232323"/>
-                </a:solidFill>
-                <a:latin typeface="Arial"/>
-              </a:rPr>
-              <a:t>Dados, códigos e detalhes de preparação nem sempre estão disponíveis.</a:t>
-            </a:r>
-          </a:p>
-        </p:txBody>
-      </p:sp>
-      <p:sp>
-        <p:nvSpPr>
-          <p:cNvPr id="23" name="Rectangle 22"/>
-          <p:cNvSpPr/>
-          <p:nvPr/>
-        </p:nvSpPr>
-        <p:spPr>
-          <a:xfrm>
-            <a:off x="8183879" y="2971800"/>
-            <a:ext cx="3337560" cy="1417320"/>
-          </a:xfrm>
-          <a:prstGeom prst="rect">
-            <a:avLst/>
-          </a:prstGeom>
-          <a:solidFill>
-            <a:srgbClr val="FFFFFF"/>
-          </a:solidFill>
-          <a:ln>
-            <a:noFill/>
-          </a:ln>
-        </p:spPr>
-        <p:style>
-          <a:lnRef idx="1">
-            <a:schemeClr val="accent1"/>
-          </a:lnRef>
-          <a:fillRef idx="3">
-            <a:schemeClr val="accent1"/>
-          </a:fillRef>
-          <a:effectRef idx="2">
-            <a:schemeClr val="accent1"/>
-          </a:effectRef>
-          <a:fontRef idx="minor">
-            <a:schemeClr val="lt1"/>
-          </a:fontRef>
-        </p:style>
-        <p:txBody>
-          <a:bodyPr rtlCol="0" anchor="ctr"/>
-          <a:lstStyle/>
-          <a:p>
-            <a:pPr algn="ctr"/>
-          </a:p>
-        </p:txBody>
-      </p:sp>
-      <p:sp>
-        <p:nvSpPr>
-          <p:cNvPr id="24" name="Rectangle 23"/>
-          <p:cNvSpPr/>
-          <p:nvPr/>
-        </p:nvSpPr>
-        <p:spPr>
-          <a:xfrm>
-            <a:off x="8183879" y="2971800"/>
-            <a:ext cx="59436" cy="1417320"/>
-          </a:xfrm>
-          <a:prstGeom prst="rect">
-            <a:avLst/>
-          </a:prstGeom>
-          <a:solidFill>
-            <a:srgbClr val="4F46E5"/>
-          </a:solidFill>
-          <a:ln>
-            <a:noFill/>
-          </a:ln>
-        </p:spPr>
-        <p:style>
-          <a:lnRef idx="1">
-            <a:schemeClr val="accent1"/>
-          </a:lnRef>
-          <a:fillRef idx="3">
-            <a:schemeClr val="accent1"/>
-          </a:fillRef>
-          <a:effectRef idx="2">
-            <a:schemeClr val="accent1"/>
-          </a:effectRef>
-          <a:fontRef idx="minor">
-            <a:schemeClr val="lt1"/>
-          </a:fontRef>
-        </p:style>
-        <p:txBody>
-          <a:bodyPr rtlCol="0" anchor="ctr"/>
-          <a:lstStyle/>
-          <a:p>
-            <a:pPr algn="ctr"/>
-          </a:p>
-        </p:txBody>
-      </p:sp>
-      <p:sp>
-        <p:nvSpPr>
-          <p:cNvPr id="25" name="TextBox 24"/>
-          <p:cNvSpPr txBox="1"/>
-          <p:nvPr/>
-        </p:nvSpPr>
-        <p:spPr>
-          <a:xfrm>
-            <a:off x="8366759" y="3026664"/>
-            <a:ext cx="3063240" cy="384048"/>
-          </a:xfrm>
-          <a:prstGeom prst="rect">
-            <a:avLst/>
-          </a:prstGeom>
-          <a:noFill/>
-        </p:spPr>
-        <p:txBody>
-          <a:bodyPr wrap="square" lIns="54864" rIns="54864" tIns="54864" bIns="54864" anchor="t">
-            <a:spAutoFit/>
-          </a:bodyPr>
-          <a:lstStyle/>
-          <a:p>
-            <a:pPr algn="l">
-              <a:spcAft>
-                <a:spcPts val="0"/>
-              </a:spcAft>
-            </a:pPr>
-            <a:r>
-              <a:rPr sz="1500" b="1">
-                <a:solidFill>
-                  <a:srgbClr val="0F0F0F"/>
-                </a:solidFill>
-                <a:latin typeface="Arial"/>
-              </a:rPr>
-              <a:t>Contexto</a:t>
-            </a:r>
-          </a:p>
-        </p:txBody>
-      </p:sp>
-      <p:sp>
-        <p:nvSpPr>
-          <p:cNvPr id="26" name="TextBox 25"/>
-          <p:cNvSpPr txBox="1"/>
-          <p:nvPr/>
-        </p:nvSpPr>
-        <p:spPr>
-          <a:xfrm>
-            <a:off x="8366759" y="3429000"/>
-            <a:ext cx="3063240" cy="896113"/>
-          </a:xfrm>
-          <a:prstGeom prst="rect">
-            <a:avLst/>
-          </a:prstGeom>
-          <a:noFill/>
-        </p:spPr>
-        <p:txBody>
-          <a:bodyPr wrap="square" lIns="54864" rIns="54864" tIns="54864" bIns="54864" anchor="t">
-            <a:spAutoFit/>
-          </a:bodyPr>
-          <a:lstStyle/>
-          <a:p>
-            <a:pPr algn="l">
-              <a:spcAft>
-                <a:spcPts val="0"/>
-              </a:spcAft>
-            </a:pPr>
-            <a:r>
-              <a:rPr sz="1350" b="0">
-                <a:solidFill>
-                  <a:srgbClr val="232323"/>
-                </a:solidFill>
-                <a:latin typeface="Arial"/>
-              </a:rPr>
-              <a:t>Validações permanecem restritas a populações e cenários específicos.</a:t>
-            </a:r>
-          </a:p>
-        </p:txBody>
-      </p:sp>
-      <p:sp>
-        <p:nvSpPr>
-          <p:cNvPr id="27" name="TextBox 26"/>
-          <p:cNvSpPr txBox="1"/>
-          <p:nvPr/>
-        </p:nvSpPr>
-        <p:spPr>
-          <a:xfrm>
-            <a:off x="914400" y="5806440"/>
-            <a:ext cx="10241280" cy="292608"/>
-          </a:xfrm>
-          <a:prstGeom prst="rect">
-            <a:avLst/>
-          </a:prstGeom>
-          <a:noFill/>
-        </p:spPr>
-        <p:txBody>
-          <a:bodyPr wrap="square" lIns="54864" rIns="54864" tIns="54864" bIns="54864" anchor="t">
-            <a:spAutoFit/>
-          </a:bodyPr>
-          <a:lstStyle/>
-          <a:p>
-            <a:pPr algn="ctr">
-              <a:spcAft>
-                <a:spcPts val="0"/>
-              </a:spcAft>
-            </a:pPr>
-            <a:r>
-              <a:rPr sz="1400" b="0">
-                <a:solidFill>
-                  <a:srgbClr val="64748B"/>
-                </a:solidFill>
-                <a:latin typeface="Arial"/>
-              </a:rPr>
-              <a:t>Essas lacunas foram tratadas como requisitos de projeto — não como prova de que uma solução futura será eficaz.</a:t>
+              <a:t>Estes exemplos localizados não estimam a frequência da literatura. Quinze registros permanecem provisoriamente no núcleo; há 14 triagens S1/S2 e 11 apreciações por categoria, e o estudo 8 segue sem respostas até adjudicação da unidade. Um relatório não recuperado não recebeu MMAT; um registro foi excluído após resumo e um protocolo após texto completo.</a:t>
             </a:r>
           </a:p>
         </p:txBody>
@@ -12568,9 +12240,9 @@
                 <a:latin typeface="Arial"/>
               </a:rPr>
               <a:t>• um único pesquisador
-• parte da apreciação baseada em resumo/metadados
+• um texto integral pendente, sem MMAT
 • fontes e idiomas delimitados
-• MMAT preliminar
+• MMAT: 14 triagens, 11 apreciações por categoria; estudo 8 sem avaliação
 • sem aplicação funcional ou eficácia pedagógica própria</a:t>
             </a:r>
           </a:p>
@@ -12876,7 +12548,7 @@
                 <a:latin typeface="Arial"/>
               </a:rPr>
               <a:t>Thales Ferreira Batista · Ciência da Computação · IFC Videira
-Snapshot adjudicado: 03/09/2026 · recorte temporal: 2015–2026</a:t>
+Versão revisada: 15/10/2026 · corte da busca: 31/08/2026</a:t>
             </a:r>
           </a:p>
         </p:txBody>
@@ -13740,7 +13412,7 @@
                 </a:solidFill>
                 <a:latin typeface="Arial"/>
               </a:rPr>
-              <a:t>Como identificar e sintetizar, por meio de revisão sistemática, as principais técnicas computacionais aplicadas ao ensino de matemática e converter essas evidências em uma especificação de protótipo que apoie o professor?</a:t>
+              <a:t>Como estruturar uma especificação técnica e pedagógica de protótipo para apoiar a interpretação docente da aprendizagem matemática a partir das evidências e técnicas computacionais identificadas na literatura?</a:t>
             </a:r>
           </a:p>
         </p:txBody>
@@ -13904,7 +13576,7 @@
                 </a:solidFill>
                 <a:latin typeface="Arial"/>
               </a:rPr>
-              <a:t>Mapear e analisar sistematicamente as aplicações e elaborar uma especificação técnica e pedagógica para apoiar a interpretação de evidências sobre competências.</a:t>
+              <a:t>Propor uma especificação técnica e pedagógica de protótipo para apoiar a interpretação docente da aprendizagem matemática, fundamentada no mapeamento e na análise da literatura científica.</a:t>
             </a:r>
           </a:p>
         </p:txBody>
@@ -14120,8 +13792,8 @@
         </p:nvSpPr>
         <p:spPr>
           <a:xfrm>
-            <a:off x="685800" y="1143000"/>
-            <a:ext cx="5166360" cy="868680"/>
+            <a:off x="685800" y="1325880"/>
+            <a:ext cx="5166360" cy="1645920"/>
           </a:xfrm>
           <a:prstGeom prst="rect">
             <a:avLst/>
@@ -14163,8 +13835,8 @@
         </p:nvSpPr>
         <p:spPr>
           <a:xfrm>
-            <a:off x="685800" y="1143000"/>
-            <a:ext cx="59436" cy="868680"/>
+            <a:off x="685800" y="1325880"/>
+            <a:ext cx="59436" cy="1645920"/>
           </a:xfrm>
           <a:prstGeom prst="rect">
             <a:avLst/>
@@ -14206,7 +13878,7 @@
         </p:nvSpPr>
         <p:spPr>
           <a:xfrm>
-            <a:off x="868680" y="1197864"/>
+            <a:off x="868680" y="1380744"/>
             <a:ext cx="4892040" cy="384048"/>
           </a:xfrm>
           <a:prstGeom prst="rect">
@@ -14226,7 +13898,7 @@
               </a:spcAft>
             </a:pPr>
             <a:r>
-              <a:rPr sz="1500" b="1">
+              <a:rPr sz="1900" b="1">
                 <a:solidFill>
                   <a:srgbClr val="0F0F0F"/>
                 </a:solidFill>
@@ -14245,8 +13917,8 @@
         </p:nvSpPr>
         <p:spPr>
           <a:xfrm>
-            <a:off x="868680" y="1600200"/>
-            <a:ext cx="4892040" cy="347473"/>
+            <a:off x="868680" y="1783080"/>
+            <a:ext cx="4892040" cy="1124713"/>
           </a:xfrm>
           <a:prstGeom prst="rect">
             <a:avLst/>
@@ -14265,13 +13937,13 @@
               </a:spcAft>
             </a:pPr>
             <a:r>
-              <a:rPr sz="1350" b="0">
+              <a:rPr sz="1800" b="0">
                 <a:solidFill>
                   <a:srgbClr val="232323"/>
                 </a:solidFill>
                 <a:latin typeface="Arial"/>
               </a:rPr>
-              <a:t>Revisão sistemática, relatada com apoio do PRISMA 2020, sobre estudos de 2015–2026.</a:t>
+              <a:t>Categorizar técnicas computacionais e finalidades pedagógicas na literatura mapeada.</a:t>
             </a:r>
           </a:p>
         </p:txBody>
@@ -14284,8 +13956,8 @@
         </p:nvSpPr>
         <p:spPr>
           <a:xfrm>
-            <a:off x="685800" y="2286000"/>
-            <a:ext cx="5166360" cy="868680"/>
+            <a:off x="685800" y="3337560"/>
+            <a:ext cx="5166360" cy="1645920"/>
           </a:xfrm>
           <a:prstGeom prst="rect">
             <a:avLst/>
@@ -14327,8 +13999,8 @@
         </p:nvSpPr>
         <p:spPr>
           <a:xfrm>
-            <a:off x="685800" y="2286000"/>
-            <a:ext cx="59436" cy="868680"/>
+            <a:off x="685800" y="3337560"/>
+            <a:ext cx="59436" cy="1645920"/>
           </a:xfrm>
           <a:prstGeom prst="rect">
             <a:avLst/>
@@ -14370,7 +14042,7 @@
         </p:nvSpPr>
         <p:spPr>
           <a:xfrm>
-            <a:off x="868680" y="2340864"/>
+            <a:off x="868680" y="3392424"/>
             <a:ext cx="4892040" cy="384048"/>
           </a:xfrm>
           <a:prstGeom prst="rect">
@@ -14390,7 +14062,7 @@
               </a:spcAft>
             </a:pPr>
             <a:r>
-              <a:rPr sz="1500" b="1">
+              <a:rPr sz="1900" b="1">
                 <a:solidFill>
                   <a:srgbClr val="0F0F0F"/>
                 </a:solidFill>
@@ -14409,8 +14081,8 @@
         </p:nvSpPr>
         <p:spPr>
           <a:xfrm>
-            <a:off x="868680" y="2743200"/>
-            <a:ext cx="4892040" cy="347473"/>
+            <a:off x="868680" y="3794760"/>
+            <a:ext cx="4892040" cy="1124713"/>
           </a:xfrm>
           <a:prstGeom prst="rect">
             <a:avLst/>
@@ -14429,13 +14101,13 @@
               </a:spcAft>
             </a:pPr>
             <a:r>
-              <a:rPr sz="1350" b="0">
+              <a:rPr sz="1800" b="0">
                 <a:solidFill>
                   <a:srgbClr val="232323"/>
                 </a:solidFill>
                 <a:latin typeface="Arial"/>
               </a:rPr>
-              <a:t>Identificação e categorização das abordagens computacionais.</a:t>
+              <a:t>Identificar limitações e lacunas técnicas, pedagógicas, metodológicas e éticas.</a:t>
             </a:r>
           </a:p>
         </p:txBody>
@@ -14448,8 +14120,8 @@
         </p:nvSpPr>
         <p:spPr>
           <a:xfrm>
-            <a:off x="685800" y="3429000"/>
-            <a:ext cx="5166360" cy="868680"/>
+            <a:off x="6309360" y="1325880"/>
+            <a:ext cx="5166360" cy="1645920"/>
           </a:xfrm>
           <a:prstGeom prst="rect">
             <a:avLst/>
@@ -14491,14 +14163,14 @@
         </p:nvSpPr>
         <p:spPr>
           <a:xfrm>
-            <a:off x="685800" y="3429000"/>
-            <a:ext cx="59436" cy="868680"/>
-          </a:xfrm>
-          <a:prstGeom prst="rect">
-            <a:avLst/>
-          </a:prstGeom>
-          <a:solidFill>
-            <a:srgbClr val="2563EB"/>
+            <a:off x="6309360" y="1325880"/>
+            <a:ext cx="59436" cy="1645920"/>
+          </a:xfrm>
+          <a:prstGeom prst="rect">
+            <a:avLst/>
+          </a:prstGeom>
+          <a:solidFill>
+            <a:srgbClr val="0D9488"/>
           </a:solidFill>
           <a:ln>
             <a:noFill/>
@@ -14534,7 +14206,7 @@
         </p:nvSpPr>
         <p:spPr>
           <a:xfrm>
-            <a:off x="868680" y="3483864"/>
+            <a:off x="6492240" y="1380744"/>
             <a:ext cx="4892040" cy="384048"/>
           </a:xfrm>
           <a:prstGeom prst="rect">
@@ -14554,7 +14226,7 @@
               </a:spcAft>
             </a:pPr>
             <a:r>
-              <a:rPr sz="1500" b="1">
+              <a:rPr sz="1900" b="1">
                 <a:solidFill>
                   <a:srgbClr val="0F0F0F"/>
                 </a:solidFill>
@@ -14573,8 +14245,8 @@
         </p:nvSpPr>
         <p:spPr>
           <a:xfrm>
-            <a:off x="868680" y="3886200"/>
-            <a:ext cx="4892040" cy="347473"/>
+            <a:off x="6492240" y="1783080"/>
+            <a:ext cx="4892040" cy="1124713"/>
           </a:xfrm>
           <a:prstGeom prst="rect">
             <a:avLst/>
@@ -14593,13 +14265,13 @@
               </a:spcAft>
             </a:pPr>
             <a:r>
-              <a:rPr sz="1350" b="0">
+              <a:rPr sz="1800" b="0">
                 <a:solidFill>
                   <a:srgbClr val="232323"/>
                 </a:solidFill>
                 <a:latin typeface="Arial"/>
               </a:rPr>
-              <a:t>Classificação das finalidades pedagógicas das aplicações.</a:t>
+              <a:t>Formular requisitos, critérios de dados e modelos e arquitetura de referência para o protótipo.</a:t>
             </a:r>
           </a:p>
         </p:txBody>
@@ -14612,8 +14284,8 @@
         </p:nvSpPr>
         <p:spPr>
           <a:xfrm>
-            <a:off x="685800" y="4572000"/>
-            <a:ext cx="5166360" cy="868680"/>
+            <a:off x="6309360" y="3337560"/>
+            <a:ext cx="5166360" cy="1645920"/>
           </a:xfrm>
           <a:prstGeom prst="rect">
             <a:avLst/>
@@ -14655,14 +14327,14 @@
         </p:nvSpPr>
         <p:spPr>
           <a:xfrm>
-            <a:off x="685800" y="4572000"/>
-            <a:ext cx="59436" cy="868680"/>
-          </a:xfrm>
-          <a:prstGeom prst="rect">
-            <a:avLst/>
-          </a:prstGeom>
-          <a:solidFill>
-            <a:srgbClr val="2563EB"/>
+            <a:off x="6309360" y="3337560"/>
+            <a:ext cx="59436" cy="1645920"/>
+          </a:xfrm>
+          <a:prstGeom prst="rect">
+            <a:avLst/>
+          </a:prstGeom>
+          <a:solidFill>
+            <a:srgbClr val="0D9488"/>
           </a:solidFill>
           <a:ln>
             <a:noFill/>
@@ -14698,7 +14370,7 @@
         </p:nvSpPr>
         <p:spPr>
           <a:xfrm>
-            <a:off x="868680" y="4626864"/>
+            <a:off x="6492240" y="3392424"/>
             <a:ext cx="4892040" cy="384048"/>
           </a:xfrm>
           <a:prstGeom prst="rect">
@@ -14718,7 +14390,7 @@
               </a:spcAft>
             </a:pPr>
             <a:r>
-              <a:rPr sz="1500" b="1">
+              <a:rPr sz="1900" b="1">
                 <a:solidFill>
                   <a:srgbClr val="0F0F0F"/>
                 </a:solidFill>
@@ -14737,8 +14409,8 @@
         </p:nvSpPr>
         <p:spPr>
           <a:xfrm>
-            <a:off x="868680" y="5029200"/>
-            <a:ext cx="4892040" cy="347473"/>
+            <a:off x="6492240" y="3794760"/>
+            <a:ext cx="4892040" cy="1124713"/>
           </a:xfrm>
           <a:prstGeom prst="rect">
             <a:avLst/>
@@ -14757,113 +14429,27 @@
               </a:spcAft>
             </a:pPr>
             <a:r>
-              <a:rPr sz="1350" b="0">
+              <a:rPr sz="1800" b="0">
                 <a:solidFill>
                   <a:srgbClr val="232323"/>
                 </a:solidFill>
                 <a:latin typeface="Arial"/>
               </a:rPr>
-              <a:t>Análise crítica das metodologias e limitações dos estudos.</a:t>
-            </a:r>
-          </a:p>
-        </p:txBody>
-      </p:sp>
-      <p:sp>
-        <p:nvSpPr>
-          <p:cNvPr id="19" name="Rectangle 18"/>
-          <p:cNvSpPr/>
-          <p:nvPr/>
-        </p:nvSpPr>
-        <p:spPr>
-          <a:xfrm>
-            <a:off x="6309360" y="1143000"/>
-            <a:ext cx="5166360" cy="1143000"/>
-          </a:xfrm>
-          <a:prstGeom prst="rect">
-            <a:avLst/>
-          </a:prstGeom>
-          <a:solidFill>
-            <a:srgbClr val="FFFFFF"/>
-          </a:solidFill>
-          <a:ln>
-            <a:noFill/>
-          </a:ln>
-        </p:spPr>
-        <p:style>
-          <a:lnRef idx="1">
-            <a:schemeClr val="accent1"/>
-          </a:lnRef>
-          <a:fillRef idx="3">
-            <a:schemeClr val="accent1"/>
-          </a:fillRef>
-          <a:effectRef idx="2">
-            <a:schemeClr val="accent1"/>
-          </a:effectRef>
-          <a:fontRef idx="minor">
-            <a:schemeClr val="lt1"/>
-          </a:fontRef>
-        </p:style>
-        <p:txBody>
-          <a:bodyPr rtlCol="0" anchor="ctr"/>
-          <a:lstStyle/>
-          <a:p>
-            <a:pPr algn="ctr"/>
-          </a:p>
-        </p:txBody>
-      </p:sp>
-      <p:sp>
-        <p:nvSpPr>
-          <p:cNvPr id="20" name="Rectangle 19"/>
-          <p:cNvSpPr/>
-          <p:nvPr/>
-        </p:nvSpPr>
-        <p:spPr>
-          <a:xfrm>
-            <a:off x="6309360" y="1143000"/>
-            <a:ext cx="59436" cy="1143000"/>
-          </a:xfrm>
-          <a:prstGeom prst="rect">
-            <a:avLst/>
-          </a:prstGeom>
-          <a:solidFill>
-            <a:srgbClr val="0D9488"/>
-          </a:solidFill>
-          <a:ln>
-            <a:noFill/>
-          </a:ln>
-        </p:spPr>
-        <p:style>
-          <a:lnRef idx="1">
-            <a:schemeClr val="accent1"/>
-          </a:lnRef>
-          <a:fillRef idx="3">
-            <a:schemeClr val="accent1"/>
-          </a:fillRef>
-          <a:effectRef idx="2">
-            <a:schemeClr val="accent1"/>
-          </a:effectRef>
-          <a:fontRef idx="minor">
-            <a:schemeClr val="lt1"/>
-          </a:fontRef>
-        </p:style>
-        <p:txBody>
-          <a:bodyPr rtlCol="0" anchor="ctr"/>
-          <a:lstStyle/>
-          <a:p>
-            <a:pPr algn="ctr"/>
-          </a:p>
-        </p:txBody>
-      </p:sp>
-      <p:sp>
-        <p:nvSpPr>
-          <p:cNvPr id="21" name="TextBox 20"/>
+              <a:t>Propor um protocolo para avaliar a viabilidade e a coerência da especificação conceitual; aplicação pendente.</a:t>
+            </a:r>
+          </a:p>
+        </p:txBody>
+      </p:sp>
+      <p:sp>
+        <p:nvSpPr>
+          <p:cNvPr id="19" name="TextBox 18"/>
           <p:cNvSpPr txBox="1"/>
           <p:nvPr/>
         </p:nvSpPr>
         <p:spPr>
           <a:xfrm>
-            <a:off x="6492240" y="1197864"/>
-            <a:ext cx="4892040" cy="384048"/>
+            <a:off x="914400" y="5669280"/>
+            <a:ext cx="10287000" cy="594360"/>
           </a:xfrm>
           <a:prstGeom prst="rect">
             <a:avLst/>
@@ -14876,425 +14462,19 @@
           </a:bodyPr>
           <a:lstStyle/>
           <a:p>
-            <a:pPr algn="l">
+            <a:pPr algn="ctr">
               <a:spcAft>
                 <a:spcPts val="0"/>
               </a:spcAft>
             </a:pPr>
             <a:r>
-              <a:rPr sz="1500" b="1">
-                <a:solidFill>
-                  <a:srgbClr val="0F0F0F"/>
+              <a:rPr sz="1400" b="0">
+                <a:solidFill>
+                  <a:srgbClr val="64748B"/>
                 </a:solidFill>
                 <a:latin typeface="Arial"/>
               </a:rPr>
-              <a:t>OE5</a:t>
-            </a:r>
-          </a:p>
-        </p:txBody>
-      </p:sp>
-      <p:sp>
-        <p:nvSpPr>
-          <p:cNvPr id="22" name="TextBox 21"/>
-          <p:cNvSpPr txBox="1"/>
-          <p:nvPr/>
-        </p:nvSpPr>
-        <p:spPr>
-          <a:xfrm>
-            <a:off x="6492240" y="1600200"/>
-            <a:ext cx="4892040" cy="621793"/>
-          </a:xfrm>
-          <a:prstGeom prst="rect">
-            <a:avLst/>
-          </a:prstGeom>
-          <a:noFill/>
-        </p:spPr>
-        <p:txBody>
-          <a:bodyPr wrap="square" lIns="54864" rIns="54864" tIns="54864" bIns="54864" anchor="t">
-            <a:spAutoFit/>
-          </a:bodyPr>
-          <a:lstStyle/>
-          <a:p>
-            <a:pPr algn="l">
-              <a:spcAft>
-                <a:spcPts val="0"/>
-              </a:spcAft>
-            </a:pPr>
-            <a:r>
-              <a:rPr sz="1350" b="0">
-                <a:solidFill>
-                  <a:srgbClr val="232323"/>
-                </a:solidFill>
-                <a:latin typeface="Arial"/>
-              </a:rPr>
-              <a:t>Mapeamento de lacunas técnicas, pedagógicas, metodológicas e éticas.</a:t>
-            </a:r>
-          </a:p>
-        </p:txBody>
-      </p:sp>
-      <p:sp>
-        <p:nvSpPr>
-          <p:cNvPr id="23" name="Rectangle 22"/>
-          <p:cNvSpPr/>
-          <p:nvPr/>
-        </p:nvSpPr>
-        <p:spPr>
-          <a:xfrm>
-            <a:off x="6309360" y="2560320"/>
-            <a:ext cx="5166360" cy="1143000"/>
-          </a:xfrm>
-          <a:prstGeom prst="rect">
-            <a:avLst/>
-          </a:prstGeom>
-          <a:solidFill>
-            <a:srgbClr val="FFFFFF"/>
-          </a:solidFill>
-          <a:ln>
-            <a:noFill/>
-          </a:ln>
-        </p:spPr>
-        <p:style>
-          <a:lnRef idx="1">
-            <a:schemeClr val="accent1"/>
-          </a:lnRef>
-          <a:fillRef idx="3">
-            <a:schemeClr val="accent1"/>
-          </a:fillRef>
-          <a:effectRef idx="2">
-            <a:schemeClr val="accent1"/>
-          </a:effectRef>
-          <a:fontRef idx="minor">
-            <a:schemeClr val="lt1"/>
-          </a:fontRef>
-        </p:style>
-        <p:txBody>
-          <a:bodyPr rtlCol="0" anchor="ctr"/>
-          <a:lstStyle/>
-          <a:p>
-            <a:pPr algn="ctr"/>
-          </a:p>
-        </p:txBody>
-      </p:sp>
-      <p:sp>
-        <p:nvSpPr>
-          <p:cNvPr id="24" name="Rectangle 23"/>
-          <p:cNvSpPr/>
-          <p:nvPr/>
-        </p:nvSpPr>
-        <p:spPr>
-          <a:xfrm>
-            <a:off x="6309360" y="2560320"/>
-            <a:ext cx="59436" cy="1143000"/>
-          </a:xfrm>
-          <a:prstGeom prst="rect">
-            <a:avLst/>
-          </a:prstGeom>
-          <a:solidFill>
-            <a:srgbClr val="0D9488"/>
-          </a:solidFill>
-          <a:ln>
-            <a:noFill/>
-          </a:ln>
-        </p:spPr>
-        <p:style>
-          <a:lnRef idx="1">
-            <a:schemeClr val="accent1"/>
-          </a:lnRef>
-          <a:fillRef idx="3">
-            <a:schemeClr val="accent1"/>
-          </a:fillRef>
-          <a:effectRef idx="2">
-            <a:schemeClr val="accent1"/>
-          </a:effectRef>
-          <a:fontRef idx="minor">
-            <a:schemeClr val="lt1"/>
-          </a:fontRef>
-        </p:style>
-        <p:txBody>
-          <a:bodyPr rtlCol="0" anchor="ctr"/>
-          <a:lstStyle/>
-          <a:p>
-            <a:pPr algn="ctr"/>
-          </a:p>
-        </p:txBody>
-      </p:sp>
-      <p:sp>
-        <p:nvSpPr>
-          <p:cNvPr id="25" name="TextBox 24"/>
-          <p:cNvSpPr txBox="1"/>
-          <p:nvPr/>
-        </p:nvSpPr>
-        <p:spPr>
-          <a:xfrm>
-            <a:off x="6492240" y="2615184"/>
-            <a:ext cx="4892040" cy="384048"/>
-          </a:xfrm>
-          <a:prstGeom prst="rect">
-            <a:avLst/>
-          </a:prstGeom>
-          <a:noFill/>
-        </p:spPr>
-        <p:txBody>
-          <a:bodyPr wrap="square" lIns="54864" rIns="54864" tIns="54864" bIns="54864" anchor="t">
-            <a:spAutoFit/>
-          </a:bodyPr>
-          <a:lstStyle/>
-          <a:p>
-            <a:pPr algn="l">
-              <a:spcAft>
-                <a:spcPts val="0"/>
-              </a:spcAft>
-            </a:pPr>
-            <a:r>
-              <a:rPr sz="1500" b="1">
-                <a:solidFill>
-                  <a:srgbClr val="0F0F0F"/>
-                </a:solidFill>
-                <a:latin typeface="Arial"/>
-              </a:rPr>
-              <a:t>OE6</a:t>
-            </a:r>
-          </a:p>
-        </p:txBody>
-      </p:sp>
-      <p:sp>
-        <p:nvSpPr>
-          <p:cNvPr id="26" name="TextBox 25"/>
-          <p:cNvSpPr txBox="1"/>
-          <p:nvPr/>
-        </p:nvSpPr>
-        <p:spPr>
-          <a:xfrm>
-            <a:off x="6492240" y="3017520"/>
-            <a:ext cx="4892040" cy="621793"/>
-          </a:xfrm>
-          <a:prstGeom prst="rect">
-            <a:avLst/>
-          </a:prstGeom>
-          <a:noFill/>
-        </p:spPr>
-        <p:txBody>
-          <a:bodyPr wrap="square" lIns="54864" rIns="54864" tIns="54864" bIns="54864" anchor="t">
-            <a:spAutoFit/>
-          </a:bodyPr>
-          <a:lstStyle/>
-          <a:p>
-            <a:pPr algn="l">
-              <a:spcAft>
-                <a:spcPts val="0"/>
-              </a:spcAft>
-            </a:pPr>
-            <a:r>
-              <a:rPr sz="1350" b="0">
-                <a:solidFill>
-                  <a:srgbClr val="232323"/>
-                </a:solidFill>
-                <a:latin typeface="Arial"/>
-              </a:rPr>
-              <a:t>Manutenção de um pipeline automatizado e auditável para coleta, processamento e exportação.</a:t>
-            </a:r>
-          </a:p>
-        </p:txBody>
-      </p:sp>
-      <p:sp>
-        <p:nvSpPr>
-          <p:cNvPr id="27" name="Rectangle 26"/>
-          <p:cNvSpPr/>
-          <p:nvPr/>
-        </p:nvSpPr>
-        <p:spPr>
-          <a:xfrm>
-            <a:off x="6309360" y="3977639"/>
-            <a:ext cx="5166360" cy="1143000"/>
-          </a:xfrm>
-          <a:prstGeom prst="rect">
-            <a:avLst/>
-          </a:prstGeom>
-          <a:solidFill>
-            <a:srgbClr val="FFFFFF"/>
-          </a:solidFill>
-          <a:ln>
-            <a:noFill/>
-          </a:ln>
-        </p:spPr>
-        <p:style>
-          <a:lnRef idx="1">
-            <a:schemeClr val="accent1"/>
-          </a:lnRef>
-          <a:fillRef idx="3">
-            <a:schemeClr val="accent1"/>
-          </a:fillRef>
-          <a:effectRef idx="2">
-            <a:schemeClr val="accent1"/>
-          </a:effectRef>
-          <a:fontRef idx="minor">
-            <a:schemeClr val="lt1"/>
-          </a:fontRef>
-        </p:style>
-        <p:txBody>
-          <a:bodyPr rtlCol="0" anchor="ctr"/>
-          <a:lstStyle/>
-          <a:p>
-            <a:pPr algn="ctr"/>
-          </a:p>
-        </p:txBody>
-      </p:sp>
-      <p:sp>
-        <p:nvSpPr>
-          <p:cNvPr id="28" name="Rectangle 27"/>
-          <p:cNvSpPr/>
-          <p:nvPr/>
-        </p:nvSpPr>
-        <p:spPr>
-          <a:xfrm>
-            <a:off x="6309360" y="3977639"/>
-            <a:ext cx="59436" cy="1143000"/>
-          </a:xfrm>
-          <a:prstGeom prst="rect">
-            <a:avLst/>
-          </a:prstGeom>
-          <a:solidFill>
-            <a:srgbClr val="0D9488"/>
-          </a:solidFill>
-          <a:ln>
-            <a:noFill/>
-          </a:ln>
-        </p:spPr>
-        <p:style>
-          <a:lnRef idx="1">
-            <a:schemeClr val="accent1"/>
-          </a:lnRef>
-          <a:fillRef idx="3">
-            <a:schemeClr val="accent1"/>
-          </a:fillRef>
-          <a:effectRef idx="2">
-            <a:schemeClr val="accent1"/>
-          </a:effectRef>
-          <a:fontRef idx="minor">
-            <a:schemeClr val="lt1"/>
-          </a:fontRef>
-        </p:style>
-        <p:txBody>
-          <a:bodyPr rtlCol="0" anchor="ctr"/>
-          <a:lstStyle/>
-          <a:p>
-            <a:pPr algn="ctr"/>
-          </a:p>
-        </p:txBody>
-      </p:sp>
-      <p:sp>
-        <p:nvSpPr>
-          <p:cNvPr id="29" name="TextBox 28"/>
-          <p:cNvSpPr txBox="1"/>
-          <p:nvPr/>
-        </p:nvSpPr>
-        <p:spPr>
-          <a:xfrm>
-            <a:off x="6492240" y="4032503"/>
-            <a:ext cx="4892040" cy="384048"/>
-          </a:xfrm>
-          <a:prstGeom prst="rect">
-            <a:avLst/>
-          </a:prstGeom>
-          <a:noFill/>
-        </p:spPr>
-        <p:txBody>
-          <a:bodyPr wrap="square" lIns="54864" rIns="54864" tIns="54864" bIns="54864" anchor="t">
-            <a:spAutoFit/>
-          </a:bodyPr>
-          <a:lstStyle/>
-          <a:p>
-            <a:pPr algn="l">
-              <a:spcAft>
-                <a:spcPts val="0"/>
-              </a:spcAft>
-            </a:pPr>
-            <a:r>
-              <a:rPr sz="1500" b="1">
-                <a:solidFill>
-                  <a:srgbClr val="0F0F0F"/>
-                </a:solidFill>
-                <a:latin typeface="Arial"/>
-              </a:rPr>
-              <a:t>OE7</a:t>
-            </a:r>
-          </a:p>
-        </p:txBody>
-      </p:sp>
-      <p:sp>
-        <p:nvSpPr>
-          <p:cNvPr id="30" name="TextBox 29"/>
-          <p:cNvSpPr txBox="1"/>
-          <p:nvPr/>
-        </p:nvSpPr>
-        <p:spPr>
-          <a:xfrm>
-            <a:off x="6492240" y="4434839"/>
-            <a:ext cx="4892040" cy="621793"/>
-          </a:xfrm>
-          <a:prstGeom prst="rect">
-            <a:avLst/>
-          </a:prstGeom>
-          <a:noFill/>
-        </p:spPr>
-        <p:txBody>
-          <a:bodyPr wrap="square" lIns="54864" rIns="54864" tIns="54864" bIns="54864" anchor="t">
-            <a:spAutoFit/>
-          </a:bodyPr>
-          <a:lstStyle/>
-          <a:p>
-            <a:pPr algn="l">
-              <a:spcAft>
-                <a:spcPts val="0"/>
-              </a:spcAft>
-            </a:pPr>
-            <a:r>
-              <a:rPr sz="1350" b="0">
-                <a:solidFill>
-                  <a:srgbClr val="232323"/>
-                </a:solidFill>
-                <a:latin typeface="Arial"/>
-              </a:rPr>
-              <a:t>Derivação de requisitos, critérios de dados e modelos, protocolo de avaliação e arquitetura de referência.</a:t>
-            </a:r>
-          </a:p>
-        </p:txBody>
-      </p:sp>
-      <p:sp>
-        <p:nvSpPr>
-          <p:cNvPr id="31" name="TextBox 30"/>
-          <p:cNvSpPr txBox="1"/>
-          <p:nvPr/>
-        </p:nvSpPr>
-        <p:spPr>
-          <a:xfrm>
-            <a:off x="914400" y="5897880"/>
-            <a:ext cx="10287000" cy="384048"/>
-          </a:xfrm>
-          <a:prstGeom prst="rect">
-            <a:avLst/>
-          </a:prstGeom>
-          <a:noFill/>
-        </p:spPr>
-        <p:txBody>
-          <a:bodyPr wrap="square" lIns="54864" rIns="54864" tIns="54864" bIns="54864" anchor="t">
-            <a:spAutoFit/>
-          </a:bodyPr>
-          <a:lstStyle/>
-          <a:p>
-            <a:pPr algn="ctr">
-              <a:spcAft>
-                <a:spcPts val="0"/>
-              </a:spcAft>
-            </a:pPr>
-            <a:r>
-              <a:rPr sz="1400" b="0">
-                <a:solidFill>
-                  <a:srgbClr val="64748B"/>
-                </a:solidFill>
-                <a:latin typeface="Arial"/>
-              </a:rPr>
-              <a:t>A apresentação distingue objetivos executados de atividades que permanecem fora do escopo, como implementação funcional e validação com participantes.</a:t>
+              <a:t>Revisão, MMAT preliminar e pipeline são meios. O protocolo proposto avalia a especificação conceitual; aplicação pendente. Experimento do protótipo é contingência.</a:t>
             </a:r>
           </a:p>
         </p:txBody>
@@ -15892,7 +15072,7 @@
                 </a:solidFill>
                 <a:latin typeface="Arial"/>
               </a:rPr>
-              <a:t>Mobilização integrada de conhecimentos, procedimentos, estratégias e atitudes.</a:t>
+              <a:t>Mobilização de conhecimentos, habilidades, atitudes e valores para resolver demandas.</a:t>
             </a:r>
           </a:p>
         </p:txBody>
@@ -16056,7 +15236,7 @@
                 </a:solidFill>
                 <a:latin typeface="Arial"/>
               </a:rPr>
-              <a:t>Transformação construída ao longo do tempo, com compreensão, autonomia e transferência.</a:t>
+              <a:t>Neste TCC: mudanças no que o estudante sabe e consegue fazer ao longo do tempo.</a:t>
             </a:r>
           </a:p>
         </p:txBody>
@@ -17084,7 +16264,7 @@
                 </a:solidFill>
                 <a:latin typeface="Arial"/>
               </a:rPr>
-              <a:t>Do registro bruto à população retida</a:t>
+              <a:t>Do registro bruto ao conjunto retido provisoriamente</a:t>
             </a:r>
           </a:p>
         </p:txBody>
@@ -17123,7 +16303,7 @@
                 </a:solidFill>
                 <a:latin typeface="Arial"/>
               </a:rPr>
-              <a:t>Contagens do snapshot adjudicado</a:t>
+              <a:t>Contagens do recorte versionado</a:t>
             </a:r>
           </a:p>
         </p:txBody>
@@ -17944,7 +17124,7 @@
                 </a:solidFill>
                 <a:latin typeface="Arial"/>
               </a:rPr>
-              <a:t>na elegibilidade</a:t>
+              <a:t>submetidos à priorização</a:t>
             </a:r>
           </a:p>
         </p:txBody>
@@ -18108,7 +17288,7 @@
                 </a:solidFill>
                 <a:latin typeface="Arial"/>
               </a:rPr>
-              <a:t>excluídos na elegibilidade</a:t>
+              <a:t>excluídos nessa etapa</a:t>
             </a:r>
           </a:p>
         </p:txBody>
@@ -18285,8 +17465,8 @@
         </p:nvSpPr>
         <p:spPr>
           <a:xfrm>
-            <a:off x="1005840" y="5669280"/>
-            <a:ext cx="10058400" cy="320040"/>
+            <a:off x="777240" y="5623560"/>
+            <a:ext cx="10607040" cy="411480"/>
           </a:xfrm>
           <a:prstGeom prst="rect">
             <a:avLst/>
@@ -18305,13 +17485,13 @@
               </a:spcAft>
             </a:pPr>
             <a:r>
-              <a:rPr sz="1400" b="0">
+              <a:rPr sz="1150" b="0">
                 <a:solidFill>
                   <a:srgbClr val="64748B"/>
                 </a:solidFill>
                 <a:latin typeface="Arial"/>
               </a:rPr>
-              <a:t>A remoção determinística por DOI/URL precede a triagem. Igualdade de título permaneceu como candidato à auditoria semântica.</a:t>
+              <a:t>A priorização dos 2.486 registros usa metadados/resumos e não equivale à elegibilidade em texto completo; títulos repetidos seguem para auditoria semântica.</a:t>
             </a:r>
           </a:p>
         </p:txBody>
@@ -18376,7 +17556,7 @@
                 </a:solidFill>
                 <a:latin typeface="Arial"/>
               </a:rPr>
-              <a:t>Fluxo PRISMA do snapshot</a:t>
+              <a:t>Fluxo operacional do processo de seleção</a:t>
             </a:r>
           </a:p>
         </p:txBody>
@@ -18397,8 +17577,8 @@
         </p:blipFill>
         <p:spPr>
           <a:xfrm>
-            <a:off x="2359571" y="960120"/>
-            <a:ext cx="7488097" cy="5212080"/>
+            <a:off x="1470660" y="960120"/>
+            <a:ext cx="9265920" cy="5212080"/>
           </a:xfrm>
           <a:prstGeom prst="rect">
             <a:avLst/>
@@ -18439,7 +17619,7 @@
                 </a:solidFill>
                 <a:latin typeface="Arial"/>
               </a:rPr>
-              <a:t>Figura versionada e sincronizada com os artefatos públicos do pipeline.</a:t>
+              <a:t>Representação operacional própria; não reproduz todas as etapas do diagrama PRISMA 2020.</a:t>
             </a:r>
           </a:p>
         </p:txBody>
@@ -18525,8 +17705,8 @@
         </p:blipFill>
         <p:spPr>
           <a:xfrm>
-            <a:off x="640080" y="1649878"/>
-            <a:ext cx="5623560" cy="3741123"/>
+            <a:off x="640080" y="1650666"/>
+            <a:ext cx="5623560" cy="3739548"/>
           </a:xfrm>
           <a:prstGeom prst="rect">
             <a:avLst/>

</xml_diff>

<commit_message>
:books: docs(research): appraise unresolved MMAT studies with explicit operational routes
</commit_message>
<xml_diff>
--- a/results/tcc/presentation/ensino_personalizado_de_matematica_tcc.pptx
+++ b/results/tcc/presentation/ensino_personalizado_de_matematica_tcc.pptx
@@ -7830,7 +7830,7 @@
                 </a:solidFill>
                 <a:latin typeface="Arial"/>
               </a:rPr>
-              <a:t>Dos 18 registros selecionados preliminarmente, um foi excluído após o resumo. Dos 17 relatórios procurados, um não foi recuperado e 16 foram avaliados em texto completo; um protocolo sem resultados concluídos foi excluído após essa avaliação e 15 registros empíricos permanecem provisoriamente no núcleo. O estudo 8 aguarda adjudicação de elegibilidade e unidade de análise; o relatório não recuperado não recebeu MMAT.</a:t>
+              <a:t>Dos 18 registros selecionados preliminarmente, um foi excluído após o resumo. Dos 17 relatórios procurados, um não foi recuperado e 16 foram avaliados em texto completo; um protocolo sem resultados concluídos foi excluído após essa avaliação e 15 registros empíricos permanecem provisoriamente no núcleo. Os 15 estudos têm apreciação preliminar, incluindo rotas operacionais explícitas; o relatório não recuperado não recebeu MMAT.</a:t>
             </a:r>
           </a:p>
         </p:txBody>
@@ -8587,7 +8587,7 @@
                 </a:solidFill>
                 <a:latin typeface="Arial"/>
               </a:rPr>
-              <a:t>15 registros provisórios. S1/S2: 14; Q1–Q5: 11. Estudos 5, 7 e 14 aguardam categoria; estudo 8 aguarda unidade. Um texto não recuperado, sem MMAT. Conferência humana pendente.</a:t>
+              <a:t>15 registros provisórios. S1/S2 e Q1–Q5: 15. Estudos 5/7: categoria 3 operacional; 14: sorteio contraditório; 8: categoria 4 adaptada. Um texto não recuperado, sem MMAT. Conferência humana pendente.</a:t>
             </a:r>
           </a:p>
         </p:txBody>
@@ -10310,7 +10310,7 @@
                 </a:solidFill>
                 <a:latin typeface="Arial"/>
               </a:rPr>
-              <a:t>Estes exemplos localizados não estimam a frequência da literatura. Quinze registros permanecem provisoriamente no núcleo; há 14 triagens S1/S2 e 11 apreciações por categoria, e o estudo 8 segue sem respostas até adjudicação da unidade. Um relatório não recuperado não recebeu MMAT; um registro foi excluído após resumo e um protocolo após texto completo.</a:t>
+              <a:t>Estes exemplos localizados não estimam a frequência da literatura. Quinze registros permanecem provisoriamente no núcleo; há 15 triagens S1/S2 e 15 apreciações por categoria, com rotas operacionais explicitamente limitadas. Um relatório não recuperado não recebeu MMAT; um registro foi excluído após resumo e um protocolo após texto completo.</a:t>
             </a:r>
           </a:p>
         </p:txBody>
@@ -12242,7 +12242,7 @@
               <a:t>• um único pesquisador
 • um texto integral pendente, sem MMAT
 • fontes e idiomas delimitados
-• MMAT: 14 triagens, 11 apreciações por categoria; estudo 8 sem avaliação
+• MMAT: 15 triagens e apreciações; rotas operacionais e conferência humana pendente
 • sem aplicação funcional ou eficácia pedagógica própria</a:t>
             </a:r>
           </a:p>

</xml_diff>

<commit_message>
:books: docs(research): appraise four MMAT studies with bounded operational routes (#120)
* :books: docs(tcc): prepare MMAT appraisal decision brief

* :books: docs(research): appraise unresolved MMAT studies with explicit operational routes
</commit_message>
<xml_diff>
--- a/results/tcc/presentation/ensino_personalizado_de_matematica_tcc.pptx
+++ b/results/tcc/presentation/ensino_personalizado_de_matematica_tcc.pptx
@@ -7830,7 +7830,7 @@
                 </a:solidFill>
                 <a:latin typeface="Arial"/>
               </a:rPr>
-              <a:t>Dos 18 registros selecionados preliminarmente, um foi excluído após o resumo. Dos 17 relatórios procurados, um não foi recuperado e 16 foram avaliados em texto completo; um protocolo sem resultados concluídos foi excluído após essa avaliação e 15 registros empíricos permanecem provisoriamente no núcleo. O estudo 8 aguarda adjudicação de elegibilidade e unidade de análise; o relatório não recuperado não recebeu MMAT.</a:t>
+              <a:t>Dos 18 registros selecionados preliminarmente, um foi excluído após o resumo. Dos 17 relatórios procurados, um não foi recuperado e 16 foram avaliados em texto completo; um protocolo sem resultados concluídos foi excluído após essa avaliação e 15 registros empíricos permanecem provisoriamente no núcleo. Os 15 estudos têm apreciação preliminar, incluindo rotas operacionais explícitas; o relatório não recuperado não recebeu MMAT.</a:t>
             </a:r>
           </a:p>
         </p:txBody>
@@ -8587,7 +8587,7 @@
                 </a:solidFill>
                 <a:latin typeface="Arial"/>
               </a:rPr>
-              <a:t>15 registros provisórios. S1/S2: 14; Q1–Q5: 11. Estudos 5, 7 e 14 aguardam categoria; estudo 8 aguarda unidade. Um texto não recuperado, sem MMAT. Conferência humana pendente.</a:t>
+              <a:t>15 registros provisórios. S1/S2 e Q1–Q5: 15. Estudos 5/7: categoria 3 operacional; 14: sorteio contraditório; 8: categoria 4 adaptada. Um texto não recuperado, sem MMAT. Conferência humana pendente.</a:t>
             </a:r>
           </a:p>
         </p:txBody>
@@ -10310,7 +10310,7 @@
                 </a:solidFill>
                 <a:latin typeface="Arial"/>
               </a:rPr>
-              <a:t>Estes exemplos localizados não estimam a frequência da literatura. Quinze registros permanecem provisoriamente no núcleo; há 14 triagens S1/S2 e 11 apreciações por categoria, e o estudo 8 segue sem respostas até adjudicação da unidade. Um relatório não recuperado não recebeu MMAT; um registro foi excluído após resumo e um protocolo após texto completo.</a:t>
+              <a:t>Estes exemplos localizados não estimam a frequência da literatura. Quinze registros permanecem provisoriamente no núcleo; há 15 triagens S1/S2 e 15 apreciações por categoria, com rotas operacionais explicitamente limitadas. Um relatório não recuperado não recebeu MMAT; um registro foi excluído após resumo e um protocolo após texto completo.</a:t>
             </a:r>
           </a:p>
         </p:txBody>
@@ -12242,7 +12242,7 @@
               <a:t>• um único pesquisador
 • um texto integral pendente, sem MMAT
 • fontes e idiomas delimitados
-• MMAT: 14 triagens, 11 apreciações por categoria; estudo 8 sem avaliação
+• MMAT: 15 triagens e apreciações; rotas operacionais e conferência humana pendente
 • sem aplicação funcional ou eficácia pedagógica própria</a:t>
             </a:r>
           </a:p>

</xml_diff>

<commit_message>
:books: docs(tcc): align defense evidence and conceptual deliverables
</commit_message>
<xml_diff>
--- a/results/tcc/presentation/ensino_personalizado_de_matematica_tcc.pptx
+++ b/results/tcc/presentation/ensino_personalizado_de_matematica_tcc.pptx
@@ -5806,7 +5806,7 @@
                 <a:latin typeface="Arial"/>
               </a:rPr>
               <a:t>Instituto Federal Catarinense — Campus Videira
-Versão revisada: 15/10/2026 · corte da busca: 31/08/2026</a:t>
+Versão revisada: 28/10/2026 · corte da busca: 31/08/2026</a:t>
             </a:r>
           </a:p>
         </p:txBody>
@@ -11148,7 +11148,7 @@
                 </a:solidFill>
                 <a:latin typeface="Arial"/>
               </a:rPr>
-              <a:t>dados, modelos, métricas e limites</a:t>
+              <a:t>especificação conceitual; aplicação pendente</a:t>
             </a:r>
           </a:p>
         </p:txBody>
@@ -11433,7 +11433,7 @@
                 </a:solidFill>
                 <a:latin typeface="Arial"/>
               </a:rPr>
-              <a:t>O resultado é uma especificação conceitual: documentada, verificável e coerente com o escopo executado.</a:t>
+              <a:t>26 grupos rastreáveis: R02 separa conceitos; R20 exige separar treino, validação e teste.</a:t>
             </a:r>
           </a:p>
         </p:txBody>
@@ -12548,7 +12548,7 @@
                 <a:latin typeface="Arial"/>
               </a:rPr>
               <a:t>Thales Ferreira Batista · Ciência da Computação · IFC Videira
-Versão revisada: 15/10/2026 · corte da busca: 31/08/2026</a:t>
+Versão revisada: 28/10/2026 · corte da busca: 31/08/2026</a:t>
             </a:r>
           </a:p>
         </p:txBody>

</xml_diff>

<commit_message>
:books: docs(tcc): align defense evidence and conceptual deliverables (#121)
</commit_message>
<xml_diff>
--- a/results/tcc/presentation/ensino_personalizado_de_matematica_tcc.pptx
+++ b/results/tcc/presentation/ensino_personalizado_de_matematica_tcc.pptx
@@ -5806,7 +5806,7 @@
                 <a:latin typeface="Arial"/>
               </a:rPr>
               <a:t>Instituto Federal Catarinense — Campus Videira
-Versão revisada: 15/10/2026 · corte da busca: 31/08/2026</a:t>
+Versão revisada: 28/10/2026 · corte da busca: 31/08/2026</a:t>
             </a:r>
           </a:p>
         </p:txBody>
@@ -11148,7 +11148,7 @@
                 </a:solidFill>
                 <a:latin typeface="Arial"/>
               </a:rPr>
-              <a:t>dados, modelos, métricas e limites</a:t>
+              <a:t>especificação conceitual; aplicação pendente</a:t>
             </a:r>
           </a:p>
         </p:txBody>
@@ -11433,7 +11433,7 @@
                 </a:solidFill>
                 <a:latin typeface="Arial"/>
               </a:rPr>
-              <a:t>O resultado é uma especificação conceitual: documentada, verificável e coerente com o escopo executado.</a:t>
+              <a:t>26 grupos rastreáveis: R02 separa conceitos; R20 exige separar treino, validação e teste.</a:t>
             </a:r>
           </a:p>
         </p:txBody>
@@ -12548,7 +12548,7 @@
                 <a:latin typeface="Arial"/>
               </a:rPr>
               <a:t>Thales Ferreira Batista · Ciência da Computação · IFC Videira
-Versão revisada: 15/10/2026 · corte da busca: 31/08/2026</a:t>
+Versão revisada: 28/10/2026 · corte da busca: 31/08/2026</a:t>
             </a:r>
           </a:p>
         </p:txBody>

</xml_diff>

<commit_message>
:bug: fix(tcc): correct figures and manuscript layout
</commit_message>
<xml_diff>
--- a/results/tcc/presentation/ensino_personalizado_de_matematica_tcc.pptx
+++ b/results/tcc/presentation/ensino_personalizado_de_matematica_tcc.pptx
@@ -6739,8 +6739,8 @@
         </p:blipFill>
         <p:spPr>
           <a:xfrm>
-            <a:off x="7187460" y="1143000"/>
-            <a:ext cx="3455879" cy="2468880"/>
+            <a:off x="7090027" y="1143000"/>
+            <a:ext cx="3650745" cy="2468880"/>
           </a:xfrm>
           <a:prstGeom prst="rect">
             <a:avLst/>
@@ -7070,7 +7070,7 @@
                 </a:solidFill>
                 <a:latin typeface="Arial"/>
               </a:rPr>
-              <a:t>As quatro fontes foram complementares; os totais brutos incluem registros posteriormente reconhecidos como duplicatas.</a:t>
+              <a:t>As quatro fontes foram complementares; as contagens representam a fonte da versão mantida após a deduplicação DOI/URL (11.877 registros).</a:t>
             </a:r>
           </a:p>
         </p:txBody>
@@ -17577,8 +17577,8 @@
         </p:blipFill>
         <p:spPr>
           <a:xfrm>
-            <a:off x="1470660" y="960120"/>
-            <a:ext cx="9265920" cy="5212080"/>
+            <a:off x="2132511" y="960120"/>
+            <a:ext cx="7942217" cy="5212080"/>
           </a:xfrm>
           <a:prstGeom prst="rect">
             <a:avLst/>
@@ -17705,8 +17705,8 @@
         </p:blipFill>
         <p:spPr>
           <a:xfrm>
-            <a:off x="640080" y="1650666"/>
-            <a:ext cx="5623560" cy="3739548"/>
+            <a:off x="640080" y="1663204"/>
+            <a:ext cx="5623560" cy="3714472"/>
           </a:xfrm>
           <a:prstGeom prst="rect">
             <a:avLst/>

</xml_diff>

<commit_message>
:bug: fix(tcc): correct figures and manuscript layout (#124)
* :bug: fix(tcc): correct figures and manuscript layout

* :bug: fix(tcc): keep longtable links on caption pages
</commit_message>
<xml_diff>
--- a/results/tcc/presentation/ensino_personalizado_de_matematica_tcc.pptx
+++ b/results/tcc/presentation/ensino_personalizado_de_matematica_tcc.pptx
@@ -6739,8 +6739,8 @@
         </p:blipFill>
         <p:spPr>
           <a:xfrm>
-            <a:off x="7187460" y="1143000"/>
-            <a:ext cx="3455879" cy="2468880"/>
+            <a:off x="7090027" y="1143000"/>
+            <a:ext cx="3650745" cy="2468880"/>
           </a:xfrm>
           <a:prstGeom prst="rect">
             <a:avLst/>
@@ -7070,7 +7070,7 @@
                 </a:solidFill>
                 <a:latin typeface="Arial"/>
               </a:rPr>
-              <a:t>As quatro fontes foram complementares; os totais brutos incluem registros posteriormente reconhecidos como duplicatas.</a:t>
+              <a:t>As quatro fontes foram complementares; as contagens representam a fonte da versão mantida após a deduplicação DOI/URL (11.877 registros).</a:t>
             </a:r>
           </a:p>
         </p:txBody>
@@ -17577,8 +17577,8 @@
         </p:blipFill>
         <p:spPr>
           <a:xfrm>
-            <a:off x="1470660" y="960120"/>
-            <a:ext cx="9265920" cy="5212080"/>
+            <a:off x="2132511" y="960120"/>
+            <a:ext cx="7942217" cy="5212080"/>
           </a:xfrm>
           <a:prstGeom prst="rect">
             <a:avLst/>
@@ -17705,8 +17705,8 @@
         </p:blipFill>
         <p:spPr>
           <a:xfrm>
-            <a:off x="640080" y="1650666"/>
-            <a:ext cx="5623560" cy="3739548"/>
+            <a:off x="640080" y="1663204"/>
+            <a:ext cx="5623560" cy="3714472"/>
           </a:xfrm>
           <a:prstGeom prst="rect">
             <a:avLst/>

</xml_diff>

<commit_message>
:bar_chart: fix(presentation): sync historical PPTX flow
</commit_message>
<xml_diff>
--- a/results/tcc/presentation/ensino_personalizado_de_matematica_tcc.pptx
+++ b/results/tcc/presentation/ensino_personalizado_de_matematica_tcc.pptx
@@ -5779,8 +5779,8 @@
         </p:nvSpPr>
         <p:spPr>
           <a:xfrm>
-            <a:off x="2057400" y="5806440"/>
-            <a:ext cx="8092440" cy="457200"/>
+            <a:off x="914400" y="5687568"/>
+            <a:ext cx="10332720" cy="640080"/>
           </a:xfrm>
           <a:prstGeom prst="rect">
             <a:avLst/>
@@ -5799,14 +5799,14 @@
               </a:spcAft>
             </a:pPr>
             <a:r>
-              <a:rPr sz="1150" b="0">
+              <a:rPr sz="1050" b="0">
                 <a:solidFill>
                   <a:srgbClr val="373737"/>
                 </a:solidFill>
                 <a:latin typeface="Arial"/>
               </a:rPr>
               <a:t>Instituto Federal Catarinense — Campus Videira
-Versão revisada: 28/10/2026 · corte da busca: 31/08/2026</a:t>
+Rascunho histórico, não usar na defesa · fluxo reconciliado em 31/10/2026 · reaplicação da emenda pendente</a:t>
             </a:r>
           </a:p>
         </p:txBody>
@@ -6629,7 +6629,7 @@
                 </a:solidFill>
                 <a:latin typeface="Arial"/>
               </a:rPr>
-              <a:t>As categorias podem se sobrepor e são calculadas sobre os 11.877 registros após a remoção determinística. Não representam qualidade ou eficácia.</a:t>
+              <a:t>As categorias podem se sobrepor e são calculadas sobre os 11.875 registros da seleção histórica reconciliada. Não representam qualidade ou eficácia.</a:t>
             </a:r>
           </a:p>
         </p:txBody>
@@ -7070,7 +7070,7 @@
                 </a:solidFill>
                 <a:latin typeface="Arial"/>
               </a:rPr>
-              <a:t>As quatro fontes foram complementares; as contagens representam a fonte da versão mantida após a deduplicação DOI/URL (11.877 registros).</a:t>
+              <a:t>As quatro fontes foram complementares; as contagens descrevem os 11.875 registros da população histórica após a reconciliação de identidade.</a:t>
             </a:r>
           </a:p>
         </p:txBody>
@@ -7338,7 +7338,7 @@
                 </a:solidFill>
                 <a:latin typeface="Arial"/>
               </a:rPr>
-              <a:t>registros retidos operacionalmente</a:t>
+              <a:t>registros na lista histórica de leitura</a:t>
             </a:r>
           </a:p>
         </p:txBody>
@@ -7502,7 +7502,7 @@
                 </a:solidFill>
                 <a:latin typeface="Arial"/>
               </a:rPr>
-              <a:t>registros empíricos mantidos provisoriamente</a:t>
+              <a:t>estudos históricos antes da emenda</a:t>
             </a:r>
           </a:p>
         </p:txBody>
@@ -7791,7 +7791,7 @@
                 </a:solidFill>
                 <a:latin typeface="Arial"/>
               </a:rPr>
-              <a:t>Desfecho da seleção</a:t>
+              <a:t>Desfecho histórico</a:t>
             </a:r>
           </a:p>
         </p:txBody>
@@ -7830,7 +7830,7 @@
                 </a:solidFill>
                 <a:latin typeface="Arial"/>
               </a:rPr>
-              <a:t>Dos 18 registros selecionados preliminarmente, um foi excluído após o resumo. Dos 17 relatórios procurados, um não foi recuperado e 16 foram avaliados em texto completo; um protocolo sem resultados concluídos foi excluído após essa avaliação e 15 registros empíricos permanecem provisoriamente no núcleo. Os 15 estudos têm apreciação preliminar, incluindo rotas operacionais explícitas; o relatório não recuperado não recebeu MMAT.</a:t>
+              <a:t>Dos 18 registros na lista antiga, um foi excluído após resumo. Dos 17 relatórios procurados, um não foi recuperado e 16 foram avaliados em texto completo; um protocolo foi excluído. Restaram 15 estudos na seleção histórica, ainda não reaplicada ao protocolo emendado. O MMAT precisa acompanhar a seleção revisada.</a:t>
             </a:r>
           </a:p>
         </p:txBody>
@@ -8548,7 +8548,7 @@
                 </a:solidFill>
                 <a:latin typeface="Arial"/>
               </a:rPr>
-              <a:t>Estado atual</a:t>
+              <a:t>Seleção histórica</a:t>
             </a:r>
           </a:p>
         </p:txBody>
@@ -8581,13 +8581,13 @@
               </a:spcAft>
             </a:pPr>
             <a:r>
-              <a:rPr sz="1300" b="0">
+              <a:rPr sz="1250" b="0">
                 <a:solidFill>
                   <a:srgbClr val="232323"/>
                 </a:solidFill>
                 <a:latin typeface="Arial"/>
               </a:rPr>
-              <a:t>15 registros provisórios. S1/S2 e Q1–Q5: 15. Estudos 5/7: categoria 3 operacional; 14: sorteio contraditório; 8: categoria 4 adaptada. Um texto não recuperado, sem MMAT. Conferência humana pendente.</a:t>
+              <a:t>15 estudos pré-emenda. S1/S2 e Q1–Q5: 15 conjuntos. Estudos 5/7: cat. 3 operacional; 14: sorteio contraditório; 8: cat. 4 adaptada. O relatório não recuperado não recebeu MMAT. Reaplicação e conferência humana pendentes.</a:t>
             </a:r>
           </a:p>
         </p:txBody>
@@ -10310,7 +10310,7 @@
                 </a:solidFill>
                 <a:latin typeface="Arial"/>
               </a:rPr>
-              <a:t>Estes exemplos localizados não estimam a frequência da literatura. Quinze registros permanecem provisoriamente no núcleo; há 15 triagens S1/S2 e 15 apreciações por categoria, com rotas operacionais explicitamente limitadas. Um relatório não recuperado não recebeu MMAT; um registro foi excluído após resumo e um protocolo após texto completo.</a:t>
+              <a:t>Exemplos da seleção histórica (n=15); não estimam a frequência da literatura. MMAT e síntese deverão ser reaplicados após a revisão do corpus. Um relatório não recuperado não recebeu MMAT; houve exclusões após resumo e texto completo.</a:t>
             </a:r>
           </a:p>
         </p:txBody>
@@ -12548,7 +12548,7 @@
                 <a:latin typeface="Arial"/>
               </a:rPr>
               <a:t>Thales Ferreira Batista · Ciência da Computação · IFC Videira
-Versão revisada: 28/10/2026 · corte da busca: 31/08/2026</a:t>
+Rascunho histórico, não usar na defesa · seleção pré-emenda</a:t>
             </a:r>
           </a:p>
         </p:txBody>
@@ -16264,7 +16264,7 @@
                 </a:solidFill>
                 <a:latin typeface="Arial"/>
               </a:rPr>
-              <a:t>Do registro bruto ao conjunto retido provisoriamente</a:t>
+              <a:t>Fluxo histórico antes da reaplicação</a:t>
             </a:r>
           </a:p>
         </p:txBody>
@@ -16278,7 +16278,7 @@
         <p:spPr>
           <a:xfrm>
             <a:off x="685800" y="960120"/>
-            <a:ext cx="4572000" cy="274320"/>
+            <a:ext cx="6858000" cy="274320"/>
           </a:xfrm>
           <a:prstGeom prst="rect">
             <a:avLst/>
@@ -16303,7 +16303,7 @@
                 </a:solidFill>
                 <a:latin typeface="Arial"/>
               </a:rPr>
-              <a:t>Contagens do recorte versionado</a:t>
+              <a:t>Fluxo histórico reconciliado em 31/10/2026</a:t>
             </a:r>
           </a:p>
         </p:txBody>
@@ -16592,7 +16592,7 @@
                 </a:solidFill>
                 <a:latin typeface="Arial"/>
               </a:rPr>
-              <a:t>27</a:t>
+              <a:t>29</a:t>
             </a:r>
           </a:p>
         </p:txBody>
@@ -16631,8 +16631,8 @@
                 </a:solidFill>
                 <a:latin typeface="Arial"/>
               </a:rPr>
-              <a:t>remoções por identidade
-25 DOI + 2 URL</a:t>
+              <a:t>duplicatas removidas
+27 DOI/URL + 2 confirmadas</a:t>
             </a:r>
           </a:p>
         </p:txBody>
@@ -16757,7 +16757,7 @@
                 </a:solidFill>
                 <a:latin typeface="Arial"/>
               </a:rPr>
-              <a:t>11.877</a:t>
+              <a:t>11.875</a:t>
             </a:r>
           </a:p>
         </p:txBody>
@@ -16796,7 +16796,7 @@
                 </a:solidFill>
                 <a:latin typeface="Arial"/>
               </a:rPr>
-              <a:t>registros na triagem</a:t>
+              <a:t>registros triados</a:t>
             </a:r>
           </a:p>
         </p:txBody>
@@ -16921,7 +16921,7 @@
                 </a:solidFill>
                 <a:latin typeface="Arial"/>
               </a:rPr>
-              <a:t>9.391</a:t>
+              <a:t>9.393</a:t>
             </a:r>
           </a:p>
         </p:txBody>
@@ -17085,7 +17085,7 @@
                 </a:solidFill>
                 <a:latin typeface="Arial"/>
               </a:rPr>
-              <a:t>2.486</a:t>
+              <a:t>2.482</a:t>
             </a:r>
           </a:p>
         </p:txBody>
@@ -17124,7 +17124,7 @@
                 </a:solidFill>
                 <a:latin typeface="Arial"/>
               </a:rPr>
-              <a:t>submetidos à priorização</a:t>
+              <a:t>priorizados no fluxo antigo</a:t>
             </a:r>
           </a:p>
         </p:txBody>
@@ -17249,7 +17249,7 @@
                 </a:solidFill>
                 <a:latin typeface="Arial"/>
               </a:rPr>
-              <a:t>2.468</a:t>
+              <a:t>2.464</a:t>
             </a:r>
           </a:p>
         </p:txBody>
@@ -17288,7 +17288,7 @@
                 </a:solidFill>
                 <a:latin typeface="Arial"/>
               </a:rPr>
-              <a:t>excluídos nessa etapa</a:t>
+              <a:t>não avançaram pelo corte antigo</a:t>
             </a:r>
           </a:p>
         </p:txBody>
@@ -17452,7 +17452,7 @@
                 </a:solidFill>
                 <a:latin typeface="Arial"/>
               </a:rPr>
-              <a:t>retidos operacionalmente</a:t>
+              <a:t>na lista histórica de leitura</a:t>
             </a:r>
           </a:p>
         </p:txBody>
@@ -17491,7 +17491,7 @@
                 </a:solidFill>
                 <a:latin typeface="Arial"/>
               </a:rPr>
-              <a:t>A priorização dos 2.486 registros usa metadados/resumos e não equivale à elegibilidade em texto completo; títulos repetidos seguem para auditoria semântica.</a:t>
+              <a:t>A seleção de 15 estudos e o corte 4,0 pertencem à execução anterior. A emenda remove o score como exclusão; sua reaplicação uniforme ainda está pendente.</a:t>
             </a:r>
           </a:p>
         </p:txBody>
@@ -17705,8 +17705,8 @@
         </p:blipFill>
         <p:spPr>
           <a:xfrm>
-            <a:off x="640080" y="1663204"/>
-            <a:ext cx="5623560" cy="3714472"/>
+            <a:off x="640080" y="1659043"/>
+            <a:ext cx="5623560" cy="3722793"/>
           </a:xfrm>
           <a:prstGeom prst="rect">
             <a:avLst/>
@@ -17872,7 +17872,7 @@
                 </a:solidFill>
                 <a:latin typeface="Arial"/>
               </a:rPr>
-              <a:t>27 linhas excedentes por identidade bibliográfica determinística: 25 DOI normalizado e 2 URL exata.</a:t>
+              <a:t>29 relatórios duplicados: 27 por DOI/URL e 2 confirmados manualmente como o mesmo relatório.</a:t>
             </a:r>
           </a:p>
         </p:txBody>

</xml_diff>

<commit_message>
:bar_chart: fix(research): reconcile historical population (#130)
* :bar_chart: fix(research): reconcile historical population

* :bar_chart: docs(presentation): label reconciled flow historical

* :memo: test(research): align historical presentation checks

* :bar_chart: fix(presentation): sync historical PPTX flow
</commit_message>
<xml_diff>
--- a/results/tcc/presentation/ensino_personalizado_de_matematica_tcc.pptx
+++ b/results/tcc/presentation/ensino_personalizado_de_matematica_tcc.pptx
@@ -5779,8 +5779,8 @@
         </p:nvSpPr>
         <p:spPr>
           <a:xfrm>
-            <a:off x="2057400" y="5806440"/>
-            <a:ext cx="8092440" cy="457200"/>
+            <a:off x="914400" y="5687568"/>
+            <a:ext cx="10332720" cy="640080"/>
           </a:xfrm>
           <a:prstGeom prst="rect">
             <a:avLst/>
@@ -5799,14 +5799,14 @@
               </a:spcAft>
             </a:pPr>
             <a:r>
-              <a:rPr sz="1150" b="0">
+              <a:rPr sz="1050" b="0">
                 <a:solidFill>
                   <a:srgbClr val="373737"/>
                 </a:solidFill>
                 <a:latin typeface="Arial"/>
               </a:rPr>
               <a:t>Instituto Federal Catarinense — Campus Videira
-Versão revisada: 28/10/2026 · corte da busca: 31/08/2026</a:t>
+Rascunho histórico, não usar na defesa · fluxo reconciliado em 31/10/2026 · reaplicação da emenda pendente</a:t>
             </a:r>
           </a:p>
         </p:txBody>
@@ -6629,7 +6629,7 @@
                 </a:solidFill>
                 <a:latin typeface="Arial"/>
               </a:rPr>
-              <a:t>As categorias podem se sobrepor e são calculadas sobre os 11.877 registros após a remoção determinística. Não representam qualidade ou eficácia.</a:t>
+              <a:t>As categorias podem se sobrepor e são calculadas sobre os 11.875 registros da seleção histórica reconciliada. Não representam qualidade ou eficácia.</a:t>
             </a:r>
           </a:p>
         </p:txBody>
@@ -7070,7 +7070,7 @@
                 </a:solidFill>
                 <a:latin typeface="Arial"/>
               </a:rPr>
-              <a:t>As quatro fontes foram complementares; as contagens representam a fonte da versão mantida após a deduplicação DOI/URL (11.877 registros).</a:t>
+              <a:t>As quatro fontes foram complementares; as contagens descrevem os 11.875 registros da população histórica após a reconciliação de identidade.</a:t>
             </a:r>
           </a:p>
         </p:txBody>
@@ -7338,7 +7338,7 @@
                 </a:solidFill>
                 <a:latin typeface="Arial"/>
               </a:rPr>
-              <a:t>registros retidos operacionalmente</a:t>
+              <a:t>registros na lista histórica de leitura</a:t>
             </a:r>
           </a:p>
         </p:txBody>
@@ -7502,7 +7502,7 @@
                 </a:solidFill>
                 <a:latin typeface="Arial"/>
               </a:rPr>
-              <a:t>registros empíricos mantidos provisoriamente</a:t>
+              <a:t>estudos históricos antes da emenda</a:t>
             </a:r>
           </a:p>
         </p:txBody>
@@ -7791,7 +7791,7 @@
                 </a:solidFill>
                 <a:latin typeface="Arial"/>
               </a:rPr>
-              <a:t>Desfecho da seleção</a:t>
+              <a:t>Desfecho histórico</a:t>
             </a:r>
           </a:p>
         </p:txBody>
@@ -7830,7 +7830,7 @@
                 </a:solidFill>
                 <a:latin typeface="Arial"/>
               </a:rPr>
-              <a:t>Dos 18 registros selecionados preliminarmente, um foi excluído após o resumo. Dos 17 relatórios procurados, um não foi recuperado e 16 foram avaliados em texto completo; um protocolo sem resultados concluídos foi excluído após essa avaliação e 15 registros empíricos permanecem provisoriamente no núcleo. Os 15 estudos têm apreciação preliminar, incluindo rotas operacionais explícitas; o relatório não recuperado não recebeu MMAT.</a:t>
+              <a:t>Dos 18 registros na lista antiga, um foi excluído após resumo. Dos 17 relatórios procurados, um não foi recuperado e 16 foram avaliados em texto completo; um protocolo foi excluído. Restaram 15 estudos na seleção histórica, ainda não reaplicada ao protocolo emendado. O MMAT precisa acompanhar a seleção revisada.</a:t>
             </a:r>
           </a:p>
         </p:txBody>
@@ -8548,7 +8548,7 @@
                 </a:solidFill>
                 <a:latin typeface="Arial"/>
               </a:rPr>
-              <a:t>Estado atual</a:t>
+              <a:t>Seleção histórica</a:t>
             </a:r>
           </a:p>
         </p:txBody>
@@ -8581,13 +8581,13 @@
               </a:spcAft>
             </a:pPr>
             <a:r>
-              <a:rPr sz="1300" b="0">
+              <a:rPr sz="1250" b="0">
                 <a:solidFill>
                   <a:srgbClr val="232323"/>
                 </a:solidFill>
                 <a:latin typeface="Arial"/>
               </a:rPr>
-              <a:t>15 registros provisórios. S1/S2 e Q1–Q5: 15. Estudos 5/7: categoria 3 operacional; 14: sorteio contraditório; 8: categoria 4 adaptada. Um texto não recuperado, sem MMAT. Conferência humana pendente.</a:t>
+              <a:t>15 estudos pré-emenda. S1/S2 e Q1–Q5: 15 conjuntos. Estudos 5/7: cat. 3 operacional; 14: sorteio contraditório; 8: cat. 4 adaptada. O relatório não recuperado não recebeu MMAT. Reaplicação e conferência humana pendentes.</a:t>
             </a:r>
           </a:p>
         </p:txBody>
@@ -10310,7 +10310,7 @@
                 </a:solidFill>
                 <a:latin typeface="Arial"/>
               </a:rPr>
-              <a:t>Estes exemplos localizados não estimam a frequência da literatura. Quinze registros permanecem provisoriamente no núcleo; há 15 triagens S1/S2 e 15 apreciações por categoria, com rotas operacionais explicitamente limitadas. Um relatório não recuperado não recebeu MMAT; um registro foi excluído após resumo e um protocolo após texto completo.</a:t>
+              <a:t>Exemplos da seleção histórica (n=15); não estimam a frequência da literatura. MMAT e síntese deverão ser reaplicados após a revisão do corpus. Um relatório não recuperado não recebeu MMAT; houve exclusões após resumo e texto completo.</a:t>
             </a:r>
           </a:p>
         </p:txBody>
@@ -12548,7 +12548,7 @@
                 <a:latin typeface="Arial"/>
               </a:rPr>
               <a:t>Thales Ferreira Batista · Ciência da Computação · IFC Videira
-Versão revisada: 28/10/2026 · corte da busca: 31/08/2026</a:t>
+Rascunho histórico, não usar na defesa · seleção pré-emenda</a:t>
             </a:r>
           </a:p>
         </p:txBody>
@@ -16264,7 +16264,7 @@
                 </a:solidFill>
                 <a:latin typeface="Arial"/>
               </a:rPr>
-              <a:t>Do registro bruto ao conjunto retido provisoriamente</a:t>
+              <a:t>Fluxo histórico antes da reaplicação</a:t>
             </a:r>
           </a:p>
         </p:txBody>
@@ -16278,7 +16278,7 @@
         <p:spPr>
           <a:xfrm>
             <a:off x="685800" y="960120"/>
-            <a:ext cx="4572000" cy="274320"/>
+            <a:ext cx="6858000" cy="274320"/>
           </a:xfrm>
           <a:prstGeom prst="rect">
             <a:avLst/>
@@ -16303,7 +16303,7 @@
                 </a:solidFill>
                 <a:latin typeface="Arial"/>
               </a:rPr>
-              <a:t>Contagens do recorte versionado</a:t>
+              <a:t>Fluxo histórico reconciliado em 31/10/2026</a:t>
             </a:r>
           </a:p>
         </p:txBody>
@@ -16592,7 +16592,7 @@
                 </a:solidFill>
                 <a:latin typeface="Arial"/>
               </a:rPr>
-              <a:t>27</a:t>
+              <a:t>29</a:t>
             </a:r>
           </a:p>
         </p:txBody>
@@ -16631,8 +16631,8 @@
                 </a:solidFill>
                 <a:latin typeface="Arial"/>
               </a:rPr>
-              <a:t>remoções por identidade
-25 DOI + 2 URL</a:t>
+              <a:t>duplicatas removidas
+27 DOI/URL + 2 confirmadas</a:t>
             </a:r>
           </a:p>
         </p:txBody>
@@ -16757,7 +16757,7 @@
                 </a:solidFill>
                 <a:latin typeface="Arial"/>
               </a:rPr>
-              <a:t>11.877</a:t>
+              <a:t>11.875</a:t>
             </a:r>
           </a:p>
         </p:txBody>
@@ -16796,7 +16796,7 @@
                 </a:solidFill>
                 <a:latin typeface="Arial"/>
               </a:rPr>
-              <a:t>registros na triagem</a:t>
+              <a:t>registros triados</a:t>
             </a:r>
           </a:p>
         </p:txBody>
@@ -16921,7 +16921,7 @@
                 </a:solidFill>
                 <a:latin typeface="Arial"/>
               </a:rPr>
-              <a:t>9.391</a:t>
+              <a:t>9.393</a:t>
             </a:r>
           </a:p>
         </p:txBody>
@@ -17085,7 +17085,7 @@
                 </a:solidFill>
                 <a:latin typeface="Arial"/>
               </a:rPr>
-              <a:t>2.486</a:t>
+              <a:t>2.482</a:t>
             </a:r>
           </a:p>
         </p:txBody>
@@ -17124,7 +17124,7 @@
                 </a:solidFill>
                 <a:latin typeface="Arial"/>
               </a:rPr>
-              <a:t>submetidos à priorização</a:t>
+              <a:t>priorizados no fluxo antigo</a:t>
             </a:r>
           </a:p>
         </p:txBody>
@@ -17249,7 +17249,7 @@
                 </a:solidFill>
                 <a:latin typeface="Arial"/>
               </a:rPr>
-              <a:t>2.468</a:t>
+              <a:t>2.464</a:t>
             </a:r>
           </a:p>
         </p:txBody>
@@ -17288,7 +17288,7 @@
                 </a:solidFill>
                 <a:latin typeface="Arial"/>
               </a:rPr>
-              <a:t>excluídos nessa etapa</a:t>
+              <a:t>não avançaram pelo corte antigo</a:t>
             </a:r>
           </a:p>
         </p:txBody>
@@ -17452,7 +17452,7 @@
                 </a:solidFill>
                 <a:latin typeface="Arial"/>
               </a:rPr>
-              <a:t>retidos operacionalmente</a:t>
+              <a:t>na lista histórica de leitura</a:t>
             </a:r>
           </a:p>
         </p:txBody>
@@ -17491,7 +17491,7 @@
                 </a:solidFill>
                 <a:latin typeface="Arial"/>
               </a:rPr>
-              <a:t>A priorização dos 2.486 registros usa metadados/resumos e não equivale à elegibilidade em texto completo; títulos repetidos seguem para auditoria semântica.</a:t>
+              <a:t>A seleção de 15 estudos e o corte 4,0 pertencem à execução anterior. A emenda remove o score como exclusão; sua reaplicação uniforme ainda está pendente.</a:t>
             </a:r>
           </a:p>
         </p:txBody>
@@ -17705,8 +17705,8 @@
         </p:blipFill>
         <p:spPr>
           <a:xfrm>
-            <a:off x="640080" y="1663204"/>
-            <a:ext cx="5623560" cy="3714472"/>
+            <a:off x="640080" y="1659043"/>
+            <a:ext cx="5623560" cy="3722793"/>
           </a:xfrm>
           <a:prstGeom prst="rect">
             <a:avLst/>
@@ -17872,7 +17872,7 @@
                 </a:solidFill>
                 <a:latin typeface="Arial"/>
               </a:rPr>
-              <a:t>27 linhas excedentes por identidade bibliográfica determinística: 25 DOI normalizado e 2 URL exata.</a:t>
+              <a:t>29 relatórios duplicados: 27 por DOI/URL e 2 confirmados manualmente como o mesmo relatório.</a:t>
             </a:r>
           </a:p>
         </p:txBody>

</xml_diff>